<commit_message>
Update PPTX deck with R32 results — lead narrowed to 20pts
Co-Authored-By: Claude Opus 4.6 <noreply@anthropic.com>
</commit_message>
<xml_diff>
--- a/Elons_Plugs_Deck.pptx
+++ b/Elons_Plugs_Deck.pptx
@@ -197,10 +197,10 @@
                     <c:v>Fizzz3</c:v>
                   </c:pt>
                   <c:pt idx="3">
-                    <c:v>twnutt</c:v>
+                    <c:v>Paul233365</c:v>
                   </c:pt>
                   <c:pt idx="4">
-                    <c:v>Paul233365</c:v>
+                    <c:v>twnutt</c:v>
                   </c:pt>
                   <c:pt idx="5">
                     <c:v>inursha</c:v>
@@ -231,10 +231,10 @@
                   <c:v>260</c:v>
                 </c:pt>
                 <c:pt idx="3">
-                  <c:v>230</c:v>
+                  <c:v>240</c:v>
                 </c:pt>
                 <c:pt idx="4">
-                  <c:v>240</c:v>
+                  <c:v>230</c:v>
                 </c:pt>
                 <c:pt idx="5">
                   <c:v>200</c:v>
@@ -311,10 +311,10 @@
                     <c:v>Fizzz3</c:v>
                   </c:pt>
                   <c:pt idx="3">
-                    <c:v>twnutt</c:v>
+                    <c:v>Paul233365</c:v>
                   </c:pt>
                   <c:pt idx="4">
-                    <c:v>Paul233365</c:v>
+                    <c:v>twnutt</c:v>
                   </c:pt>
                   <c:pt idx="5">
                     <c:v>inursha</c:v>
@@ -339,16 +339,16 @@
                   <c:v>160</c:v>
                 </c:pt>
                 <c:pt idx="1">
-                  <c:v>160</c:v>
+                  <c:v>180</c:v>
                 </c:pt>
                 <c:pt idx="2">
-                  <c:v>140</c:v>
+                  <c:v>160</c:v>
                 </c:pt>
                 <c:pt idx="3">
                   <c:v>160</c:v>
                 </c:pt>
                 <c:pt idx="4">
-                  <c:v>140</c:v>
+                  <c:v>160</c:v>
                 </c:pt>
                 <c:pt idx="5">
                   <c:v>140</c:v>
@@ -2829,7 +2829,7 @@
                   <a:srgbClr val="AAAAAA"/>
                 </a:solidFill>
               </a:rPr>
-              <a:t>ESPN Tournament Challenge / Bracket Analytics / Mar 22, 2026</a:t>
+              <a:t>ESPN Tournament Challenge / Bracket Analytics / Mar 22, 2026 7:30 PM ET</a:t>
             </a:r>
             <a:endParaRPr lang="en-US" sz="1100" dirty="0"/>
           </a:p>
@@ -3175,7 +3175,7 @@
                   <a:srgbClr val="2C2C2C"/>
                 </a:solidFill>
               </a:rPr>
-              <a:t>twnutt</a:t>
+              <a:t>Paul233365</a:t>
             </a:r>
             <a:endParaRPr lang="en-US" sz="550" dirty="0"/>
           </a:p>
@@ -3211,7 +3211,7 @@
                   <a:srgbClr val="2C2C2C"/>
                 </a:solidFill>
               </a:rPr>
-              <a:t>Paul233365</a:t>
+              <a:t>twnutt</a:t>
             </a:r>
             <a:endParaRPr lang="en-US" sz="550" dirty="0"/>
           </a:p>
@@ -4819,7 +4819,7 @@
                   <a:srgbClr val="2C2C2C"/>
                 </a:solidFill>
               </a:rPr>
-              <a:t>twnutt</a:t>
+              <a:t>Paul233365</a:t>
             </a:r>
             <a:endParaRPr lang="en-US" sz="600" dirty="0"/>
           </a:p>
@@ -5307,7 +5307,7 @@
                   <a:srgbClr val="2C2C2C"/>
                 </a:solidFill>
               </a:rPr>
-              <a:t>Paul233365</a:t>
+              <a:t>twnutt</a:t>
             </a:r>
             <a:endParaRPr lang="en-US" sz="600" dirty="0"/>
           </a:p>
@@ -8261,7 +8261,7 @@
                             <a:srgbClr val="2C2C2C"/>
                           </a:solidFill>
                         </a:rPr>
-                        <a:t>6</a:t>
+                        <a:t>7</a:t>
                       </a:r>
                       <a:endParaRPr lang="en-US" sz="900" dirty="0"/>
                     </a:p>
@@ -8611,7 +8611,7 @@
                             <a:srgbClr val="2C2C2C"/>
                           </a:solidFill>
                         </a:rPr>
-                        <a:t>33</a:t>
+                        <a:t>34</a:t>
                       </a:r>
                       <a:endParaRPr lang="en-US" sz="900" dirty="0"/>
                     </a:p>
@@ -8785,7 +8785,7 @@
                             <a:srgbClr val="2C2C2C"/>
                           </a:solidFill>
                         </a:rPr>
-                        <a:t>16</a:t>
+                        <a:t>18</a:t>
                       </a:r>
                       <a:endParaRPr lang="en-US" sz="900" dirty="0"/>
                     </a:p>
@@ -9019,7 +9019,7 @@
                             <a:srgbClr val="2C2C2C"/>
                           </a:solidFill>
                         </a:rPr>
-                        <a:t>33</a:t>
+                        <a:t>34</a:t>
                       </a:r>
                       <a:endParaRPr lang="en-US" sz="900" dirty="0"/>
                     </a:p>
@@ -9193,7 +9193,7 @@
                             <a:srgbClr val="2C2C2C"/>
                           </a:solidFill>
                         </a:rPr>
-                        <a:t>14</a:t>
+                        <a:t>16</a:t>
                       </a:r>
                       <a:endParaRPr lang="en-US" sz="900" dirty="0"/>
                     </a:p>
@@ -9310,6 +9310,414 @@
                           </a:solidFill>
                         </a:rPr>
                         <a:t>10</a:t>
+                      </a:r>
+                      <a:endParaRPr lang="en-US" sz="900" dirty="0"/>
+                    </a:p>
+                  </a:txBody>
+                  <a:tcPr marL="91440" marR="91440" marT="45720" marB="45720">
+                    <a:lnL w="6350" cap="flat" cmpd="sng" algn="ctr">
+                      <a:solidFill>
+                        <a:srgbClr val="CCCCCC"/>
+                      </a:solidFill>
+                      <a:prstDash val="solid"/>
+                      <a:round/>
+                      <a:headEnd type="none" w="med" len="med"/>
+                      <a:tailEnd type="none" w="med" len="med"/>
+                    </a:lnL>
+                    <a:lnR w="6350" cap="flat" cmpd="sng" algn="ctr">
+                      <a:solidFill>
+                        <a:srgbClr val="CCCCCC"/>
+                      </a:solidFill>
+                      <a:prstDash val="solid"/>
+                      <a:round/>
+                      <a:headEnd type="none" w="med" len="med"/>
+                      <a:tailEnd type="none" w="med" len="med"/>
+                    </a:lnR>
+                    <a:lnT w="6350" cap="flat" cmpd="sng" algn="ctr">
+                      <a:solidFill>
+                        <a:srgbClr val="CCCCCC"/>
+                      </a:solidFill>
+                      <a:prstDash val="solid"/>
+                      <a:round/>
+                      <a:headEnd type="none" w="med" len="med"/>
+                      <a:tailEnd type="none" w="med" len="med"/>
+                    </a:lnT>
+                    <a:lnB w="6350" cap="flat" cmpd="sng" algn="ctr">
+                      <a:solidFill>
+                        <a:srgbClr val="CCCCCC"/>
+                      </a:solidFill>
+                      <a:prstDash val="solid"/>
+                      <a:round/>
+                      <a:headEnd type="none" w="med" len="med"/>
+                      <a:tailEnd type="none" w="med" len="med"/>
+                    </a:lnB>
+                  </a:tcPr>
+                </a:tc>
+              </a:tr>
+              <a:tr h="406400">
+                <a:tc>
+                  <a:txBody>
+                    <a:bodyPr/>
+                    <a:lstStyle/>
+                    <a:p>
+                      <a:pPr algn="ctr" indent="0" marL="0">
+                        <a:buNone/>
+                      </a:pPr>
+                      <a:r>
+                        <a:rPr lang="en-US" sz="900" dirty="0">
+                          <a:solidFill>
+                            <a:srgbClr val="2C2C2C"/>
+                          </a:solidFill>
+                        </a:rPr>
+                        <a:t>Paul233365</a:t>
+                      </a:r>
+                      <a:endParaRPr lang="en-US" sz="900" dirty="0"/>
+                    </a:p>
+                  </a:txBody>
+                  <a:tcPr marL="91440" marR="91440" marT="45720" marB="45720">
+                    <a:lnL w="6350" cap="flat" cmpd="sng" algn="ctr">
+                      <a:solidFill>
+                        <a:srgbClr val="CCCCCC"/>
+                      </a:solidFill>
+                      <a:prstDash val="solid"/>
+                      <a:round/>
+                      <a:headEnd type="none" w="med" len="med"/>
+                      <a:tailEnd type="none" w="med" len="med"/>
+                    </a:lnL>
+                    <a:lnR w="6350" cap="flat" cmpd="sng" algn="ctr">
+                      <a:solidFill>
+                        <a:srgbClr val="CCCCCC"/>
+                      </a:solidFill>
+                      <a:prstDash val="solid"/>
+                      <a:round/>
+                      <a:headEnd type="none" w="med" len="med"/>
+                      <a:tailEnd type="none" w="med" len="med"/>
+                    </a:lnR>
+                    <a:lnT w="6350" cap="flat" cmpd="sng" algn="ctr">
+                      <a:solidFill>
+                        <a:srgbClr val="CCCCCC"/>
+                      </a:solidFill>
+                      <a:prstDash val="solid"/>
+                      <a:round/>
+                      <a:headEnd type="none" w="med" len="med"/>
+                      <a:tailEnd type="none" w="med" len="med"/>
+                    </a:lnT>
+                    <a:lnB w="6350" cap="flat" cmpd="sng" algn="ctr">
+                      <a:solidFill>
+                        <a:srgbClr val="CCCCCC"/>
+                      </a:solidFill>
+                      <a:prstDash val="solid"/>
+                      <a:round/>
+                      <a:headEnd type="none" w="med" len="med"/>
+                      <a:tailEnd type="none" w="med" len="med"/>
+                    </a:lnB>
+                  </a:tcPr>
+                </a:tc>
+                <a:tc>
+                  <a:txBody>
+                    <a:bodyPr/>
+                    <a:lstStyle/>
+                    <a:p>
+                      <a:pPr algn="ctr" indent="0" marL="0">
+                        <a:buNone/>
+                      </a:pPr>
+                      <a:r>
+                        <a:rPr lang="en-US" sz="900" dirty="0">
+                          <a:solidFill>
+                            <a:srgbClr val="2C2C2C"/>
+                          </a:solidFill>
+                        </a:rPr>
+                        <a:t>32</a:t>
+                      </a:r>
+                      <a:endParaRPr lang="en-US" sz="900" dirty="0"/>
+                    </a:p>
+                  </a:txBody>
+                  <a:tcPr marL="91440" marR="91440" marT="45720" marB="45720">
+                    <a:lnL w="6350" cap="flat" cmpd="sng" algn="ctr">
+                      <a:solidFill>
+                        <a:srgbClr val="CCCCCC"/>
+                      </a:solidFill>
+                      <a:prstDash val="solid"/>
+                      <a:round/>
+                      <a:headEnd type="none" w="med" len="med"/>
+                      <a:tailEnd type="none" w="med" len="med"/>
+                    </a:lnL>
+                    <a:lnR w="6350" cap="flat" cmpd="sng" algn="ctr">
+                      <a:solidFill>
+                        <a:srgbClr val="CCCCCC"/>
+                      </a:solidFill>
+                      <a:prstDash val="solid"/>
+                      <a:round/>
+                      <a:headEnd type="none" w="med" len="med"/>
+                      <a:tailEnd type="none" w="med" len="med"/>
+                    </a:lnR>
+                    <a:lnT w="6350" cap="flat" cmpd="sng" algn="ctr">
+                      <a:solidFill>
+                        <a:srgbClr val="CCCCCC"/>
+                      </a:solidFill>
+                      <a:prstDash val="solid"/>
+                      <a:round/>
+                      <a:headEnd type="none" w="med" len="med"/>
+                      <a:tailEnd type="none" w="med" len="med"/>
+                    </a:lnT>
+                    <a:lnB w="6350" cap="flat" cmpd="sng" algn="ctr">
+                      <a:solidFill>
+                        <a:srgbClr val="CCCCCC"/>
+                      </a:solidFill>
+                      <a:prstDash val="solid"/>
+                      <a:round/>
+                      <a:headEnd type="none" w="med" len="med"/>
+                      <a:tailEnd type="none" w="med" len="med"/>
+                    </a:lnB>
+                  </a:tcPr>
+                </a:tc>
+                <a:tc>
+                  <a:txBody>
+                    <a:bodyPr/>
+                    <a:lstStyle/>
+                    <a:p>
+                      <a:pPr algn="ctr" indent="0" marL="0">
+                        <a:buNone/>
+                      </a:pPr>
+                      <a:r>
+                        <a:rPr lang="en-US" sz="900" dirty="0">
+                          <a:solidFill>
+                            <a:srgbClr val="2C2C2C"/>
+                          </a:solidFill>
+                        </a:rPr>
+                        <a:t>11</a:t>
+                      </a:r>
+                      <a:endParaRPr lang="en-US" sz="900" dirty="0"/>
+                    </a:p>
+                  </a:txBody>
+                  <a:tcPr marL="91440" marR="91440" marT="45720" marB="45720">
+                    <a:lnL w="6350" cap="flat" cmpd="sng" algn="ctr">
+                      <a:solidFill>
+                        <a:srgbClr val="CCCCCC"/>
+                      </a:solidFill>
+                      <a:prstDash val="solid"/>
+                      <a:round/>
+                      <a:headEnd type="none" w="med" len="med"/>
+                      <a:tailEnd type="none" w="med" len="med"/>
+                    </a:lnL>
+                    <a:lnR w="6350" cap="flat" cmpd="sng" algn="ctr">
+                      <a:solidFill>
+                        <a:srgbClr val="CCCCCC"/>
+                      </a:solidFill>
+                      <a:prstDash val="solid"/>
+                      <a:round/>
+                      <a:headEnd type="none" w="med" len="med"/>
+                      <a:tailEnd type="none" w="med" len="med"/>
+                    </a:lnR>
+                    <a:lnT w="6350" cap="flat" cmpd="sng" algn="ctr">
+                      <a:solidFill>
+                        <a:srgbClr val="CCCCCC"/>
+                      </a:solidFill>
+                      <a:prstDash val="solid"/>
+                      <a:round/>
+                      <a:headEnd type="none" w="med" len="med"/>
+                      <a:tailEnd type="none" w="med" len="med"/>
+                    </a:lnT>
+                    <a:lnB w="6350" cap="flat" cmpd="sng" algn="ctr">
+                      <a:solidFill>
+                        <a:srgbClr val="CCCCCC"/>
+                      </a:solidFill>
+                      <a:prstDash val="solid"/>
+                      <a:round/>
+                      <a:headEnd type="none" w="med" len="med"/>
+                      <a:tailEnd type="none" w="med" len="med"/>
+                    </a:lnB>
+                  </a:tcPr>
+                </a:tc>
+                <a:tc>
+                  <a:txBody>
+                    <a:bodyPr/>
+                    <a:lstStyle/>
+                    <a:p>
+                      <a:pPr algn="ctr" indent="0" marL="0">
+                        <a:buNone/>
+                      </a:pPr>
+                      <a:r>
+                        <a:rPr lang="en-US" sz="900" dirty="0">
+                          <a:solidFill>
+                            <a:srgbClr val="2C2C2C"/>
+                          </a:solidFill>
+                        </a:rPr>
+                        <a:t>24</a:t>
+                      </a:r>
+                      <a:endParaRPr lang="en-US" sz="900" dirty="0"/>
+                    </a:p>
+                  </a:txBody>
+                  <a:tcPr marL="91440" marR="91440" marT="45720" marB="45720">
+                    <a:lnL w="6350" cap="flat" cmpd="sng" algn="ctr">
+                      <a:solidFill>
+                        <a:srgbClr val="CCCCCC"/>
+                      </a:solidFill>
+                      <a:prstDash val="solid"/>
+                      <a:round/>
+                      <a:headEnd type="none" w="med" len="med"/>
+                      <a:tailEnd type="none" w="med" len="med"/>
+                    </a:lnL>
+                    <a:lnR w="6350" cap="flat" cmpd="sng" algn="ctr">
+                      <a:solidFill>
+                        <a:srgbClr val="CCCCCC"/>
+                      </a:solidFill>
+                      <a:prstDash val="solid"/>
+                      <a:round/>
+                      <a:headEnd type="none" w="med" len="med"/>
+                      <a:tailEnd type="none" w="med" len="med"/>
+                    </a:lnR>
+                    <a:lnT w="6350" cap="flat" cmpd="sng" algn="ctr">
+                      <a:solidFill>
+                        <a:srgbClr val="CCCCCC"/>
+                      </a:solidFill>
+                      <a:prstDash val="solid"/>
+                      <a:round/>
+                      <a:headEnd type="none" w="med" len="med"/>
+                      <a:tailEnd type="none" w="med" len="med"/>
+                    </a:lnT>
+                    <a:lnB w="6350" cap="flat" cmpd="sng" algn="ctr">
+                      <a:solidFill>
+                        <a:srgbClr val="CCCCCC"/>
+                      </a:solidFill>
+                      <a:prstDash val="solid"/>
+                      <a:round/>
+                      <a:headEnd type="none" w="med" len="med"/>
+                      <a:tailEnd type="none" w="med" len="med"/>
+                    </a:lnB>
+                  </a:tcPr>
+                </a:tc>
+                <a:tc>
+                  <a:txBody>
+                    <a:bodyPr/>
+                    <a:lstStyle/>
+                    <a:p>
+                      <a:pPr algn="ctr" indent="0" marL="0">
+                        <a:buNone/>
+                      </a:pPr>
+                      <a:r>
+                        <a:rPr lang="en-US" sz="900" dirty="0">
+                          <a:solidFill>
+                            <a:srgbClr val="2C2C2C"/>
+                          </a:solidFill>
+                        </a:rPr>
+                        <a:t>16</a:t>
+                      </a:r>
+                      <a:endParaRPr lang="en-US" sz="900" dirty="0"/>
+                    </a:p>
+                  </a:txBody>
+                  <a:tcPr marL="91440" marR="91440" marT="45720" marB="45720">
+                    <a:lnL w="6350" cap="flat" cmpd="sng" algn="ctr">
+                      <a:solidFill>
+                        <a:srgbClr val="CCCCCC"/>
+                      </a:solidFill>
+                      <a:prstDash val="solid"/>
+                      <a:round/>
+                      <a:headEnd type="none" w="med" len="med"/>
+                      <a:tailEnd type="none" w="med" len="med"/>
+                    </a:lnL>
+                    <a:lnR w="6350" cap="flat" cmpd="sng" algn="ctr">
+                      <a:solidFill>
+                        <a:srgbClr val="CCCCCC"/>
+                      </a:solidFill>
+                      <a:prstDash val="solid"/>
+                      <a:round/>
+                      <a:headEnd type="none" w="med" len="med"/>
+                      <a:tailEnd type="none" w="med" len="med"/>
+                    </a:lnR>
+                    <a:lnT w="6350" cap="flat" cmpd="sng" algn="ctr">
+                      <a:solidFill>
+                        <a:srgbClr val="CCCCCC"/>
+                      </a:solidFill>
+                      <a:prstDash val="solid"/>
+                      <a:round/>
+                      <a:headEnd type="none" w="med" len="med"/>
+                      <a:tailEnd type="none" w="med" len="med"/>
+                    </a:lnT>
+                    <a:lnB w="6350" cap="flat" cmpd="sng" algn="ctr">
+                      <a:solidFill>
+                        <a:srgbClr val="CCCCCC"/>
+                      </a:solidFill>
+                      <a:prstDash val="solid"/>
+                      <a:round/>
+                      <a:headEnd type="none" w="med" len="med"/>
+                      <a:tailEnd type="none" w="med" len="med"/>
+                    </a:lnB>
+                  </a:tcPr>
+                </a:tc>
+                <a:tc>
+                  <a:txBody>
+                    <a:bodyPr/>
+                    <a:lstStyle/>
+                    <a:p>
+                      <a:pPr algn="ctr" indent="0" marL="0">
+                        <a:buNone/>
+                      </a:pPr>
+                      <a:r>
+                        <a:rPr lang="en-US" sz="900" dirty="0">
+                          <a:solidFill>
+                            <a:srgbClr val="2C2C2C"/>
+                          </a:solidFill>
+                        </a:rPr>
+                        <a:t>86</a:t>
+                      </a:r>
+                      <a:endParaRPr lang="en-US" sz="900" dirty="0"/>
+                    </a:p>
+                  </a:txBody>
+                  <a:tcPr marL="91440" marR="91440" marT="45720" marB="45720">
+                    <a:lnL w="6350" cap="flat" cmpd="sng" algn="ctr">
+                      <a:solidFill>
+                        <a:srgbClr val="CCCCCC"/>
+                      </a:solidFill>
+                      <a:prstDash val="solid"/>
+                      <a:round/>
+                      <a:headEnd type="none" w="med" len="med"/>
+                      <a:tailEnd type="none" w="med" len="med"/>
+                    </a:lnL>
+                    <a:lnR w="6350" cap="flat" cmpd="sng" algn="ctr">
+                      <a:solidFill>
+                        <a:srgbClr val="CCCCCC"/>
+                      </a:solidFill>
+                      <a:prstDash val="solid"/>
+                      <a:round/>
+                      <a:headEnd type="none" w="med" len="med"/>
+                      <a:tailEnd type="none" w="med" len="med"/>
+                    </a:lnR>
+                    <a:lnT w="6350" cap="flat" cmpd="sng" algn="ctr">
+                      <a:solidFill>
+                        <a:srgbClr val="CCCCCC"/>
+                      </a:solidFill>
+                      <a:prstDash val="solid"/>
+                      <a:round/>
+                      <a:headEnd type="none" w="med" len="med"/>
+                      <a:tailEnd type="none" w="med" len="med"/>
+                    </a:lnT>
+                    <a:lnB w="6350" cap="flat" cmpd="sng" algn="ctr">
+                      <a:solidFill>
+                        <a:srgbClr val="CCCCCC"/>
+                      </a:solidFill>
+                      <a:prstDash val="solid"/>
+                      <a:round/>
+                      <a:headEnd type="none" w="med" len="med"/>
+                      <a:tailEnd type="none" w="med" len="med"/>
+                    </a:lnB>
+                  </a:tcPr>
+                </a:tc>
+                <a:tc>
+                  <a:txBody>
+                    <a:bodyPr/>
+                    <a:lstStyle/>
+                    <a:p>
+                      <a:pPr algn="ctr" indent="0" marL="0">
+                        <a:buNone/>
+                      </a:pPr>
+                      <a:r>
+                        <a:rPr lang="en-US" sz="900" dirty="0">
+                          <a:solidFill>
+                            <a:srgbClr val="2C2C2C"/>
+                          </a:solidFill>
+                        </a:rPr>
+                        <a:t>3</a:t>
                       </a:r>
                       <a:endParaRPr lang="en-US" sz="900" dirty="0"/>
                     </a:p>
@@ -9485,7 +9893,7 @@
                             <a:srgbClr val="2C2C2C"/>
                           </a:solidFill>
                         </a:rPr>
-                        <a:t>12</a:t>
+                        <a:t>13</a:t>
                       </a:r>
                       <a:endParaRPr lang="en-US" sz="900" dirty="0"/>
                     </a:p>
@@ -9718,414 +10126,6 @@
                           </a:solidFill>
                         </a:rPr>
                         <a:t>6</a:t>
-                      </a:r>
-                      <a:endParaRPr lang="en-US" sz="900" dirty="0"/>
-                    </a:p>
-                  </a:txBody>
-                  <a:tcPr marL="91440" marR="91440" marT="45720" marB="45720">
-                    <a:lnL w="6350" cap="flat" cmpd="sng" algn="ctr">
-                      <a:solidFill>
-                        <a:srgbClr val="CCCCCC"/>
-                      </a:solidFill>
-                      <a:prstDash val="solid"/>
-                      <a:round/>
-                      <a:headEnd type="none" w="med" len="med"/>
-                      <a:tailEnd type="none" w="med" len="med"/>
-                    </a:lnL>
-                    <a:lnR w="6350" cap="flat" cmpd="sng" algn="ctr">
-                      <a:solidFill>
-                        <a:srgbClr val="CCCCCC"/>
-                      </a:solidFill>
-                      <a:prstDash val="solid"/>
-                      <a:round/>
-                      <a:headEnd type="none" w="med" len="med"/>
-                      <a:tailEnd type="none" w="med" len="med"/>
-                    </a:lnR>
-                    <a:lnT w="6350" cap="flat" cmpd="sng" algn="ctr">
-                      <a:solidFill>
-                        <a:srgbClr val="CCCCCC"/>
-                      </a:solidFill>
-                      <a:prstDash val="solid"/>
-                      <a:round/>
-                      <a:headEnd type="none" w="med" len="med"/>
-                      <a:tailEnd type="none" w="med" len="med"/>
-                    </a:lnT>
-                    <a:lnB w="6350" cap="flat" cmpd="sng" algn="ctr">
-                      <a:solidFill>
-                        <a:srgbClr val="CCCCCC"/>
-                      </a:solidFill>
-                      <a:prstDash val="solid"/>
-                      <a:round/>
-                      <a:headEnd type="none" w="med" len="med"/>
-                      <a:tailEnd type="none" w="med" len="med"/>
-                    </a:lnB>
-                  </a:tcPr>
-                </a:tc>
-              </a:tr>
-              <a:tr h="406400">
-                <a:tc>
-                  <a:txBody>
-                    <a:bodyPr/>
-                    <a:lstStyle/>
-                    <a:p>
-                      <a:pPr algn="ctr" indent="0" marL="0">
-                        <a:buNone/>
-                      </a:pPr>
-                      <a:r>
-                        <a:rPr lang="en-US" sz="900" dirty="0">
-                          <a:solidFill>
-                            <a:srgbClr val="2C2C2C"/>
-                          </a:solidFill>
-                        </a:rPr>
-                        <a:t>Paul233365</a:t>
-                      </a:r>
-                      <a:endParaRPr lang="en-US" sz="900" dirty="0"/>
-                    </a:p>
-                  </a:txBody>
-                  <a:tcPr marL="91440" marR="91440" marT="45720" marB="45720">
-                    <a:lnL w="6350" cap="flat" cmpd="sng" algn="ctr">
-                      <a:solidFill>
-                        <a:srgbClr val="CCCCCC"/>
-                      </a:solidFill>
-                      <a:prstDash val="solid"/>
-                      <a:round/>
-                      <a:headEnd type="none" w="med" len="med"/>
-                      <a:tailEnd type="none" w="med" len="med"/>
-                    </a:lnL>
-                    <a:lnR w="6350" cap="flat" cmpd="sng" algn="ctr">
-                      <a:solidFill>
-                        <a:srgbClr val="CCCCCC"/>
-                      </a:solidFill>
-                      <a:prstDash val="solid"/>
-                      <a:round/>
-                      <a:headEnd type="none" w="med" len="med"/>
-                      <a:tailEnd type="none" w="med" len="med"/>
-                    </a:lnR>
-                    <a:lnT w="6350" cap="flat" cmpd="sng" algn="ctr">
-                      <a:solidFill>
-                        <a:srgbClr val="CCCCCC"/>
-                      </a:solidFill>
-                      <a:prstDash val="solid"/>
-                      <a:round/>
-                      <a:headEnd type="none" w="med" len="med"/>
-                      <a:tailEnd type="none" w="med" len="med"/>
-                    </a:lnT>
-                    <a:lnB w="6350" cap="flat" cmpd="sng" algn="ctr">
-                      <a:solidFill>
-                        <a:srgbClr val="CCCCCC"/>
-                      </a:solidFill>
-                      <a:prstDash val="solid"/>
-                      <a:round/>
-                      <a:headEnd type="none" w="med" len="med"/>
-                      <a:tailEnd type="none" w="med" len="med"/>
-                    </a:lnB>
-                  </a:tcPr>
-                </a:tc>
-                <a:tc>
-                  <a:txBody>
-                    <a:bodyPr/>
-                    <a:lstStyle/>
-                    <a:p>
-                      <a:pPr algn="ctr" indent="0" marL="0">
-                        <a:buNone/>
-                      </a:pPr>
-                      <a:r>
-                        <a:rPr lang="en-US" sz="900" dirty="0">
-                          <a:solidFill>
-                            <a:srgbClr val="2C2C2C"/>
-                          </a:solidFill>
-                        </a:rPr>
-                        <a:t>31</a:t>
-                      </a:r>
-                      <a:endParaRPr lang="en-US" sz="900" dirty="0"/>
-                    </a:p>
-                  </a:txBody>
-                  <a:tcPr marL="91440" marR="91440" marT="45720" marB="45720">
-                    <a:lnL w="6350" cap="flat" cmpd="sng" algn="ctr">
-                      <a:solidFill>
-                        <a:srgbClr val="CCCCCC"/>
-                      </a:solidFill>
-                      <a:prstDash val="solid"/>
-                      <a:round/>
-                      <a:headEnd type="none" w="med" len="med"/>
-                      <a:tailEnd type="none" w="med" len="med"/>
-                    </a:lnL>
-                    <a:lnR w="6350" cap="flat" cmpd="sng" algn="ctr">
-                      <a:solidFill>
-                        <a:srgbClr val="CCCCCC"/>
-                      </a:solidFill>
-                      <a:prstDash val="solid"/>
-                      <a:round/>
-                      <a:headEnd type="none" w="med" len="med"/>
-                      <a:tailEnd type="none" w="med" len="med"/>
-                    </a:lnR>
-                    <a:lnT w="6350" cap="flat" cmpd="sng" algn="ctr">
-                      <a:solidFill>
-                        <a:srgbClr val="CCCCCC"/>
-                      </a:solidFill>
-                      <a:prstDash val="solid"/>
-                      <a:round/>
-                      <a:headEnd type="none" w="med" len="med"/>
-                      <a:tailEnd type="none" w="med" len="med"/>
-                    </a:lnT>
-                    <a:lnB w="6350" cap="flat" cmpd="sng" algn="ctr">
-                      <a:solidFill>
-                        <a:srgbClr val="CCCCCC"/>
-                      </a:solidFill>
-                      <a:prstDash val="solid"/>
-                      <a:round/>
-                      <a:headEnd type="none" w="med" len="med"/>
-                      <a:tailEnd type="none" w="med" len="med"/>
-                    </a:lnB>
-                  </a:tcPr>
-                </a:tc>
-                <a:tc>
-                  <a:txBody>
-                    <a:bodyPr/>
-                    <a:lstStyle/>
-                    <a:p>
-                      <a:pPr algn="ctr" indent="0" marL="0">
-                        <a:buNone/>
-                      </a:pPr>
-                      <a:r>
-                        <a:rPr lang="en-US" sz="900" dirty="0">
-                          <a:solidFill>
-                            <a:srgbClr val="2C2C2C"/>
-                          </a:solidFill>
-                        </a:rPr>
-                        <a:t>11</a:t>
-                      </a:r>
-                      <a:endParaRPr lang="en-US" sz="900" dirty="0"/>
-                    </a:p>
-                  </a:txBody>
-                  <a:tcPr marL="91440" marR="91440" marT="45720" marB="45720">
-                    <a:lnL w="6350" cap="flat" cmpd="sng" algn="ctr">
-                      <a:solidFill>
-                        <a:srgbClr val="CCCCCC"/>
-                      </a:solidFill>
-                      <a:prstDash val="solid"/>
-                      <a:round/>
-                      <a:headEnd type="none" w="med" len="med"/>
-                      <a:tailEnd type="none" w="med" len="med"/>
-                    </a:lnL>
-                    <a:lnR w="6350" cap="flat" cmpd="sng" algn="ctr">
-                      <a:solidFill>
-                        <a:srgbClr val="CCCCCC"/>
-                      </a:solidFill>
-                      <a:prstDash val="solid"/>
-                      <a:round/>
-                      <a:headEnd type="none" w="med" len="med"/>
-                      <a:tailEnd type="none" w="med" len="med"/>
-                    </a:lnR>
-                    <a:lnT w="6350" cap="flat" cmpd="sng" algn="ctr">
-                      <a:solidFill>
-                        <a:srgbClr val="CCCCCC"/>
-                      </a:solidFill>
-                      <a:prstDash val="solid"/>
-                      <a:round/>
-                      <a:headEnd type="none" w="med" len="med"/>
-                      <a:tailEnd type="none" w="med" len="med"/>
-                    </a:lnT>
-                    <a:lnB w="6350" cap="flat" cmpd="sng" algn="ctr">
-                      <a:solidFill>
-                        <a:srgbClr val="CCCCCC"/>
-                      </a:solidFill>
-                      <a:prstDash val="solid"/>
-                      <a:round/>
-                      <a:headEnd type="none" w="med" len="med"/>
-                      <a:tailEnd type="none" w="med" len="med"/>
-                    </a:lnB>
-                  </a:tcPr>
-                </a:tc>
-                <a:tc>
-                  <a:txBody>
-                    <a:bodyPr/>
-                    <a:lstStyle/>
-                    <a:p>
-                      <a:pPr algn="ctr" indent="0" marL="0">
-                        <a:buNone/>
-                      </a:pPr>
-                      <a:r>
-                        <a:rPr lang="en-US" sz="900" dirty="0">
-                          <a:solidFill>
-                            <a:srgbClr val="2C2C2C"/>
-                          </a:solidFill>
-                        </a:rPr>
-                        <a:t>24</a:t>
-                      </a:r>
-                      <a:endParaRPr lang="en-US" sz="900" dirty="0"/>
-                    </a:p>
-                  </a:txBody>
-                  <a:tcPr marL="91440" marR="91440" marT="45720" marB="45720">
-                    <a:lnL w="6350" cap="flat" cmpd="sng" algn="ctr">
-                      <a:solidFill>
-                        <a:srgbClr val="CCCCCC"/>
-                      </a:solidFill>
-                      <a:prstDash val="solid"/>
-                      <a:round/>
-                      <a:headEnd type="none" w="med" len="med"/>
-                      <a:tailEnd type="none" w="med" len="med"/>
-                    </a:lnL>
-                    <a:lnR w="6350" cap="flat" cmpd="sng" algn="ctr">
-                      <a:solidFill>
-                        <a:srgbClr val="CCCCCC"/>
-                      </a:solidFill>
-                      <a:prstDash val="solid"/>
-                      <a:round/>
-                      <a:headEnd type="none" w="med" len="med"/>
-                      <a:tailEnd type="none" w="med" len="med"/>
-                    </a:lnR>
-                    <a:lnT w="6350" cap="flat" cmpd="sng" algn="ctr">
-                      <a:solidFill>
-                        <a:srgbClr val="CCCCCC"/>
-                      </a:solidFill>
-                      <a:prstDash val="solid"/>
-                      <a:round/>
-                      <a:headEnd type="none" w="med" len="med"/>
-                      <a:tailEnd type="none" w="med" len="med"/>
-                    </a:lnT>
-                    <a:lnB w="6350" cap="flat" cmpd="sng" algn="ctr">
-                      <a:solidFill>
-                        <a:srgbClr val="CCCCCC"/>
-                      </a:solidFill>
-                      <a:prstDash val="solid"/>
-                      <a:round/>
-                      <a:headEnd type="none" w="med" len="med"/>
-                      <a:tailEnd type="none" w="med" len="med"/>
-                    </a:lnB>
-                  </a:tcPr>
-                </a:tc>
-                <a:tc>
-                  <a:txBody>
-                    <a:bodyPr/>
-                    <a:lstStyle/>
-                    <a:p>
-                      <a:pPr algn="ctr" indent="0" marL="0">
-                        <a:buNone/>
-                      </a:pPr>
-                      <a:r>
-                        <a:rPr lang="en-US" sz="900" dirty="0">
-                          <a:solidFill>
-                            <a:srgbClr val="2C2C2C"/>
-                          </a:solidFill>
-                        </a:rPr>
-                        <a:t>14</a:t>
-                      </a:r>
-                      <a:endParaRPr lang="en-US" sz="900" dirty="0"/>
-                    </a:p>
-                  </a:txBody>
-                  <a:tcPr marL="91440" marR="91440" marT="45720" marB="45720">
-                    <a:lnL w="6350" cap="flat" cmpd="sng" algn="ctr">
-                      <a:solidFill>
-                        <a:srgbClr val="CCCCCC"/>
-                      </a:solidFill>
-                      <a:prstDash val="solid"/>
-                      <a:round/>
-                      <a:headEnd type="none" w="med" len="med"/>
-                      <a:tailEnd type="none" w="med" len="med"/>
-                    </a:lnL>
-                    <a:lnR w="6350" cap="flat" cmpd="sng" algn="ctr">
-                      <a:solidFill>
-                        <a:srgbClr val="CCCCCC"/>
-                      </a:solidFill>
-                      <a:prstDash val="solid"/>
-                      <a:round/>
-                      <a:headEnd type="none" w="med" len="med"/>
-                      <a:tailEnd type="none" w="med" len="med"/>
-                    </a:lnR>
-                    <a:lnT w="6350" cap="flat" cmpd="sng" algn="ctr">
-                      <a:solidFill>
-                        <a:srgbClr val="CCCCCC"/>
-                      </a:solidFill>
-                      <a:prstDash val="solid"/>
-                      <a:round/>
-                      <a:headEnd type="none" w="med" len="med"/>
-                      <a:tailEnd type="none" w="med" len="med"/>
-                    </a:lnT>
-                    <a:lnB w="6350" cap="flat" cmpd="sng" algn="ctr">
-                      <a:solidFill>
-                        <a:srgbClr val="CCCCCC"/>
-                      </a:solidFill>
-                      <a:prstDash val="solid"/>
-                      <a:round/>
-                      <a:headEnd type="none" w="med" len="med"/>
-                      <a:tailEnd type="none" w="med" len="med"/>
-                    </a:lnB>
-                  </a:tcPr>
-                </a:tc>
-                <a:tc>
-                  <a:txBody>
-                    <a:bodyPr/>
-                    <a:lstStyle/>
-                    <a:p>
-                      <a:pPr algn="ctr" indent="0" marL="0">
-                        <a:buNone/>
-                      </a:pPr>
-                      <a:r>
-                        <a:rPr lang="en-US" sz="900" dirty="0">
-                          <a:solidFill>
-                            <a:srgbClr val="2C2C2C"/>
-                          </a:solidFill>
-                        </a:rPr>
-                        <a:t>86</a:t>
-                      </a:r>
-                      <a:endParaRPr lang="en-US" sz="900" dirty="0"/>
-                    </a:p>
-                  </a:txBody>
-                  <a:tcPr marL="91440" marR="91440" marT="45720" marB="45720">
-                    <a:lnL w="6350" cap="flat" cmpd="sng" algn="ctr">
-                      <a:solidFill>
-                        <a:srgbClr val="CCCCCC"/>
-                      </a:solidFill>
-                      <a:prstDash val="solid"/>
-                      <a:round/>
-                      <a:headEnd type="none" w="med" len="med"/>
-                      <a:tailEnd type="none" w="med" len="med"/>
-                    </a:lnL>
-                    <a:lnR w="6350" cap="flat" cmpd="sng" algn="ctr">
-                      <a:solidFill>
-                        <a:srgbClr val="CCCCCC"/>
-                      </a:solidFill>
-                      <a:prstDash val="solid"/>
-                      <a:round/>
-                      <a:headEnd type="none" w="med" len="med"/>
-                      <a:tailEnd type="none" w="med" len="med"/>
-                    </a:lnR>
-                    <a:lnT w="6350" cap="flat" cmpd="sng" algn="ctr">
-                      <a:solidFill>
-                        <a:srgbClr val="CCCCCC"/>
-                      </a:solidFill>
-                      <a:prstDash val="solid"/>
-                      <a:round/>
-                      <a:headEnd type="none" w="med" len="med"/>
-                      <a:tailEnd type="none" w="med" len="med"/>
-                    </a:lnT>
-                    <a:lnB w="6350" cap="flat" cmpd="sng" algn="ctr">
-                      <a:solidFill>
-                        <a:srgbClr val="CCCCCC"/>
-                      </a:solidFill>
-                      <a:prstDash val="solid"/>
-                      <a:round/>
-                      <a:headEnd type="none" w="med" len="med"/>
-                      <a:tailEnd type="none" w="med" len="med"/>
-                    </a:lnB>
-                  </a:tcPr>
-                </a:tc>
-                <a:tc>
-                  <a:txBody>
-                    <a:bodyPr/>
-                    <a:lstStyle/>
-                    <a:p>
-                      <a:pPr algn="ctr" indent="0" marL="0">
-                        <a:buNone/>
-                      </a:pPr>
-                      <a:r>
-                        <a:rPr lang="en-US" sz="900" dirty="0">
-                          <a:solidFill>
-                            <a:srgbClr val="2C2C2C"/>
-                          </a:solidFill>
-                        </a:rPr>
-                        <a:t>3</a:t>
                       </a:r>
                       <a:endParaRPr lang="en-US" sz="900" dirty="0"/>
                     </a:p>
@@ -10301,7 +10301,7 @@
                             <a:srgbClr val="2C2C2C"/>
                           </a:solidFill>
                         </a:rPr>
-                        <a:t>16</a:t>
+                        <a:t>17</a:t>
                       </a:r>
                       <a:endParaRPr lang="en-US" sz="900" dirty="0"/>
                     </a:p>
@@ -10709,7 +10709,7 @@
                             <a:srgbClr val="2C2C2C"/>
                           </a:solidFill>
                         </a:rPr>
-                        <a:t>17</a:t>
+                        <a:t>18</a:t>
                       </a:r>
                       <a:endParaRPr lang="en-US" sz="900" dirty="0"/>
                     </a:p>
@@ -11117,7 +11117,7 @@
                             <a:srgbClr val="2C2C2C"/>
                           </a:solidFill>
                         </a:rPr>
-                        <a:t>16</a:t>
+                        <a:t>17</a:t>
                       </a:r>
                       <a:endParaRPr lang="en-US" sz="900" dirty="0"/>
                     </a:p>
@@ -11888,7 +11888,7 @@
         </p:nvSpPr>
         <p:spPr>
           <a:xfrm>
-            <a:off x="4536440" y="2912633"/>
+            <a:off x="5806440" y="3445136"/>
             <a:ext cx="274320" cy="274320"/>
           </a:xfrm>
           <a:prstGeom prst="ellipse">
@@ -11903,6 +11903,62 @@
       <p:sp>
         <p:nvSpPr>
           <p:cNvPr id="16" name="Text 14"/>
+          <p:cNvSpPr/>
+          <p:nvPr/>
+        </p:nvSpPr>
+        <p:spPr>
+          <a:xfrm>
+            <a:off x="5577840" y="3170816"/>
+            <a:ext cx="731520" cy="182880"/>
+          </a:xfrm>
+          <a:prstGeom prst="rect">
+            <a:avLst/>
+          </a:prstGeom>
+          <a:noFill/>
+          <a:ln/>
+        </p:spPr>
+        <p:txBody>
+          <a:bodyPr wrap="square" rtlCol="0" anchor="ctr"/>
+          <a:lstStyle/>
+          <a:p>
+            <a:pPr algn="ctr" indent="0" marL="0">
+              <a:buNone/>
+            </a:pPr>
+            <a:r>
+              <a:rPr lang="en-US" sz="600" dirty="0">
+                <a:solidFill>
+                  <a:srgbClr val="2C2C2C"/>
+                </a:solidFill>
+              </a:rPr>
+              <a:t>Paul233365</a:t>
+            </a:r>
+            <a:endParaRPr lang="en-US" sz="600" dirty="0"/>
+          </a:p>
+        </p:txBody>
+      </p:sp>
+      <p:sp>
+        <p:nvSpPr>
+          <p:cNvPr id="17" name="Shape 15"/>
+          <p:cNvSpPr/>
+          <p:nvPr/>
+        </p:nvSpPr>
+        <p:spPr>
+          <a:xfrm>
+            <a:off x="4536440" y="2912633"/>
+            <a:ext cx="274320" cy="274320"/>
+          </a:xfrm>
+          <a:prstGeom prst="ellipse">
+            <a:avLst/>
+          </a:prstGeom>
+          <a:solidFill>
+            <a:srgbClr val="DC1A41"/>
+          </a:solidFill>
+          <a:ln/>
+        </p:spPr>
+      </p:sp>
+      <p:sp>
+        <p:nvSpPr>
+          <p:cNvPr id="18" name="Text 16"/>
           <p:cNvSpPr/>
           <p:nvPr/>
         </p:nvSpPr>
@@ -11931,62 +11987,6 @@
                 </a:solidFill>
               </a:rPr>
               <a:t>twnutt</a:t>
-            </a:r>
-            <a:endParaRPr lang="en-US" sz="600" dirty="0"/>
-          </a:p>
-        </p:txBody>
-      </p:sp>
-      <p:sp>
-        <p:nvSpPr>
-          <p:cNvPr id="17" name="Shape 15"/>
-          <p:cNvSpPr/>
-          <p:nvPr/>
-        </p:nvSpPr>
-        <p:spPr>
-          <a:xfrm>
-            <a:off x="5806440" y="3445136"/>
-            <a:ext cx="274320" cy="274320"/>
-          </a:xfrm>
-          <a:prstGeom prst="ellipse">
-            <a:avLst/>
-          </a:prstGeom>
-          <a:solidFill>
-            <a:srgbClr val="DC1A41"/>
-          </a:solidFill>
-          <a:ln/>
-        </p:spPr>
-      </p:sp>
-      <p:sp>
-        <p:nvSpPr>
-          <p:cNvPr id="18" name="Text 16"/>
-          <p:cNvSpPr/>
-          <p:nvPr/>
-        </p:nvSpPr>
-        <p:spPr>
-          <a:xfrm>
-            <a:off x="5577840" y="3170816"/>
-            <a:ext cx="731520" cy="182880"/>
-          </a:xfrm>
-          <a:prstGeom prst="rect">
-            <a:avLst/>
-          </a:prstGeom>
-          <a:noFill/>
-          <a:ln/>
-        </p:spPr>
-        <p:txBody>
-          <a:bodyPr wrap="square" rtlCol="0" anchor="ctr"/>
-          <a:lstStyle/>
-          <a:p>
-            <a:pPr algn="ctr" indent="0" marL="0">
-              <a:buNone/>
-            </a:pPr>
-            <a:r>
-              <a:rPr lang="en-US" sz="600" dirty="0">
-                <a:solidFill>
-                  <a:srgbClr val="2C2C2C"/>
-                </a:solidFill>
-              </a:rPr>
-              <a:t>Paul233365</a:t>
             </a:r>
             <a:endParaRPr lang="en-US" sz="600" dirty="0"/>
           </a:p>
@@ -12728,6 +12728,118 @@
                   <a:srgbClr val="2C2C2C"/>
                 </a:solidFill>
               </a:rPr>
+              <a:t>Paul233365</a:t>
+            </a:r>
+            <a:endParaRPr lang="en-US" sz="800" dirty="0"/>
+          </a:p>
+        </p:txBody>
+      </p:sp>
+      <p:sp>
+        <p:nvSpPr>
+          <p:cNvPr id="18" name="Shape 16"/>
+          <p:cNvSpPr/>
+          <p:nvPr/>
+        </p:nvSpPr>
+        <p:spPr>
+          <a:xfrm>
+            <a:off x="2103120" y="2139696"/>
+            <a:ext cx="5547360" cy="109728"/>
+          </a:xfrm>
+          <a:prstGeom prst="rect">
+            <a:avLst/>
+          </a:prstGeom>
+          <a:solidFill>
+            <a:srgbClr val="2B5A7E"/>
+          </a:solidFill>
+          <a:ln/>
+        </p:spPr>
+      </p:sp>
+      <p:sp>
+        <p:nvSpPr>
+          <p:cNvPr id="19" name="Shape 17"/>
+          <p:cNvSpPr/>
+          <p:nvPr/>
+        </p:nvSpPr>
+        <p:spPr>
+          <a:xfrm>
+            <a:off x="7650480" y="2139696"/>
+            <a:ext cx="1132114" cy="109728"/>
+          </a:xfrm>
+          <a:prstGeom prst="rect">
+            <a:avLst/>
+          </a:prstGeom>
+          <a:solidFill>
+            <a:srgbClr val="DC1A41"/>
+          </a:solidFill>
+          <a:ln/>
+        </p:spPr>
+      </p:sp>
+      <p:sp>
+        <p:nvSpPr>
+          <p:cNvPr id="20" name="Text 18"/>
+          <p:cNvSpPr/>
+          <p:nvPr/>
+        </p:nvSpPr>
+        <p:spPr>
+          <a:xfrm>
+            <a:off x="8874034" y="2112264"/>
+            <a:ext cx="548640" cy="292608"/>
+          </a:xfrm>
+          <a:prstGeom prst="rect">
+            <a:avLst/>
+          </a:prstGeom>
+          <a:noFill/>
+          <a:ln/>
+        </p:spPr>
+        <p:txBody>
+          <a:bodyPr wrap="square" rtlCol="0" anchor="ctr"/>
+          <a:lstStyle/>
+          <a:p>
+            <a:pPr indent="0" marL="0">
+              <a:buNone/>
+            </a:pPr>
+            <a:r>
+              <a:rPr lang="en-US" sz="800" b="1" dirty="0">
+                <a:solidFill>
+                  <a:srgbClr val="2C2C2C"/>
+                </a:solidFill>
+              </a:rPr>
+              <a:t>64</a:t>
+            </a:r>
+            <a:endParaRPr lang="en-US" sz="800" dirty="0"/>
+          </a:p>
+        </p:txBody>
+      </p:sp>
+      <p:sp>
+        <p:nvSpPr>
+          <p:cNvPr id="21" name="Text 19"/>
+          <p:cNvSpPr/>
+          <p:nvPr/>
+        </p:nvSpPr>
+        <p:spPr>
+          <a:xfrm>
+            <a:off x="365760" y="2496312"/>
+            <a:ext cx="1645920" cy="292608"/>
+          </a:xfrm>
+          <a:prstGeom prst="rect">
+            <a:avLst/>
+          </a:prstGeom>
+          <a:noFill/>
+          <a:ln/>
+        </p:spPr>
+        <p:txBody>
+          <a:bodyPr wrap="square" rtlCol="0" anchor="ctr"/>
+          <a:lstStyle/>
+          <a:p>
+            <a:pPr algn="r" indent="0" marL="0">
+              <a:buNone/>
+            </a:pPr>
+            <a:r>
+              <a:rPr lang="en-US" sz="800" dirty="0">
+                <a:solidFill>
+                  <a:srgbClr val="2C2C2C"/>
+                </a:solidFill>
+              </a:rPr>
               <a:t>twnutt</a:t>
             </a:r>
             <a:endParaRPr lang="en-US" sz="800" dirty="0"/>
@@ -12736,13 +12848,13 @@
       </p:sp>
       <p:sp>
         <p:nvSpPr>
-          <p:cNvPr id="18" name="Shape 16"/>
-          <p:cNvSpPr/>
-          <p:nvPr/>
-        </p:nvSpPr>
-        <p:spPr>
-          <a:xfrm>
-            <a:off x="2103120" y="2139696"/>
+          <p:cNvPr id="22" name="Shape 20"/>
+          <p:cNvSpPr/>
+          <p:nvPr/>
+        </p:nvSpPr>
+        <p:spPr>
+          <a:xfrm>
+            <a:off x="2103120" y="2523744"/>
             <a:ext cx="5250180" cy="109728"/>
           </a:xfrm>
           <a:prstGeom prst="rect">
@@ -12756,13 +12868,13 @@
       </p:sp>
       <p:sp>
         <p:nvSpPr>
-          <p:cNvPr id="19" name="Shape 17"/>
-          <p:cNvSpPr/>
-          <p:nvPr/>
-        </p:nvSpPr>
-        <p:spPr>
-          <a:xfrm>
-            <a:off x="7353300" y="2139696"/>
+          <p:cNvPr id="23" name="Shape 21"/>
+          <p:cNvSpPr/>
+          <p:nvPr/>
+        </p:nvSpPr>
+        <p:spPr>
+          <a:xfrm>
+            <a:off x="7353300" y="2523744"/>
             <a:ext cx="2122714" cy="109728"/>
           </a:xfrm>
           <a:prstGeom prst="rect">
@@ -12776,13 +12888,13 @@
       </p:sp>
       <p:sp>
         <p:nvSpPr>
-          <p:cNvPr id="20" name="Text 18"/>
-          <p:cNvSpPr/>
-          <p:nvPr/>
-        </p:nvSpPr>
-        <p:spPr>
-          <a:xfrm>
-            <a:off x="9567454" y="2112264"/>
+          <p:cNvPr id="24" name="Text 22"/>
+          <p:cNvSpPr/>
+          <p:nvPr/>
+        </p:nvSpPr>
+        <p:spPr>
+          <a:xfrm>
+            <a:off x="9567454" y="2496312"/>
             <a:ext cx="548640" cy="292608"/>
           </a:xfrm>
           <a:prstGeom prst="rect">
@@ -12805,118 +12917,6 @@
                 </a:solidFill>
               </a:rPr>
               <a:t>68</a:t>
-            </a:r>
-            <a:endParaRPr lang="en-US" sz="800" dirty="0"/>
-          </a:p>
-        </p:txBody>
-      </p:sp>
-      <p:sp>
-        <p:nvSpPr>
-          <p:cNvPr id="21" name="Text 19"/>
-          <p:cNvSpPr/>
-          <p:nvPr/>
-        </p:nvSpPr>
-        <p:spPr>
-          <a:xfrm>
-            <a:off x="365760" y="2496312"/>
-            <a:ext cx="1645920" cy="292608"/>
-          </a:xfrm>
-          <a:prstGeom prst="rect">
-            <a:avLst/>
-          </a:prstGeom>
-          <a:noFill/>
-          <a:ln/>
-        </p:spPr>
-        <p:txBody>
-          <a:bodyPr wrap="square" rtlCol="0" anchor="ctr"/>
-          <a:lstStyle/>
-          <a:p>
-            <a:pPr algn="r" indent="0" marL="0">
-              <a:buNone/>
-            </a:pPr>
-            <a:r>
-              <a:rPr lang="en-US" sz="800" dirty="0">
-                <a:solidFill>
-                  <a:srgbClr val="2C2C2C"/>
-                </a:solidFill>
-              </a:rPr>
-              <a:t>Paul233365</a:t>
-            </a:r>
-            <a:endParaRPr lang="en-US" sz="800" dirty="0"/>
-          </a:p>
-        </p:txBody>
-      </p:sp>
-      <p:sp>
-        <p:nvSpPr>
-          <p:cNvPr id="22" name="Shape 20"/>
-          <p:cNvSpPr/>
-          <p:nvPr/>
-        </p:nvSpPr>
-        <p:spPr>
-          <a:xfrm>
-            <a:off x="2103120" y="2523744"/>
-            <a:ext cx="5547360" cy="109728"/>
-          </a:xfrm>
-          <a:prstGeom prst="rect">
-            <a:avLst/>
-          </a:prstGeom>
-          <a:solidFill>
-            <a:srgbClr val="2B5A7E"/>
-          </a:solidFill>
-          <a:ln/>
-        </p:spPr>
-      </p:sp>
-      <p:sp>
-        <p:nvSpPr>
-          <p:cNvPr id="23" name="Shape 21"/>
-          <p:cNvSpPr/>
-          <p:nvPr/>
-        </p:nvSpPr>
-        <p:spPr>
-          <a:xfrm>
-            <a:off x="7650480" y="2523744"/>
-            <a:ext cx="1132114" cy="109728"/>
-          </a:xfrm>
-          <a:prstGeom prst="rect">
-            <a:avLst/>
-          </a:prstGeom>
-          <a:solidFill>
-            <a:srgbClr val="DC1A41"/>
-          </a:solidFill>
-          <a:ln/>
-        </p:spPr>
-      </p:sp>
-      <p:sp>
-        <p:nvSpPr>
-          <p:cNvPr id="24" name="Text 22"/>
-          <p:cNvSpPr/>
-          <p:nvPr/>
-        </p:nvSpPr>
-        <p:spPr>
-          <a:xfrm>
-            <a:off x="8874034" y="2496312"/>
-            <a:ext cx="548640" cy="292608"/>
-          </a:xfrm>
-          <a:prstGeom prst="rect">
-            <a:avLst/>
-          </a:prstGeom>
-          <a:noFill/>
-          <a:ln/>
-        </p:spPr>
-        <p:txBody>
-          <a:bodyPr wrap="square" rtlCol="0" anchor="ctr"/>
-          <a:lstStyle/>
-          <a:p>
-            <a:pPr indent="0" marL="0">
-              <a:buNone/>
-            </a:pPr>
-            <a:r>
-              <a:rPr lang="en-US" sz="800" b="1" dirty="0">
-                <a:solidFill>
-                  <a:srgbClr val="2C2C2C"/>
-                </a:solidFill>
-              </a:rPr>
-              <a:t>64</a:t>
             </a:r>
             <a:endParaRPr lang="en-US" sz="800" dirty="0"/>
           </a:p>
@@ -15780,7 +15780,7 @@
                   <a:srgbClr val="DC1A41"/>
                 </a:solidFill>
               </a:rPr>
-              <a:t>78% ceiling</a:t>
+              <a:t>82% ceiling</a:t>
             </a:r>
             <a:endParaRPr lang="en-US" sz="1600" dirty="0"/>
           </a:p>
@@ -15933,7 +15933,7 @@
                   <a:srgbClr val="DC1A41"/>
                 </a:solidFill>
               </a:rPr>
-              <a:t>75% ceiling</a:t>
+              <a:t>86% ceiling</a:t>
             </a:r>
             <a:endParaRPr lang="en-US" sz="1600" dirty="0"/>
           </a:p>
@@ -15993,6 +15993,159 @@
         <p:spPr>
           <a:xfrm>
             <a:off x="6647688" y="1481328"/>
+            <a:ext cx="1783080" cy="228600"/>
+          </a:xfrm>
+          <a:prstGeom prst="rect">
+            <a:avLst/>
+          </a:prstGeom>
+          <a:noFill/>
+          <a:ln/>
+        </p:spPr>
+        <p:txBody>
+          <a:bodyPr wrap="square" rtlCol="0" anchor="ctr"/>
+          <a:lstStyle/>
+          <a:p>
+            <a:pPr indent="0" marL="0">
+              <a:buNone/>
+            </a:pPr>
+            <a:r>
+              <a:rPr lang="en-US" sz="900" b="1" dirty="0">
+                <a:solidFill>
+                  <a:srgbClr val="2C2C2C"/>
+                </a:solidFill>
+              </a:rPr>
+              <a:t>Paul233365</a:t>
+            </a:r>
+            <a:endParaRPr lang="en-US" sz="900" dirty="0"/>
+          </a:p>
+        </p:txBody>
+      </p:sp>
+      <p:sp>
+        <p:nvSpPr>
+          <p:cNvPr id="24" name="Text 22"/>
+          <p:cNvSpPr/>
+          <p:nvPr/>
+        </p:nvSpPr>
+        <p:spPr>
+          <a:xfrm>
+            <a:off x="6647688" y="1737360"/>
+            <a:ext cx="1783080" cy="274320"/>
+          </a:xfrm>
+          <a:prstGeom prst="rect">
+            <a:avLst/>
+          </a:prstGeom>
+          <a:noFill/>
+          <a:ln/>
+        </p:spPr>
+        <p:txBody>
+          <a:bodyPr wrap="square" rtlCol="0" anchor="ctr"/>
+          <a:lstStyle/>
+          <a:p>
+            <a:pPr indent="0" marL="0">
+              <a:buNone/>
+            </a:pPr>
+            <a:r>
+              <a:rPr lang="en-US" sz="800" dirty="0">
+                <a:solidFill>
+                  <a:srgbClr val="6B6B6B"/>
+                </a:solidFill>
+              </a:rPr>
+              <a:t>Arizona Wildcats</a:t>
+            </a:r>
+            <a:endParaRPr lang="en-US" sz="800" dirty="0"/>
+          </a:p>
+        </p:txBody>
+      </p:sp>
+      <p:sp>
+        <p:nvSpPr>
+          <p:cNvPr id="25" name="Text 23"/>
+          <p:cNvSpPr/>
+          <p:nvPr/>
+        </p:nvSpPr>
+        <p:spPr>
+          <a:xfrm>
+            <a:off x="6647688" y="2057400"/>
+            <a:ext cx="1783080" cy="320040"/>
+          </a:xfrm>
+          <a:prstGeom prst="rect">
+            <a:avLst/>
+          </a:prstGeom>
+          <a:noFill/>
+          <a:ln/>
+        </p:spPr>
+        <p:txBody>
+          <a:bodyPr wrap="square" rtlCol="0" anchor="ctr"/>
+          <a:lstStyle/>
+          <a:p>
+            <a:pPr indent="0" marL="0">
+              <a:buNone/>
+            </a:pPr>
+            <a:r>
+              <a:rPr lang="en-US" sz="1600" b="1" dirty="0">
+                <a:solidFill>
+                  <a:srgbClr val="DC1A41"/>
+                </a:solidFill>
+              </a:rPr>
+              <a:t>84% ceiling</a:t>
+            </a:r>
+            <a:endParaRPr lang="en-US" sz="1600" dirty="0"/>
+          </a:p>
+        </p:txBody>
+      </p:sp>
+      <p:sp>
+        <p:nvSpPr>
+          <p:cNvPr id="26" name="Shape 24"/>
+          <p:cNvSpPr/>
+          <p:nvPr/>
+        </p:nvSpPr>
+        <p:spPr>
+          <a:xfrm>
+            <a:off x="365760" y="2834640"/>
+            <a:ext cx="1965960" cy="1280160"/>
+          </a:xfrm>
+          <a:prstGeom prst="rect">
+            <a:avLst/>
+          </a:prstGeom>
+          <a:solidFill>
+            <a:srgbClr val="FFFFFF"/>
+          </a:solidFill>
+          <a:ln w="12700">
+            <a:solidFill>
+              <a:srgbClr val="CCCCCC"/>
+            </a:solidFill>
+            <a:prstDash val="solid"/>
+          </a:ln>
+        </p:spPr>
+      </p:sp>
+      <p:sp>
+        <p:nvSpPr>
+          <p:cNvPr id="27" name="Shape 25"/>
+          <p:cNvSpPr/>
+          <p:nvPr/>
+        </p:nvSpPr>
+        <p:spPr>
+          <a:xfrm>
+            <a:off x="365760" y="2834640"/>
+            <a:ext cx="73152" cy="1280160"/>
+          </a:xfrm>
+          <a:prstGeom prst="rect">
+            <a:avLst/>
+          </a:prstGeom>
+          <a:solidFill>
+            <a:srgbClr val="DC1A41"/>
+          </a:solidFill>
+          <a:ln/>
+        </p:spPr>
+      </p:sp>
+      <p:sp>
+        <p:nvSpPr>
+          <p:cNvPr id="28" name="Text 26"/>
+          <p:cNvSpPr/>
+          <p:nvPr/>
+        </p:nvSpPr>
+        <p:spPr>
+          <a:xfrm>
+            <a:off x="475488" y="2944368"/>
             <a:ext cx="1783080" cy="228600"/>
           </a:xfrm>
           <a:prstGeom prst="rect">
@@ -16022,13 +16175,13 @@
       </p:sp>
       <p:sp>
         <p:nvSpPr>
-          <p:cNvPr id="24" name="Text 22"/>
-          <p:cNvSpPr/>
-          <p:nvPr/>
-        </p:nvSpPr>
-        <p:spPr>
-          <a:xfrm>
-            <a:off x="6647688" y="1737360"/>
+          <p:cNvPr id="29" name="Text 27"/>
+          <p:cNvSpPr/>
+          <p:nvPr/>
+        </p:nvSpPr>
+        <p:spPr>
+          <a:xfrm>
+            <a:off x="475488" y="3200400"/>
             <a:ext cx="1783080" cy="274320"/>
           </a:xfrm>
           <a:prstGeom prst="rect">
@@ -16058,13 +16211,13 @@
       </p:sp>
       <p:sp>
         <p:nvSpPr>
-          <p:cNvPr id="25" name="Text 23"/>
-          <p:cNvSpPr/>
-          <p:nvPr/>
-        </p:nvSpPr>
-        <p:spPr>
-          <a:xfrm>
-            <a:off x="6647688" y="2057400"/>
+          <p:cNvPr id="30" name="Text 28"/>
+          <p:cNvSpPr/>
+          <p:nvPr/>
+        </p:nvSpPr>
+        <p:spPr>
+          <a:xfrm>
+            <a:off x="475488" y="3520440"/>
             <a:ext cx="1783080" cy="320040"/>
           </a:xfrm>
           <a:prstGeom prst="rect">
@@ -16086,160 +16239,7 @@
                   <a:srgbClr val="DC1A41"/>
                 </a:solidFill>
               </a:rPr>
-              <a:t>81% ceiling</a:t>
-            </a:r>
-            <a:endParaRPr lang="en-US" sz="1600" dirty="0"/>
-          </a:p>
-        </p:txBody>
-      </p:sp>
-      <p:sp>
-        <p:nvSpPr>
-          <p:cNvPr id="26" name="Shape 24"/>
-          <p:cNvSpPr/>
-          <p:nvPr/>
-        </p:nvSpPr>
-        <p:spPr>
-          <a:xfrm>
-            <a:off x="365760" y="2834640"/>
-            <a:ext cx="1965960" cy="1280160"/>
-          </a:xfrm>
-          <a:prstGeom prst="rect">
-            <a:avLst/>
-          </a:prstGeom>
-          <a:solidFill>
-            <a:srgbClr val="FFFFFF"/>
-          </a:solidFill>
-          <a:ln w="12700">
-            <a:solidFill>
-              <a:srgbClr val="CCCCCC"/>
-            </a:solidFill>
-            <a:prstDash val="solid"/>
-          </a:ln>
-        </p:spPr>
-      </p:sp>
-      <p:sp>
-        <p:nvSpPr>
-          <p:cNvPr id="27" name="Shape 25"/>
-          <p:cNvSpPr/>
-          <p:nvPr/>
-        </p:nvSpPr>
-        <p:spPr>
-          <a:xfrm>
-            <a:off x="365760" y="2834640"/>
-            <a:ext cx="73152" cy="1280160"/>
-          </a:xfrm>
-          <a:prstGeom prst="rect">
-            <a:avLst/>
-          </a:prstGeom>
-          <a:solidFill>
-            <a:srgbClr val="DC1A41"/>
-          </a:solidFill>
-          <a:ln/>
-        </p:spPr>
-      </p:sp>
-      <p:sp>
-        <p:nvSpPr>
-          <p:cNvPr id="28" name="Text 26"/>
-          <p:cNvSpPr/>
-          <p:nvPr/>
-        </p:nvSpPr>
-        <p:spPr>
-          <a:xfrm>
-            <a:off x="475488" y="2944368"/>
-            <a:ext cx="1783080" cy="228600"/>
-          </a:xfrm>
-          <a:prstGeom prst="rect">
-            <a:avLst/>
-          </a:prstGeom>
-          <a:noFill/>
-          <a:ln/>
-        </p:spPr>
-        <p:txBody>
-          <a:bodyPr wrap="square" rtlCol="0" anchor="ctr"/>
-          <a:lstStyle/>
-          <a:p>
-            <a:pPr indent="0" marL="0">
-              <a:buNone/>
-            </a:pPr>
-            <a:r>
-              <a:rPr lang="en-US" sz="900" b="1" dirty="0">
-                <a:solidFill>
-                  <a:srgbClr val="2C2C2C"/>
-                </a:solidFill>
-              </a:rPr>
-              <a:t>Paul233365</a:t>
-            </a:r>
-            <a:endParaRPr lang="en-US" sz="900" dirty="0"/>
-          </a:p>
-        </p:txBody>
-      </p:sp>
-      <p:sp>
-        <p:nvSpPr>
-          <p:cNvPr id="29" name="Text 27"/>
-          <p:cNvSpPr/>
-          <p:nvPr/>
-        </p:nvSpPr>
-        <p:spPr>
-          <a:xfrm>
-            <a:off x="475488" y="3200400"/>
-            <a:ext cx="1783080" cy="274320"/>
-          </a:xfrm>
-          <a:prstGeom prst="rect">
-            <a:avLst/>
-          </a:prstGeom>
-          <a:noFill/>
-          <a:ln/>
-        </p:spPr>
-        <p:txBody>
-          <a:bodyPr wrap="square" rtlCol="0" anchor="ctr"/>
-          <a:lstStyle/>
-          <a:p>
-            <a:pPr indent="0" marL="0">
-              <a:buNone/>
-            </a:pPr>
-            <a:r>
-              <a:rPr lang="en-US" sz="800" dirty="0">
-                <a:solidFill>
-                  <a:srgbClr val="6B6B6B"/>
-                </a:solidFill>
-              </a:rPr>
-              <a:t>Arizona Wildcats</a:t>
-            </a:r>
-            <a:endParaRPr lang="en-US" sz="800" dirty="0"/>
-          </a:p>
-        </p:txBody>
-      </p:sp>
-      <p:sp>
-        <p:nvSpPr>
-          <p:cNvPr id="30" name="Text 28"/>
-          <p:cNvSpPr/>
-          <p:nvPr/>
-        </p:nvSpPr>
-        <p:spPr>
-          <a:xfrm>
-            <a:off x="475488" y="3520440"/>
-            <a:ext cx="1783080" cy="320040"/>
-          </a:xfrm>
-          <a:prstGeom prst="rect">
-            <a:avLst/>
-          </a:prstGeom>
-          <a:noFill/>
-          <a:ln/>
-        </p:spPr>
-        <p:txBody>
-          <a:bodyPr wrap="square" rtlCol="0" anchor="ctr"/>
-          <a:lstStyle/>
-          <a:p>
-            <a:pPr indent="0" marL="0">
-              <a:buNone/>
-            </a:pPr>
-            <a:r>
-              <a:rPr lang="en-US" sz="1600" b="1" dirty="0">
-                <a:solidFill>
-                  <a:srgbClr val="DC1A41"/>
-                </a:solidFill>
-              </a:rPr>
-              <a:t>86% ceiling</a:t>
+              <a:t>77% ceiling</a:t>
             </a:r>
             <a:endParaRPr lang="en-US" sz="1600" dirty="0"/>
           </a:p>
@@ -16392,7 +16392,7 @@
                   <a:srgbClr val="DC1A41"/>
                 </a:solidFill>
               </a:rPr>
-              <a:t>80% ceiling</a:t>
+              <a:t>90% ceiling</a:t>
             </a:r>
             <a:endParaRPr lang="en-US" sz="1600" dirty="0"/>
           </a:p>
@@ -16545,7 +16545,7 @@
                   <a:srgbClr val="DC1A41"/>
                 </a:solidFill>
               </a:rPr>
-              <a:t>79% ceiling</a:t>
+              <a:t>78% ceiling</a:t>
             </a:r>
             <a:endParaRPr lang="en-US" sz="1600" dirty="0"/>
           </a:p>
@@ -16698,7 +16698,7 @@
                   <a:srgbClr val="DC1A41"/>
                 </a:solidFill>
               </a:rPr>
-              <a:t>77% ceiling</a:t>
+              <a:t>82% ceiling</a:t>
             </a:r>
             <a:endParaRPr lang="en-US" sz="1600" dirty="0"/>
           </a:p>
@@ -16971,7 +16971,7 @@
         <p:spPr>
           <a:xfrm>
             <a:off x="8503920" y="987552"/>
-            <a:ext cx="6400800" cy="228600"/>
+            <a:ext cx="6306671" cy="228600"/>
           </a:xfrm>
           <a:prstGeom prst="rect">
             <a:avLst/>
@@ -16990,7 +16990,119 @@
         </p:nvSpPr>
         <p:spPr>
           <a:xfrm>
-            <a:off x="14996160" y="960120"/>
+            <a:off x="14902031" y="960120"/>
+            <a:ext cx="731520" cy="292608"/>
+          </a:xfrm>
+          <a:prstGeom prst="rect">
+            <a:avLst/>
+          </a:prstGeom>
+          <a:noFill/>
+          <a:ln/>
+        </p:spPr>
+        <p:txBody>
+          <a:bodyPr wrap="square" rtlCol="0" anchor="ctr"/>
+          <a:lstStyle/>
+          <a:p>
+            <a:pPr indent="0" marL="0">
+              <a:buNone/>
+            </a:pPr>
+            <a:r>
+              <a:rPr lang="en-US" sz="800" b="1" dirty="0">
+                <a:solidFill>
+                  <a:srgbClr val="2C2C2C"/>
+                </a:solidFill>
+              </a:rPr>
+              <a:t>1790</a:t>
+            </a:r>
+            <a:endParaRPr lang="en-US" sz="800" dirty="0"/>
+          </a:p>
+        </p:txBody>
+      </p:sp>
+      <p:sp>
+        <p:nvSpPr>
+          <p:cNvPr id="9" name="Text 7"/>
+          <p:cNvSpPr/>
+          <p:nvPr/>
+        </p:nvSpPr>
+        <p:spPr>
+          <a:xfrm>
+            <a:off x="365760" y="1344168"/>
+            <a:ext cx="1645920" cy="292608"/>
+          </a:xfrm>
+          <a:prstGeom prst="rect">
+            <a:avLst/>
+          </a:prstGeom>
+          <a:noFill/>
+          <a:ln/>
+        </p:spPr>
+        <p:txBody>
+          <a:bodyPr wrap="square" rtlCol="0" anchor="ctr"/>
+          <a:lstStyle/>
+          <a:p>
+            <a:pPr algn="r" indent="0" marL="0">
+              <a:buNone/>
+            </a:pPr>
+            <a:r>
+              <a:rPr lang="en-US" sz="800" dirty="0">
+                <a:solidFill>
+                  <a:srgbClr val="2C2C2C"/>
+                </a:solidFill>
+              </a:rPr>
+              <a:t>Capn'Kirk</a:t>
+            </a:r>
+            <a:endParaRPr lang="en-US" sz="800" dirty="0"/>
+          </a:p>
+        </p:txBody>
+      </p:sp>
+      <p:sp>
+        <p:nvSpPr>
+          <p:cNvPr id="10" name="Shape 8"/>
+          <p:cNvSpPr/>
+          <p:nvPr/>
+        </p:nvSpPr>
+        <p:spPr>
+          <a:xfrm>
+            <a:off x="2103120" y="1371600"/>
+            <a:ext cx="6116320" cy="228600"/>
+          </a:xfrm>
+          <a:prstGeom prst="rect">
+            <a:avLst/>
+          </a:prstGeom>
+          <a:solidFill>
+            <a:srgbClr val="2B5A7E"/>
+          </a:solidFill>
+          <a:ln/>
+        </p:spPr>
+      </p:sp>
+      <p:sp>
+        <p:nvSpPr>
+          <p:cNvPr id="11" name="Shape 9"/>
+          <p:cNvSpPr/>
+          <p:nvPr/>
+        </p:nvSpPr>
+        <p:spPr>
+          <a:xfrm>
+            <a:off x="8219440" y="1371600"/>
+            <a:ext cx="6494929" cy="228600"/>
+          </a:xfrm>
+          <a:prstGeom prst="rect">
+            <a:avLst/>
+          </a:prstGeom>
+          <a:solidFill>
+            <a:srgbClr val="E0E0E0"/>
+          </a:solidFill>
+          <a:ln/>
+        </p:spPr>
+      </p:sp>
+      <p:sp>
+        <p:nvSpPr>
+          <p:cNvPr id="12" name="Text 10"/>
+          <p:cNvSpPr/>
+          <p:nvPr/>
+        </p:nvSpPr>
+        <p:spPr>
+          <a:xfrm>
+            <a:off x="14805809" y="1344168"/>
             <a:ext cx="731520" cy="292608"/>
           </a:xfrm>
           <a:prstGeom prst="rect">
@@ -17020,118 +17132,6 @@
       </p:sp>
       <p:sp>
         <p:nvSpPr>
-          <p:cNvPr id="9" name="Text 7"/>
-          <p:cNvSpPr/>
-          <p:nvPr/>
-        </p:nvSpPr>
-        <p:spPr>
-          <a:xfrm>
-            <a:off x="365760" y="1344168"/>
-            <a:ext cx="1645920" cy="292608"/>
-          </a:xfrm>
-          <a:prstGeom prst="rect">
-            <a:avLst/>
-          </a:prstGeom>
-          <a:noFill/>
-          <a:ln/>
-        </p:spPr>
-        <p:txBody>
-          <a:bodyPr wrap="square" rtlCol="0" anchor="ctr"/>
-          <a:lstStyle/>
-          <a:p>
-            <a:pPr algn="r" indent="0" marL="0">
-              <a:buNone/>
-            </a:pPr>
-            <a:r>
-              <a:rPr lang="en-US" sz="800" dirty="0">
-                <a:solidFill>
-                  <a:srgbClr val="2C2C2C"/>
-                </a:solidFill>
-              </a:rPr>
-              <a:t>Capn'Kirk</a:t>
-            </a:r>
-            <a:endParaRPr lang="en-US" sz="800" dirty="0"/>
-          </a:p>
-        </p:txBody>
-      </p:sp>
-      <p:sp>
-        <p:nvSpPr>
-          <p:cNvPr id="10" name="Shape 8"/>
-          <p:cNvSpPr/>
-          <p:nvPr/>
-        </p:nvSpPr>
-        <p:spPr>
-          <a:xfrm>
-            <a:off x="2103120" y="1371600"/>
-            <a:ext cx="5831840" cy="228600"/>
-          </a:xfrm>
-          <a:prstGeom prst="rect">
-            <a:avLst/>
-          </a:prstGeom>
-          <a:solidFill>
-            <a:srgbClr val="2B5A7E"/>
-          </a:solidFill>
-          <a:ln/>
-        </p:spPr>
-      </p:sp>
-      <p:sp>
-        <p:nvSpPr>
-          <p:cNvPr id="11" name="Shape 9"/>
-          <p:cNvSpPr/>
-          <p:nvPr/>
-        </p:nvSpPr>
-        <p:spPr>
-          <a:xfrm>
-            <a:off x="7934960" y="1371600"/>
-            <a:ext cx="6589059" cy="228600"/>
-          </a:xfrm>
-          <a:prstGeom prst="rect">
-            <a:avLst/>
-          </a:prstGeom>
-          <a:solidFill>
-            <a:srgbClr val="E0E0E0"/>
-          </a:solidFill>
-          <a:ln/>
-        </p:spPr>
-      </p:sp>
-      <p:sp>
-        <p:nvSpPr>
-          <p:cNvPr id="12" name="Text 10"/>
-          <p:cNvSpPr/>
-          <p:nvPr/>
-        </p:nvSpPr>
-        <p:spPr>
-          <a:xfrm>
-            <a:off x="14615459" y="1344168"/>
-            <a:ext cx="731520" cy="292608"/>
-          </a:xfrm>
-          <a:prstGeom prst="rect">
-            <a:avLst/>
-          </a:prstGeom>
-          <a:noFill/>
-          <a:ln/>
-        </p:spPr>
-        <p:txBody>
-          <a:bodyPr wrap="square" rtlCol="0" anchor="ctr"/>
-          <a:lstStyle/>
-          <a:p>
-            <a:pPr indent="0" marL="0">
-              <a:buNone/>
-            </a:pPr>
-            <a:r>
-              <a:rPr lang="en-US" sz="800" b="1" dirty="0">
-                <a:solidFill>
-                  <a:srgbClr val="2C2C2C"/>
-                </a:solidFill>
-              </a:rPr>
-              <a:t>1810</a:t>
-            </a:r>
-            <a:endParaRPr lang="en-US" sz="800" dirty="0"/>
-          </a:p>
-        </p:txBody>
-      </p:sp>
-      <p:sp>
-        <p:nvSpPr>
           <p:cNvPr id="13" name="Text 11"/>
           <p:cNvSpPr/>
           <p:nvPr/>
@@ -17175,7 +17175,7 @@
         <p:spPr>
           <a:xfrm>
             <a:off x="2103120" y="1755648"/>
-            <a:ext cx="5689600" cy="228600"/>
+            <a:ext cx="5974080" cy="228600"/>
           </a:xfrm>
           <a:prstGeom prst="rect">
             <a:avLst/>
@@ -17194,8 +17194,8 @@
         </p:nvSpPr>
         <p:spPr>
           <a:xfrm>
-            <a:off x="7792720" y="1755648"/>
-            <a:ext cx="6400800" cy="228600"/>
+            <a:off x="8077200" y="1755648"/>
+            <a:ext cx="6306671" cy="228600"/>
           </a:xfrm>
           <a:prstGeom prst="rect">
             <a:avLst/>
@@ -17214,7 +17214,7 @@
         </p:nvSpPr>
         <p:spPr>
           <a:xfrm>
-            <a:off x="14284960" y="1728216"/>
+            <a:off x="14475311" y="1728216"/>
             <a:ext cx="731520" cy="292608"/>
           </a:xfrm>
           <a:prstGeom prst="rect">
@@ -17272,6 +17272,118 @@
                   <a:srgbClr val="2C2C2C"/>
                 </a:solidFill>
               </a:rPr>
+              <a:t>Paul233365</a:t>
+            </a:r>
+            <a:endParaRPr lang="en-US" sz="800" dirty="0"/>
+          </a:p>
+        </p:txBody>
+      </p:sp>
+      <p:sp>
+        <p:nvSpPr>
+          <p:cNvPr id="18" name="Shape 16"/>
+          <p:cNvSpPr/>
+          <p:nvPr/>
+        </p:nvSpPr>
+        <p:spPr>
+          <a:xfrm>
+            <a:off x="2103120" y="2139696"/>
+            <a:ext cx="5689600" cy="228600"/>
+          </a:xfrm>
+          <a:prstGeom prst="rect">
+            <a:avLst/>
+          </a:prstGeom>
+          <a:solidFill>
+            <a:srgbClr val="2B5A7E"/>
+          </a:solidFill>
+          <a:ln/>
+        </p:spPr>
+      </p:sp>
+      <p:sp>
+        <p:nvSpPr>
+          <p:cNvPr id="19" name="Shape 17"/>
+          <p:cNvSpPr/>
+          <p:nvPr/>
+        </p:nvSpPr>
+        <p:spPr>
+          <a:xfrm>
+            <a:off x="7792720" y="2139696"/>
+            <a:ext cx="6494929" cy="228600"/>
+          </a:xfrm>
+          <a:prstGeom prst="rect">
+            <a:avLst/>
+          </a:prstGeom>
+          <a:solidFill>
+            <a:srgbClr val="E0E0E0"/>
+          </a:solidFill>
+          <a:ln/>
+        </p:spPr>
+      </p:sp>
+      <p:sp>
+        <p:nvSpPr>
+          <p:cNvPr id="20" name="Text 18"/>
+          <p:cNvSpPr/>
+          <p:nvPr/>
+        </p:nvSpPr>
+        <p:spPr>
+          <a:xfrm>
+            <a:off x="14379089" y="2112264"/>
+            <a:ext cx="731520" cy="292608"/>
+          </a:xfrm>
+          <a:prstGeom prst="rect">
+            <a:avLst/>
+          </a:prstGeom>
+          <a:noFill/>
+          <a:ln/>
+        </p:spPr>
+        <p:txBody>
+          <a:bodyPr wrap="square" rtlCol="0" anchor="ctr"/>
+          <a:lstStyle/>
+          <a:p>
+            <a:pPr indent="0" marL="0">
+              <a:buNone/>
+            </a:pPr>
+            <a:r>
+              <a:rPr lang="en-US" sz="800" b="1" dirty="0">
+                <a:solidFill>
+                  <a:srgbClr val="2C2C2C"/>
+                </a:solidFill>
+              </a:rPr>
+              <a:t>1780</a:t>
+            </a:r>
+            <a:endParaRPr lang="en-US" sz="800" dirty="0"/>
+          </a:p>
+        </p:txBody>
+      </p:sp>
+      <p:sp>
+        <p:nvSpPr>
+          <p:cNvPr id="21" name="Text 19"/>
+          <p:cNvSpPr/>
+          <p:nvPr/>
+        </p:nvSpPr>
+        <p:spPr>
+          <a:xfrm>
+            <a:off x="365760" y="2496312"/>
+            <a:ext cx="1645920" cy="292608"/>
+          </a:xfrm>
+          <a:prstGeom prst="rect">
+            <a:avLst/>
+          </a:prstGeom>
+          <a:noFill/>
+          <a:ln/>
+        </p:spPr>
+        <p:txBody>
+          <a:bodyPr wrap="square" rtlCol="0" anchor="ctr"/>
+          <a:lstStyle/>
+          <a:p>
+            <a:pPr algn="r" indent="0" marL="0">
+              <a:buNone/>
+            </a:pPr>
+            <a:r>
+              <a:rPr lang="en-US" sz="800" dirty="0">
+                <a:solidFill>
+                  <a:srgbClr val="2C2C2C"/>
+                </a:solidFill>
+              </a:rPr>
               <a:t>twnutt</a:t>
             </a:r>
             <a:endParaRPr lang="en-US" sz="800" dirty="0"/>
@@ -17280,13 +17392,13 @@
       </p:sp>
       <p:sp>
         <p:nvSpPr>
-          <p:cNvPr id="18" name="Shape 16"/>
-          <p:cNvSpPr/>
-          <p:nvPr/>
-        </p:nvSpPr>
-        <p:spPr>
-          <a:xfrm>
-            <a:off x="2103120" y="2139696"/>
+          <p:cNvPr id="22" name="Shape 20"/>
+          <p:cNvSpPr/>
+          <p:nvPr/>
+        </p:nvSpPr>
+        <p:spPr>
+          <a:xfrm>
+            <a:off x="2103120" y="2523744"/>
             <a:ext cx="5547360" cy="228600"/>
           </a:xfrm>
           <a:prstGeom prst="rect">
@@ -17300,13 +17412,13 @@
       </p:sp>
       <p:sp>
         <p:nvSpPr>
-          <p:cNvPr id="19" name="Shape 17"/>
-          <p:cNvSpPr/>
-          <p:nvPr/>
-        </p:nvSpPr>
-        <p:spPr>
-          <a:xfrm>
-            <a:off x="7650480" y="2139696"/>
+          <p:cNvPr id="23" name="Shape 21"/>
+          <p:cNvSpPr/>
+          <p:nvPr/>
+        </p:nvSpPr>
+        <p:spPr>
+          <a:xfrm>
+            <a:off x="7650480" y="2523744"/>
             <a:ext cx="6494929" cy="228600"/>
           </a:xfrm>
           <a:prstGeom prst="rect">
@@ -17320,13 +17432,13 @@
       </p:sp>
       <p:sp>
         <p:nvSpPr>
-          <p:cNvPr id="20" name="Text 18"/>
-          <p:cNvSpPr/>
-          <p:nvPr/>
-        </p:nvSpPr>
-        <p:spPr>
-          <a:xfrm>
-            <a:off x="14236849" y="2112264"/>
+          <p:cNvPr id="24" name="Text 22"/>
+          <p:cNvSpPr/>
+          <p:nvPr/>
+        </p:nvSpPr>
+        <p:spPr>
+          <a:xfrm>
+            <a:off x="14236849" y="2496312"/>
             <a:ext cx="731520" cy="292608"/>
           </a:xfrm>
           <a:prstGeom prst="rect">
@@ -17349,118 +17461,6 @@
                 </a:solidFill>
               </a:rPr>
               <a:t>1770</a:t>
-            </a:r>
-            <a:endParaRPr lang="en-US" sz="800" dirty="0"/>
-          </a:p>
-        </p:txBody>
-      </p:sp>
-      <p:sp>
-        <p:nvSpPr>
-          <p:cNvPr id="21" name="Text 19"/>
-          <p:cNvSpPr/>
-          <p:nvPr/>
-        </p:nvSpPr>
-        <p:spPr>
-          <a:xfrm>
-            <a:off x="365760" y="2496312"/>
-            <a:ext cx="1645920" cy="292608"/>
-          </a:xfrm>
-          <a:prstGeom prst="rect">
-            <a:avLst/>
-          </a:prstGeom>
-          <a:noFill/>
-          <a:ln/>
-        </p:spPr>
-        <p:txBody>
-          <a:bodyPr wrap="square" rtlCol="0" anchor="ctr"/>
-          <a:lstStyle/>
-          <a:p>
-            <a:pPr algn="r" indent="0" marL="0">
-              <a:buNone/>
-            </a:pPr>
-            <a:r>
-              <a:rPr lang="en-US" sz="800" dirty="0">
-                <a:solidFill>
-                  <a:srgbClr val="2C2C2C"/>
-                </a:solidFill>
-              </a:rPr>
-              <a:t>Paul233365</a:t>
-            </a:r>
-            <a:endParaRPr lang="en-US" sz="800" dirty="0"/>
-          </a:p>
-        </p:txBody>
-      </p:sp>
-      <p:sp>
-        <p:nvSpPr>
-          <p:cNvPr id="22" name="Shape 20"/>
-          <p:cNvSpPr/>
-          <p:nvPr/>
-        </p:nvSpPr>
-        <p:spPr>
-          <a:xfrm>
-            <a:off x="2103120" y="2523744"/>
-            <a:ext cx="5405120" cy="228600"/>
-          </a:xfrm>
-          <a:prstGeom prst="rect">
-            <a:avLst/>
-          </a:prstGeom>
-          <a:solidFill>
-            <a:srgbClr val="2B5A7E"/>
-          </a:solidFill>
-          <a:ln/>
-        </p:spPr>
-      </p:sp>
-      <p:sp>
-        <p:nvSpPr>
-          <p:cNvPr id="23" name="Shape 21"/>
-          <p:cNvSpPr/>
-          <p:nvPr/>
-        </p:nvSpPr>
-        <p:spPr>
-          <a:xfrm>
-            <a:off x="7508240" y="2523744"/>
-            <a:ext cx="6589059" cy="228600"/>
-          </a:xfrm>
-          <a:prstGeom prst="rect">
-            <a:avLst/>
-          </a:prstGeom>
-          <a:solidFill>
-            <a:srgbClr val="E0E0E0"/>
-          </a:solidFill>
-          <a:ln/>
-        </p:spPr>
-      </p:sp>
-      <p:sp>
-        <p:nvSpPr>
-          <p:cNvPr id="24" name="Text 22"/>
-          <p:cNvSpPr/>
-          <p:nvPr/>
-        </p:nvSpPr>
-        <p:spPr>
-          <a:xfrm>
-            <a:off x="14188739" y="2496312"/>
-            <a:ext cx="731520" cy="292608"/>
-          </a:xfrm>
-          <a:prstGeom prst="rect">
-            <a:avLst/>
-          </a:prstGeom>
-          <a:noFill/>
-          <a:ln/>
-        </p:spPr>
-        <p:txBody>
-          <a:bodyPr wrap="square" rtlCol="0" anchor="ctr"/>
-          <a:lstStyle/>
-          <a:p>
-            <a:pPr indent="0" marL="0">
-              <a:buNone/>
-            </a:pPr>
-            <a:r>
-              <a:rPr lang="en-US" sz="800" b="1" dirty="0">
-                <a:solidFill>
-                  <a:srgbClr val="2C2C2C"/>
-                </a:solidFill>
-              </a:rPr>
-              <a:t>1780</a:t>
             </a:r>
             <a:endParaRPr lang="en-US" sz="800" dirty="0"/>
           </a:p>
@@ -18591,7 +18591,7 @@
                 <a:ea typeface="Arial" pitchFamily="34" charset="-122"/>
                 <a:cs typeface="Arial" pitchFamily="34" charset="-120"/>
               </a:rPr>
-              <a:t>+40</a:t>
+              <a:t>+20</a:t>
             </a:r>
             <a:endParaRPr lang="en-US" sz="1600" dirty="0"/>
           </a:p>
@@ -19063,7 +19063,7 @@
                 <a:ea typeface="Arial" pitchFamily="34" charset="-122"/>
                 <a:cs typeface="Arial" pitchFamily="34" charset="-120"/>
               </a:rPr>
-              <a:t>TaylorDuran holds a commanding 40-point lead with Arizona as champion pick. Capn'Kirk stays close with Duke. Both leaders have strong remaining upside potential in Sweet 16+ rounds.</a:t>
+              <a:t>TaylorDuran clings to a narrow 20-point lead with Arizona as champion pick. Capn'Kirk surged in R32 and is breathing down his neck with Duke. The Sweet 16 will be decisive.</a:t>
             </a:r>
             <a:endParaRPr lang="en-US" sz="1000" dirty="0"/>
           </a:p>
@@ -19559,7 +19559,7 @@
                             <a:srgbClr val="2C2C2C"/>
                           </a:solidFill>
                         </a:rPr>
-                        <a:t>99.4%</a:t>
+                        <a:t>97.5%</a:t>
                       </a:r>
                       <a:endParaRPr lang="en-US" sz="900" dirty="0"/>
                     </a:p>
@@ -19735,7 +19735,7 @@
                             <a:srgbClr val="2C2C2C"/>
                           </a:solidFill>
                         </a:rPr>
-                        <a:t>410</a:t>
+                        <a:t>430</a:t>
                       </a:r>
                       <a:endParaRPr lang="en-US" sz="900" dirty="0"/>
                     </a:p>
@@ -19793,7 +19793,7 @@
                             <a:srgbClr val="2C2C2C"/>
                           </a:solidFill>
                         </a:rPr>
-                        <a:t>80.7%</a:t>
+                        <a:t>88.0%</a:t>
                       </a:r>
                       <a:endParaRPr lang="en-US" sz="900" dirty="0"/>
                     </a:p>
@@ -19969,7 +19969,7 @@
                             <a:srgbClr val="2C2C2C"/>
                           </a:solidFill>
                         </a:rPr>
-                        <a:t>400</a:t>
+                        <a:t>420</a:t>
                       </a:r>
                       <a:endParaRPr lang="en-US" sz="900" dirty="0"/>
                     </a:p>
@@ -20027,7 +20027,7 @@
                             <a:srgbClr val="2C2C2C"/>
                           </a:solidFill>
                         </a:rPr>
-                        <a:t>71.0%</a:t>
+                        <a:t>79.9%</a:t>
                       </a:r>
                       <a:endParaRPr lang="en-US" sz="900" dirty="0"/>
                     </a:p>
@@ -20145,7 +20145,7 @@
                             <a:srgbClr val="2C2C2C"/>
                           </a:solidFill>
                         </a:rPr>
-                        <a:t>twnutt</a:t>
+                        <a:t>Paul233365</a:t>
                       </a:r>
                       <a:endParaRPr lang="en-US" sz="900" dirty="0"/>
                     </a:p>
@@ -20203,7 +20203,7 @@
                             <a:srgbClr val="2C2C2C"/>
                           </a:solidFill>
                         </a:rPr>
-                        <a:t>390</a:t>
+                        <a:t>400</a:t>
                       </a:r>
                       <a:endParaRPr lang="en-US" sz="900" dirty="0"/>
                     </a:p>
@@ -20261,7 +20261,7 @@
                             <a:srgbClr val="2C2C2C"/>
                           </a:solidFill>
                         </a:rPr>
-                        <a:t>61.7%</a:t>
+                        <a:t>61.0%</a:t>
                       </a:r>
                       <a:endParaRPr lang="en-US" sz="900" dirty="0"/>
                     </a:p>
@@ -20379,7 +20379,7 @@
                             <a:srgbClr val="2C2C2C"/>
                           </a:solidFill>
                         </a:rPr>
-                        <a:t>Paul233365</a:t>
+                        <a:t>twnutt</a:t>
                       </a:r>
                       <a:endParaRPr lang="en-US" sz="900" dirty="0"/>
                     </a:p>
@@ -20437,7 +20437,7 @@
                             <a:srgbClr val="2C2C2C"/>
                           </a:solidFill>
                         </a:rPr>
-                        <a:t>380</a:t>
+                        <a:t>390</a:t>
                       </a:r>
                       <a:endParaRPr lang="en-US" sz="900" dirty="0"/>
                     </a:p>
@@ -20495,7 +20495,7 @@
                             <a:srgbClr val="2C2C2C"/>
                           </a:solidFill>
                         </a:rPr>
-                        <a:t>52.7%</a:t>
+                        <a:t>52.6%</a:t>
                       </a:r>
                       <a:endParaRPr lang="en-US" sz="900" dirty="0"/>
                     </a:p>
@@ -20729,7 +20729,7 @@
                             <a:srgbClr val="2C2C2C"/>
                           </a:solidFill>
                         </a:rPr>
-                        <a:t>24.4%</a:t>
+                        <a:t>21.1%</a:t>
                       </a:r>
                       <a:endParaRPr lang="en-US" sz="900" dirty="0"/>
                     </a:p>
@@ -20789,7 +20789,7 @@
                             <a:srgbClr val="2C2C2C"/>
                           </a:solidFill>
                         </a:rPr>
-                        <a:t>7</a:t>
+                        <a:t>6</a:t>
                       </a:r>
                       <a:endParaRPr lang="en-US" sz="900" dirty="0"/>
                     </a:p>
@@ -20963,7 +20963,7 @@
                             <a:srgbClr val="2C2C2C"/>
                           </a:solidFill>
                         </a:rPr>
-                        <a:t>24.4%</a:t>
+                        <a:t>21.1%</a:t>
                       </a:r>
                       <a:endParaRPr lang="en-US" sz="900" dirty="0"/>
                     </a:p>
@@ -21842,7 +21842,7 @@
                             <a:srgbClr val="2C2C2C"/>
                           </a:solidFill>
                         </a:rPr>
-                        <a:t>1810</a:t>
+                        <a:t>1790</a:t>
                       </a:r>
                       <a:endParaRPr lang="en-US" sz="900" dirty="0"/>
                     </a:p>
@@ -21958,7 +21958,7 @@
                             <a:srgbClr val="2C2C2C"/>
                           </a:solidFill>
                         </a:rPr>
-                        <a:t>6</a:t>
+                        <a:t>7</a:t>
                       </a:r>
                       <a:endParaRPr lang="en-US" sz="900" dirty="0"/>
                     </a:p>
@@ -22192,7 +22192,7 @@
                             <a:srgbClr val="2C2C2C"/>
                           </a:solidFill>
                         </a:rPr>
-                        <a:t>410</a:t>
+                        <a:t>430</a:t>
                       </a:r>
                       <a:endParaRPr lang="en-US" sz="900" dirty="0"/>
                     </a:p>
@@ -22308,7 +22308,7 @@
                             <a:srgbClr val="2C2C2C"/>
                           </a:solidFill>
                         </a:rPr>
-                        <a:t>33</a:t>
+                        <a:t>34</a:t>
                       </a:r>
                       <a:endParaRPr lang="en-US" sz="900" dirty="0"/>
                     </a:p>
@@ -22600,7 +22600,7 @@
                             <a:srgbClr val="2C2C2C"/>
                           </a:solidFill>
                         </a:rPr>
-                        <a:t>400</a:t>
+                        <a:t>420</a:t>
                       </a:r>
                       <a:endParaRPr lang="en-US" sz="900" dirty="0"/>
                     </a:p>
@@ -22716,7 +22716,7 @@
                             <a:srgbClr val="2C2C2C"/>
                           </a:solidFill>
                         </a:rPr>
-                        <a:t>33</a:t>
+                        <a:t>34</a:t>
                       </a:r>
                       <a:endParaRPr lang="en-US" sz="900" dirty="0"/>
                     </a:p>
@@ -22950,7 +22950,7 @@
                             <a:srgbClr val="2C2C2C"/>
                           </a:solidFill>
                         </a:rPr>
-                        <a:t>twnutt</a:t>
+                        <a:t>Paul233365</a:t>
                       </a:r>
                       <a:endParaRPr lang="en-US" sz="900" dirty="0"/>
                     </a:p>
@@ -23008,7 +23008,7 @@
                             <a:srgbClr val="2C2C2C"/>
                           </a:solidFill>
                         </a:rPr>
-                        <a:t>390</a:t>
+                        <a:t>400</a:t>
                       </a:r>
                       <a:endParaRPr lang="en-US" sz="900" dirty="0"/>
                     </a:p>
@@ -23066,7 +23066,7 @@
                             <a:srgbClr val="2C2C2C"/>
                           </a:solidFill>
                         </a:rPr>
-                        <a:t>1770</a:t>
+                        <a:t>1780</a:t>
                       </a:r>
                       <a:endParaRPr lang="en-US" sz="900" dirty="0"/>
                     </a:p>
@@ -23124,7 +23124,7 @@
                             <a:srgbClr val="2C2C2C"/>
                           </a:solidFill>
                         </a:rPr>
-                        <a:t>31</a:t>
+                        <a:t>32</a:t>
                       </a:r>
                       <a:endParaRPr lang="en-US" sz="900" dirty="0"/>
                     </a:p>
@@ -23182,7 +23182,7 @@
                             <a:srgbClr val="2C2C2C"/>
                           </a:solidFill>
                         </a:rPr>
-                        <a:t>12</a:t>
+                        <a:t>11</a:t>
                       </a:r>
                       <a:endParaRPr lang="en-US" sz="900" dirty="0"/>
                     </a:p>
@@ -23240,7 +23240,7 @@
                             <a:srgbClr val="2C2C2C"/>
                           </a:solidFill>
                         </a:rPr>
-                        <a:t>Duke Blue Devils</a:t>
+                        <a:t>Arizona Wildcats</a:t>
                       </a:r>
                       <a:endParaRPr lang="en-US" sz="900" dirty="0"/>
                     </a:p>
@@ -23358,7 +23358,7 @@
                             <a:srgbClr val="2C2C2C"/>
                           </a:solidFill>
                         </a:rPr>
-                        <a:t>Paul233365</a:t>
+                        <a:t>twnutt</a:t>
                       </a:r>
                       <a:endParaRPr lang="en-US" sz="900" dirty="0"/>
                     </a:p>
@@ -23416,7 +23416,7 @@
                             <a:srgbClr val="2C2C2C"/>
                           </a:solidFill>
                         </a:rPr>
-                        <a:t>380</a:t>
+                        <a:t>390</a:t>
                       </a:r>
                       <a:endParaRPr lang="en-US" sz="900" dirty="0"/>
                     </a:p>
@@ -23474,7 +23474,7 @@
                             <a:srgbClr val="2C2C2C"/>
                           </a:solidFill>
                         </a:rPr>
-                        <a:t>1780</a:t>
+                        <a:t>1770</a:t>
                       </a:r>
                       <a:endParaRPr lang="en-US" sz="900" dirty="0"/>
                     </a:p>
@@ -23590,7 +23590,7 @@
                             <a:srgbClr val="2C2C2C"/>
                           </a:solidFill>
                         </a:rPr>
-                        <a:t>11</a:t>
+                        <a:t>13</a:t>
                       </a:r>
                       <a:endParaRPr lang="en-US" sz="900" dirty="0"/>
                     </a:p>
@@ -23648,7 +23648,7 @@
                             <a:srgbClr val="2C2C2C"/>
                           </a:solidFill>
                         </a:rPr>
-                        <a:t>Arizona Wildcats</a:t>
+                        <a:t>Duke Blue Devils</a:t>
                       </a:r>
                       <a:endParaRPr lang="en-US" sz="900" dirty="0"/>
                     </a:p>
@@ -23998,7 +23998,7 @@
                             <a:srgbClr val="2C2C2C"/>
                           </a:solidFill>
                         </a:rPr>
-                        <a:t>16</a:t>
+                        <a:t>17</a:t>
                       </a:r>
                       <a:endParaRPr lang="en-US" sz="900" dirty="0"/>
                     </a:p>
@@ -24116,7 +24116,7 @@
                             <a:srgbClr val="2C2C2C"/>
                           </a:solidFill>
                         </a:rPr>
-                        <a:t>7</a:t>
+                        <a:t>6</a:t>
                       </a:r>
                       <a:endParaRPr lang="en-US" sz="900" dirty="0"/>
                     </a:p>
@@ -24406,7 +24406,7 @@
                             <a:srgbClr val="2C2C2C"/>
                           </a:solidFill>
                         </a:rPr>
-                        <a:t>17</a:t>
+                        <a:t>18</a:t>
                       </a:r>
                       <a:endParaRPr lang="en-US" sz="900" dirty="0"/>
                     </a:p>
@@ -24814,7 +24814,7 @@
                             <a:srgbClr val="2C2C2C"/>
                           </a:solidFill>
                         </a:rPr>
-                        <a:t>16</a:t>
+                        <a:t>17</a:t>
                       </a:r>
                       <a:endParaRPr lang="en-US" sz="900" dirty="0"/>
                     </a:p>
@@ -25195,7 +25195,7 @@
                 <a:ea typeface="Arial" pitchFamily="34" charset="-122"/>
                 <a:cs typeface="Arial" pitchFamily="34" charset="-120"/>
               </a:rPr>
-              <a:t>A 40-point gap with both leaders still alive. Next round predictions will determine if the lead holds or tightens.</a:t>
+              <a:t>Only a 20-point gap after Capn'Kirk surged in R32. Sweet 16 picks will determine if TaylorDuran holds or gets overtaken.</a:t>
             </a:r>
             <a:endParaRPr lang="en-US" sz="900" dirty="0"/>
           </a:p>
@@ -25774,7 +25774,7 @@
         <p:spPr>
           <a:xfrm>
             <a:off x="2103120" y="1371600"/>
-            <a:ext cx="5831840" cy="228600"/>
+            <a:ext cx="6116320" cy="228600"/>
           </a:xfrm>
           <a:prstGeom prst="rect">
             <a:avLst/>
@@ -25793,7 +25793,7 @@
         </p:nvSpPr>
         <p:spPr>
           <a:xfrm>
-            <a:off x="8026400" y="1344168"/>
+            <a:off x="8310880" y="1344168"/>
             <a:ext cx="548640" cy="292608"/>
           </a:xfrm>
           <a:prstGeom prst="rect">
@@ -25815,7 +25815,7 @@
                   <a:srgbClr val="2C2C2C"/>
                 </a:solidFill>
               </a:rPr>
-              <a:t>410</a:t>
+              <a:t>430</a:t>
             </a:r>
             <a:endParaRPr lang="en-US" sz="800" dirty="0"/>
           </a:p>
@@ -25866,7 +25866,7 @@
         <p:spPr>
           <a:xfrm>
             <a:off x="2103120" y="1755648"/>
-            <a:ext cx="5689600" cy="228600"/>
+            <a:ext cx="5974080" cy="228600"/>
           </a:xfrm>
           <a:prstGeom prst="rect">
             <a:avLst/>
@@ -25885,7 +25885,99 @@
         </p:nvSpPr>
         <p:spPr>
           <a:xfrm>
-            <a:off x="7884160" y="1728216"/>
+            <a:off x="8168640" y="1728216"/>
+            <a:ext cx="548640" cy="292608"/>
+          </a:xfrm>
+          <a:prstGeom prst="rect">
+            <a:avLst/>
+          </a:prstGeom>
+          <a:noFill/>
+          <a:ln/>
+        </p:spPr>
+        <p:txBody>
+          <a:bodyPr wrap="square" rtlCol="0" anchor="ctr"/>
+          <a:lstStyle/>
+          <a:p>
+            <a:pPr indent="0" marL="0">
+              <a:buNone/>
+            </a:pPr>
+            <a:r>
+              <a:rPr lang="en-US" sz="800" b="1" dirty="0">
+                <a:solidFill>
+                  <a:srgbClr val="2C2C2C"/>
+                </a:solidFill>
+              </a:rPr>
+              <a:t>420</a:t>
+            </a:r>
+            <a:endParaRPr lang="en-US" sz="800" dirty="0"/>
+          </a:p>
+        </p:txBody>
+      </p:sp>
+      <p:sp>
+        <p:nvSpPr>
+          <p:cNvPr id="14" name="Text 12"/>
+          <p:cNvSpPr/>
+          <p:nvPr/>
+        </p:nvSpPr>
+        <p:spPr>
+          <a:xfrm>
+            <a:off x="365760" y="2112264"/>
+            <a:ext cx="1645920" cy="292608"/>
+          </a:xfrm>
+          <a:prstGeom prst="rect">
+            <a:avLst/>
+          </a:prstGeom>
+          <a:noFill/>
+          <a:ln/>
+        </p:spPr>
+        <p:txBody>
+          <a:bodyPr wrap="square" rtlCol="0" anchor="ctr"/>
+          <a:lstStyle/>
+          <a:p>
+            <a:pPr algn="r" indent="0" marL="0">
+              <a:buNone/>
+            </a:pPr>
+            <a:r>
+              <a:rPr lang="en-US" sz="800" dirty="0">
+                <a:solidFill>
+                  <a:srgbClr val="2C2C2C"/>
+                </a:solidFill>
+              </a:rPr>
+              <a:t>Paul233365</a:t>
+            </a:r>
+            <a:endParaRPr lang="en-US" sz="800" dirty="0"/>
+          </a:p>
+        </p:txBody>
+      </p:sp>
+      <p:sp>
+        <p:nvSpPr>
+          <p:cNvPr id="15" name="Shape 13"/>
+          <p:cNvSpPr/>
+          <p:nvPr/>
+        </p:nvSpPr>
+        <p:spPr>
+          <a:xfrm>
+            <a:off x="2103120" y="2139696"/>
+            <a:ext cx="5689600" cy="228600"/>
+          </a:xfrm>
+          <a:prstGeom prst="rect">
+            <a:avLst/>
+          </a:prstGeom>
+          <a:solidFill>
+            <a:srgbClr val="2B5A7E"/>
+          </a:solidFill>
+          <a:ln/>
+        </p:spPr>
+      </p:sp>
+      <p:sp>
+        <p:nvSpPr>
+          <p:cNvPr id="16" name="Text 14"/>
+          <p:cNvSpPr/>
+          <p:nvPr/>
+        </p:nvSpPr>
+        <p:spPr>
+          <a:xfrm>
+            <a:off x="7884160" y="2112264"/>
             <a:ext cx="548640" cy="292608"/>
           </a:xfrm>
           <a:prstGeom prst="rect">
@@ -25915,13 +26007,13 @@
       </p:sp>
       <p:sp>
         <p:nvSpPr>
-          <p:cNvPr id="14" name="Text 12"/>
-          <p:cNvSpPr/>
-          <p:nvPr/>
-        </p:nvSpPr>
-        <p:spPr>
-          <a:xfrm>
-            <a:off x="365760" y="2112264"/>
+          <p:cNvPr id="17" name="Text 15"/>
+          <p:cNvSpPr/>
+          <p:nvPr/>
+        </p:nvSpPr>
+        <p:spPr>
+          <a:xfrm>
+            <a:off x="365760" y="2496312"/>
             <a:ext cx="1645920" cy="292608"/>
           </a:xfrm>
           <a:prstGeom prst="rect">
@@ -25951,13 +26043,13 @@
       </p:sp>
       <p:sp>
         <p:nvSpPr>
-          <p:cNvPr id="15" name="Shape 13"/>
-          <p:cNvSpPr/>
-          <p:nvPr/>
-        </p:nvSpPr>
-        <p:spPr>
-          <a:xfrm>
-            <a:off x="2103120" y="2139696"/>
+          <p:cNvPr id="18" name="Shape 16"/>
+          <p:cNvSpPr/>
+          <p:nvPr/>
+        </p:nvSpPr>
+        <p:spPr>
+          <a:xfrm>
+            <a:off x="2103120" y="2523744"/>
             <a:ext cx="5547360" cy="228600"/>
           </a:xfrm>
           <a:prstGeom prst="rect">
@@ -25971,13 +26063,13 @@
       </p:sp>
       <p:sp>
         <p:nvSpPr>
-          <p:cNvPr id="16" name="Text 14"/>
-          <p:cNvSpPr/>
-          <p:nvPr/>
-        </p:nvSpPr>
-        <p:spPr>
-          <a:xfrm>
-            <a:off x="7741920" y="2112264"/>
+          <p:cNvPr id="19" name="Text 17"/>
+          <p:cNvSpPr/>
+          <p:nvPr/>
+        </p:nvSpPr>
+        <p:spPr>
+          <a:xfrm>
+            <a:off x="7741920" y="2496312"/>
             <a:ext cx="548640" cy="292608"/>
           </a:xfrm>
           <a:prstGeom prst="rect">
@@ -26000,98 +26092,6 @@
                 </a:solidFill>
               </a:rPr>
               <a:t>390</a:t>
-            </a:r>
-            <a:endParaRPr lang="en-US" sz="800" dirty="0"/>
-          </a:p>
-        </p:txBody>
-      </p:sp>
-      <p:sp>
-        <p:nvSpPr>
-          <p:cNvPr id="17" name="Text 15"/>
-          <p:cNvSpPr/>
-          <p:nvPr/>
-        </p:nvSpPr>
-        <p:spPr>
-          <a:xfrm>
-            <a:off x="365760" y="2496312"/>
-            <a:ext cx="1645920" cy="292608"/>
-          </a:xfrm>
-          <a:prstGeom prst="rect">
-            <a:avLst/>
-          </a:prstGeom>
-          <a:noFill/>
-          <a:ln/>
-        </p:spPr>
-        <p:txBody>
-          <a:bodyPr wrap="square" rtlCol="0" anchor="ctr"/>
-          <a:lstStyle/>
-          <a:p>
-            <a:pPr algn="r" indent="0" marL="0">
-              <a:buNone/>
-            </a:pPr>
-            <a:r>
-              <a:rPr lang="en-US" sz="800" dirty="0">
-                <a:solidFill>
-                  <a:srgbClr val="2C2C2C"/>
-                </a:solidFill>
-              </a:rPr>
-              <a:t>Paul233365</a:t>
-            </a:r>
-            <a:endParaRPr lang="en-US" sz="800" dirty="0"/>
-          </a:p>
-        </p:txBody>
-      </p:sp>
-      <p:sp>
-        <p:nvSpPr>
-          <p:cNvPr id="18" name="Shape 16"/>
-          <p:cNvSpPr/>
-          <p:nvPr/>
-        </p:nvSpPr>
-        <p:spPr>
-          <a:xfrm>
-            <a:off x="2103120" y="2523744"/>
-            <a:ext cx="5405120" cy="228600"/>
-          </a:xfrm>
-          <a:prstGeom prst="rect">
-            <a:avLst/>
-          </a:prstGeom>
-          <a:solidFill>
-            <a:srgbClr val="2B5A7E"/>
-          </a:solidFill>
-          <a:ln/>
-        </p:spPr>
-      </p:sp>
-      <p:sp>
-        <p:nvSpPr>
-          <p:cNvPr id="19" name="Text 17"/>
-          <p:cNvSpPr/>
-          <p:nvPr/>
-        </p:nvSpPr>
-        <p:spPr>
-          <a:xfrm>
-            <a:off x="7599680" y="2496312"/>
-            <a:ext cx="548640" cy="292608"/>
-          </a:xfrm>
-          <a:prstGeom prst="rect">
-            <a:avLst/>
-          </a:prstGeom>
-          <a:noFill/>
-          <a:ln/>
-        </p:spPr>
-        <p:txBody>
-          <a:bodyPr wrap="square" rtlCol="0" anchor="ctr"/>
-          <a:lstStyle/>
-          <a:p>
-            <a:pPr indent="0" marL="0">
-              <a:buNone/>
-            </a:pPr>
-            <a:r>
-              <a:rPr lang="en-US" sz="800" b="1" dirty="0">
-                <a:solidFill>
-                  <a:srgbClr val="2C2C2C"/>
-                </a:solidFill>
-              </a:rPr>
-              <a:t>380</a:t>
             </a:r>
             <a:endParaRPr lang="en-US" sz="800" dirty="0"/>
           </a:p>
@@ -29991,7 +29991,7 @@
                             <a:srgbClr val="2C2C2C"/>
                           </a:solidFill>
                         </a:rPr>
-                        <a:t>WRONG</a:t>
+                        <a:t>CORRECT</a:t>
                       </a:r>
                       <a:endParaRPr lang="en-US" sz="800" dirty="0"/>
                     </a:p>

</xml_diff>

<commit_message>
Update with Tennessee result — Fizzz3 surges to #2, lead shrinks to 10pts
Co-Authored-By: Claude Opus 4.6 <noreply@anthropic.com>
</commit_message>
<xml_diff>
--- a/Elons_Plugs_Deck.pptx
+++ b/Elons_Plugs_Deck.pptx
@@ -191,10 +191,10 @@
                     <c:v>TaylorDuran</c:v>
                   </c:pt>
                   <c:pt idx="1">
-                    <c:v>Capn'Kirk</c:v>
+                    <c:v>Fizzz3</c:v>
                   </c:pt>
                   <c:pt idx="2">
-                    <c:v>Fizzz3</c:v>
+                    <c:v>Capn'Kirk</c:v>
                   </c:pt>
                   <c:pt idx="3">
                     <c:v>Paul233365</c:v>
@@ -225,10 +225,10 @@
                   <c:v>290</c:v>
                 </c:pt>
                 <c:pt idx="1">
-                  <c:v>250</c:v>
+                  <c:v>260</c:v>
                 </c:pt>
                 <c:pt idx="2">
-                  <c:v>260</c:v>
+                  <c:v>250</c:v>
                 </c:pt>
                 <c:pt idx="3">
                   <c:v>240</c:v>
@@ -305,10 +305,10 @@
                     <c:v>TaylorDuran</c:v>
                   </c:pt>
                   <c:pt idx="1">
-                    <c:v>Capn'Kirk</c:v>
+                    <c:v>Fizzz3</c:v>
                   </c:pt>
                   <c:pt idx="2">
-                    <c:v>Fizzz3</c:v>
+                    <c:v>Capn'Kirk</c:v>
                   </c:pt>
                   <c:pt idx="3">
                     <c:v>Paul233365</c:v>
@@ -342,7 +342,7 @@
                   <c:v>180</c:v>
                 </c:pt>
                 <c:pt idx="2">
-                  <c:v>160</c:v>
+                  <c:v>180</c:v>
                 </c:pt>
                 <c:pt idx="3">
                   <c:v>160</c:v>
@@ -2829,7 +2829,7 @@
                   <a:srgbClr val="AAAAAA"/>
                 </a:solidFill>
               </a:rPr>
-              <a:t>ESPN Tournament Challenge / Bracket Analytics / Mar 22, 2026 7:30 PM ET</a:t>
+              <a:t>ESPN Tournament Challenge / Bracket Analytics / Mar 22, 2026 8:30 PM ET</a:t>
             </a:r>
             <a:endParaRPr lang="en-US" sz="1100" dirty="0"/>
           </a:p>
@@ -3103,7 +3103,7 @@
                   <a:srgbClr val="2C2C2C"/>
                 </a:solidFill>
               </a:rPr>
-              <a:t>Capn'Kirk</a:t>
+              <a:t>Fizzz3</a:t>
             </a:r>
             <a:endParaRPr lang="en-US" sz="550" dirty="0"/>
           </a:p>
@@ -3139,7 +3139,7 @@
                   <a:srgbClr val="2C2C2C"/>
                 </a:solidFill>
               </a:rPr>
-              <a:t>Fizzz3</a:t>
+              <a:t>Capn'Kirk</a:t>
             </a:r>
             <a:endParaRPr lang="en-US" sz="550" dirty="0"/>
           </a:p>
@@ -3843,7 +3843,7 @@
                   <a:srgbClr val="2C2C2C"/>
                 </a:solidFill>
               </a:rPr>
-              <a:t>Capn'Kirk</a:t>
+              <a:t>Fizzz3</a:t>
             </a:r>
             <a:endParaRPr lang="en-US" sz="600" dirty="0"/>
           </a:p>
@@ -4331,7 +4331,7 @@
                   <a:srgbClr val="2C2C2C"/>
                 </a:solidFill>
               </a:rPr>
-              <a:t>Fizzz3</a:t>
+              <a:t>Capn'Kirk</a:t>
             </a:r>
             <a:endParaRPr lang="en-US" sz="600" dirty="0"/>
           </a:p>
@@ -8261,7 +8261,7 @@
                             <a:srgbClr val="2C2C2C"/>
                           </a:solidFill>
                         </a:rPr>
-                        <a:t>7</a:t>
+                        <a:t>8</a:t>
                       </a:r>
                       <a:endParaRPr lang="en-US" sz="900" dirty="0"/>
                     </a:p>
@@ -8494,6 +8494,414 @@
                           </a:solidFill>
                         </a:rPr>
                         <a:t>5</a:t>
+                      </a:r>
+                      <a:endParaRPr lang="en-US" sz="900" dirty="0"/>
+                    </a:p>
+                  </a:txBody>
+                  <a:tcPr marL="91440" marR="91440" marT="45720" marB="45720">
+                    <a:lnL w="6350" cap="flat" cmpd="sng" algn="ctr">
+                      <a:solidFill>
+                        <a:srgbClr val="CCCCCC"/>
+                      </a:solidFill>
+                      <a:prstDash val="solid"/>
+                      <a:round/>
+                      <a:headEnd type="none" w="med" len="med"/>
+                      <a:tailEnd type="none" w="med" len="med"/>
+                    </a:lnL>
+                    <a:lnR w="6350" cap="flat" cmpd="sng" algn="ctr">
+                      <a:solidFill>
+                        <a:srgbClr val="CCCCCC"/>
+                      </a:solidFill>
+                      <a:prstDash val="solid"/>
+                      <a:round/>
+                      <a:headEnd type="none" w="med" len="med"/>
+                      <a:tailEnd type="none" w="med" len="med"/>
+                    </a:lnR>
+                    <a:lnT w="6350" cap="flat" cmpd="sng" algn="ctr">
+                      <a:solidFill>
+                        <a:srgbClr val="CCCCCC"/>
+                      </a:solidFill>
+                      <a:prstDash val="solid"/>
+                      <a:round/>
+                      <a:headEnd type="none" w="med" len="med"/>
+                      <a:tailEnd type="none" w="med" len="med"/>
+                    </a:lnT>
+                    <a:lnB w="6350" cap="flat" cmpd="sng" algn="ctr">
+                      <a:solidFill>
+                        <a:srgbClr val="CCCCCC"/>
+                      </a:solidFill>
+                      <a:prstDash val="solid"/>
+                      <a:round/>
+                      <a:headEnd type="none" w="med" len="med"/>
+                      <a:tailEnd type="none" w="med" len="med"/>
+                    </a:lnB>
+                  </a:tcPr>
+                </a:tc>
+              </a:tr>
+              <a:tr h="406400">
+                <a:tc>
+                  <a:txBody>
+                    <a:bodyPr/>
+                    <a:lstStyle/>
+                    <a:p>
+                      <a:pPr algn="ctr" indent="0" marL="0">
+                        <a:buNone/>
+                      </a:pPr>
+                      <a:r>
+                        <a:rPr lang="en-US" sz="900" dirty="0">
+                          <a:solidFill>
+                            <a:srgbClr val="2C2C2C"/>
+                          </a:solidFill>
+                        </a:rPr>
+                        <a:t>Fizzz3</a:t>
+                      </a:r>
+                      <a:endParaRPr lang="en-US" sz="900" dirty="0"/>
+                    </a:p>
+                  </a:txBody>
+                  <a:tcPr marL="91440" marR="91440" marT="45720" marB="45720">
+                    <a:lnL w="6350" cap="flat" cmpd="sng" algn="ctr">
+                      <a:solidFill>
+                        <a:srgbClr val="CCCCCC"/>
+                      </a:solidFill>
+                      <a:prstDash val="solid"/>
+                      <a:round/>
+                      <a:headEnd type="none" w="med" len="med"/>
+                      <a:tailEnd type="none" w="med" len="med"/>
+                    </a:lnL>
+                    <a:lnR w="6350" cap="flat" cmpd="sng" algn="ctr">
+                      <a:solidFill>
+                        <a:srgbClr val="CCCCCC"/>
+                      </a:solidFill>
+                      <a:prstDash val="solid"/>
+                      <a:round/>
+                      <a:headEnd type="none" w="med" len="med"/>
+                      <a:tailEnd type="none" w="med" len="med"/>
+                    </a:lnR>
+                    <a:lnT w="6350" cap="flat" cmpd="sng" algn="ctr">
+                      <a:solidFill>
+                        <a:srgbClr val="CCCCCC"/>
+                      </a:solidFill>
+                      <a:prstDash val="solid"/>
+                      <a:round/>
+                      <a:headEnd type="none" w="med" len="med"/>
+                      <a:tailEnd type="none" w="med" len="med"/>
+                    </a:lnT>
+                    <a:lnB w="6350" cap="flat" cmpd="sng" algn="ctr">
+                      <a:solidFill>
+                        <a:srgbClr val="CCCCCC"/>
+                      </a:solidFill>
+                      <a:prstDash val="solid"/>
+                      <a:round/>
+                      <a:headEnd type="none" w="med" len="med"/>
+                      <a:tailEnd type="none" w="med" len="med"/>
+                    </a:lnB>
+                  </a:tcPr>
+                </a:tc>
+                <a:tc>
+                  <a:txBody>
+                    <a:bodyPr/>
+                    <a:lstStyle/>
+                    <a:p>
+                      <a:pPr algn="ctr" indent="0" marL="0">
+                        <a:buNone/>
+                      </a:pPr>
+                      <a:r>
+                        <a:rPr lang="en-US" sz="900" dirty="0">
+                          <a:solidFill>
+                            <a:srgbClr val="2C2C2C"/>
+                          </a:solidFill>
+                        </a:rPr>
+                        <a:t>35</a:t>
+                      </a:r>
+                      <a:endParaRPr lang="en-US" sz="900" dirty="0"/>
+                    </a:p>
+                  </a:txBody>
+                  <a:tcPr marL="91440" marR="91440" marT="45720" marB="45720">
+                    <a:lnL w="6350" cap="flat" cmpd="sng" algn="ctr">
+                      <a:solidFill>
+                        <a:srgbClr val="CCCCCC"/>
+                      </a:solidFill>
+                      <a:prstDash val="solid"/>
+                      <a:round/>
+                      <a:headEnd type="none" w="med" len="med"/>
+                      <a:tailEnd type="none" w="med" len="med"/>
+                    </a:lnL>
+                    <a:lnR w="6350" cap="flat" cmpd="sng" algn="ctr">
+                      <a:solidFill>
+                        <a:srgbClr val="CCCCCC"/>
+                      </a:solidFill>
+                      <a:prstDash val="solid"/>
+                      <a:round/>
+                      <a:headEnd type="none" w="med" len="med"/>
+                      <a:tailEnd type="none" w="med" len="med"/>
+                    </a:lnR>
+                    <a:lnT w="6350" cap="flat" cmpd="sng" algn="ctr">
+                      <a:solidFill>
+                        <a:srgbClr val="CCCCCC"/>
+                      </a:solidFill>
+                      <a:prstDash val="solid"/>
+                      <a:round/>
+                      <a:headEnd type="none" w="med" len="med"/>
+                      <a:tailEnd type="none" w="med" len="med"/>
+                    </a:lnT>
+                    <a:lnB w="6350" cap="flat" cmpd="sng" algn="ctr">
+                      <a:solidFill>
+                        <a:srgbClr val="CCCCCC"/>
+                      </a:solidFill>
+                      <a:prstDash val="solid"/>
+                      <a:round/>
+                      <a:headEnd type="none" w="med" len="med"/>
+                      <a:tailEnd type="none" w="med" len="med"/>
+                    </a:lnB>
+                  </a:tcPr>
+                </a:tc>
+                <a:tc>
+                  <a:txBody>
+                    <a:bodyPr/>
+                    <a:lstStyle/>
+                    <a:p>
+                      <a:pPr algn="ctr" indent="0" marL="0">
+                        <a:buNone/>
+                      </a:pPr>
+                      <a:r>
+                        <a:rPr lang="en-US" sz="900" dirty="0">
+                          <a:solidFill>
+                            <a:srgbClr val="2C2C2C"/>
+                          </a:solidFill>
+                        </a:rPr>
+                        <a:t>10</a:t>
+                      </a:r>
+                      <a:endParaRPr lang="en-US" sz="900" dirty="0"/>
+                    </a:p>
+                  </a:txBody>
+                  <a:tcPr marL="91440" marR="91440" marT="45720" marB="45720">
+                    <a:lnL w="6350" cap="flat" cmpd="sng" algn="ctr">
+                      <a:solidFill>
+                        <a:srgbClr val="CCCCCC"/>
+                      </a:solidFill>
+                      <a:prstDash val="solid"/>
+                      <a:round/>
+                      <a:headEnd type="none" w="med" len="med"/>
+                      <a:tailEnd type="none" w="med" len="med"/>
+                    </a:lnL>
+                    <a:lnR w="6350" cap="flat" cmpd="sng" algn="ctr">
+                      <a:solidFill>
+                        <a:srgbClr val="CCCCCC"/>
+                      </a:solidFill>
+                      <a:prstDash val="solid"/>
+                      <a:round/>
+                      <a:headEnd type="none" w="med" len="med"/>
+                      <a:tailEnd type="none" w="med" len="med"/>
+                    </a:lnR>
+                    <a:lnT w="6350" cap="flat" cmpd="sng" algn="ctr">
+                      <a:solidFill>
+                        <a:srgbClr val="CCCCCC"/>
+                      </a:solidFill>
+                      <a:prstDash val="solid"/>
+                      <a:round/>
+                      <a:headEnd type="none" w="med" len="med"/>
+                      <a:tailEnd type="none" w="med" len="med"/>
+                    </a:lnT>
+                    <a:lnB w="6350" cap="flat" cmpd="sng" algn="ctr">
+                      <a:solidFill>
+                        <a:srgbClr val="CCCCCC"/>
+                      </a:solidFill>
+                      <a:prstDash val="solid"/>
+                      <a:round/>
+                      <a:headEnd type="none" w="med" len="med"/>
+                      <a:tailEnd type="none" w="med" len="med"/>
+                    </a:lnB>
+                  </a:tcPr>
+                </a:tc>
+                <a:tc>
+                  <a:txBody>
+                    <a:bodyPr/>
+                    <a:lstStyle/>
+                    <a:p>
+                      <a:pPr algn="ctr" indent="0" marL="0">
+                        <a:buNone/>
+                      </a:pPr>
+                      <a:r>
+                        <a:rPr lang="en-US" sz="900" dirty="0">
+                          <a:solidFill>
+                            <a:srgbClr val="2C2C2C"/>
+                          </a:solidFill>
+                        </a:rPr>
+                        <a:t>26</a:t>
+                      </a:r>
+                      <a:endParaRPr lang="en-US" sz="900" dirty="0"/>
+                    </a:p>
+                  </a:txBody>
+                  <a:tcPr marL="91440" marR="91440" marT="45720" marB="45720">
+                    <a:lnL w="6350" cap="flat" cmpd="sng" algn="ctr">
+                      <a:solidFill>
+                        <a:srgbClr val="CCCCCC"/>
+                      </a:solidFill>
+                      <a:prstDash val="solid"/>
+                      <a:round/>
+                      <a:headEnd type="none" w="med" len="med"/>
+                      <a:tailEnd type="none" w="med" len="med"/>
+                    </a:lnL>
+                    <a:lnR w="6350" cap="flat" cmpd="sng" algn="ctr">
+                      <a:solidFill>
+                        <a:srgbClr val="CCCCCC"/>
+                      </a:solidFill>
+                      <a:prstDash val="solid"/>
+                      <a:round/>
+                      <a:headEnd type="none" w="med" len="med"/>
+                      <a:tailEnd type="none" w="med" len="med"/>
+                    </a:lnR>
+                    <a:lnT w="6350" cap="flat" cmpd="sng" algn="ctr">
+                      <a:solidFill>
+                        <a:srgbClr val="CCCCCC"/>
+                      </a:solidFill>
+                      <a:prstDash val="solid"/>
+                      <a:round/>
+                      <a:headEnd type="none" w="med" len="med"/>
+                      <a:tailEnd type="none" w="med" len="med"/>
+                    </a:lnT>
+                    <a:lnB w="6350" cap="flat" cmpd="sng" algn="ctr">
+                      <a:solidFill>
+                        <a:srgbClr val="CCCCCC"/>
+                      </a:solidFill>
+                      <a:prstDash val="solid"/>
+                      <a:round/>
+                      <a:headEnd type="none" w="med" len="med"/>
+                      <a:tailEnd type="none" w="med" len="med"/>
+                    </a:lnB>
+                  </a:tcPr>
+                </a:tc>
+                <a:tc>
+                  <a:txBody>
+                    <a:bodyPr/>
+                    <a:lstStyle/>
+                    <a:p>
+                      <a:pPr algn="ctr" indent="0" marL="0">
+                        <a:buNone/>
+                      </a:pPr>
+                      <a:r>
+                        <a:rPr lang="en-US" sz="900" dirty="0">
+                          <a:solidFill>
+                            <a:srgbClr val="2C2C2C"/>
+                          </a:solidFill>
+                        </a:rPr>
+                        <a:t>18</a:t>
+                      </a:r>
+                      <a:endParaRPr lang="en-US" sz="900" dirty="0"/>
+                    </a:p>
+                  </a:txBody>
+                  <a:tcPr marL="91440" marR="91440" marT="45720" marB="45720">
+                    <a:lnL w="6350" cap="flat" cmpd="sng" algn="ctr">
+                      <a:solidFill>
+                        <a:srgbClr val="CCCCCC"/>
+                      </a:solidFill>
+                      <a:prstDash val="solid"/>
+                      <a:round/>
+                      <a:headEnd type="none" w="med" len="med"/>
+                      <a:tailEnd type="none" w="med" len="med"/>
+                    </a:lnL>
+                    <a:lnR w="6350" cap="flat" cmpd="sng" algn="ctr">
+                      <a:solidFill>
+                        <a:srgbClr val="CCCCCC"/>
+                      </a:solidFill>
+                      <a:prstDash val="solid"/>
+                      <a:round/>
+                      <a:headEnd type="none" w="med" len="med"/>
+                      <a:tailEnd type="none" w="med" len="med"/>
+                    </a:lnR>
+                    <a:lnT w="6350" cap="flat" cmpd="sng" algn="ctr">
+                      <a:solidFill>
+                        <a:srgbClr val="CCCCCC"/>
+                      </a:solidFill>
+                      <a:prstDash val="solid"/>
+                      <a:round/>
+                      <a:headEnd type="none" w="med" len="med"/>
+                      <a:tailEnd type="none" w="med" len="med"/>
+                    </a:lnT>
+                    <a:lnB w="6350" cap="flat" cmpd="sng" algn="ctr">
+                      <a:solidFill>
+                        <a:srgbClr val="CCCCCC"/>
+                      </a:solidFill>
+                      <a:prstDash val="solid"/>
+                      <a:round/>
+                      <a:headEnd type="none" w="med" len="med"/>
+                      <a:tailEnd type="none" w="med" len="med"/>
+                    </a:lnB>
+                  </a:tcPr>
+                </a:tc>
+                <a:tc>
+                  <a:txBody>
+                    <a:bodyPr/>
+                    <a:lstStyle/>
+                    <a:p>
+                      <a:pPr algn="ctr" indent="0" marL="0">
+                        <a:buNone/>
+                      </a:pPr>
+                      <a:r>
+                        <a:rPr lang="en-US" sz="900" dirty="0">
+                          <a:solidFill>
+                            <a:srgbClr val="2C2C2C"/>
+                          </a:solidFill>
+                        </a:rPr>
+                        <a:t>75</a:t>
+                      </a:r>
+                      <a:endParaRPr lang="en-US" sz="900" dirty="0"/>
+                    </a:p>
+                  </a:txBody>
+                  <a:tcPr marL="91440" marR="91440" marT="45720" marB="45720">
+                    <a:lnL w="6350" cap="flat" cmpd="sng" algn="ctr">
+                      <a:solidFill>
+                        <a:srgbClr val="CCCCCC"/>
+                      </a:solidFill>
+                      <a:prstDash val="solid"/>
+                      <a:round/>
+                      <a:headEnd type="none" w="med" len="med"/>
+                      <a:tailEnd type="none" w="med" len="med"/>
+                    </a:lnL>
+                    <a:lnR w="6350" cap="flat" cmpd="sng" algn="ctr">
+                      <a:solidFill>
+                        <a:srgbClr val="CCCCCC"/>
+                      </a:solidFill>
+                      <a:prstDash val="solid"/>
+                      <a:round/>
+                      <a:headEnd type="none" w="med" len="med"/>
+                      <a:tailEnd type="none" w="med" len="med"/>
+                    </a:lnR>
+                    <a:lnT w="6350" cap="flat" cmpd="sng" algn="ctr">
+                      <a:solidFill>
+                        <a:srgbClr val="CCCCCC"/>
+                      </a:solidFill>
+                      <a:prstDash val="solid"/>
+                      <a:round/>
+                      <a:headEnd type="none" w="med" len="med"/>
+                      <a:tailEnd type="none" w="med" len="med"/>
+                    </a:lnT>
+                    <a:lnB w="6350" cap="flat" cmpd="sng" algn="ctr">
+                      <a:solidFill>
+                        <a:srgbClr val="CCCCCC"/>
+                      </a:solidFill>
+                      <a:prstDash val="solid"/>
+                      <a:round/>
+                      <a:headEnd type="none" w="med" len="med"/>
+                      <a:tailEnd type="none" w="med" len="med"/>
+                    </a:lnB>
+                  </a:tcPr>
+                </a:tc>
+                <a:tc>
+                  <a:txBody>
+                    <a:bodyPr/>
+                    <a:lstStyle/>
+                    <a:p>
+                      <a:pPr algn="ctr" indent="0" marL="0">
+                        <a:buNone/>
+                      </a:pPr>
+                      <a:r>
+                        <a:rPr lang="en-US" sz="900" dirty="0">
+                          <a:solidFill>
+                            <a:srgbClr val="2C2C2C"/>
+                          </a:solidFill>
+                        </a:rPr>
+                        <a:t>10</a:t>
                       </a:r>
                       <a:endParaRPr lang="en-US" sz="900" dirty="0"/>
                     </a:p>
@@ -8669,7 +9077,7 @@
                             <a:srgbClr val="2C2C2C"/>
                           </a:solidFill>
                         </a:rPr>
-                        <a:t>9</a:t>
+                        <a:t>10</a:t>
                       </a:r>
                       <a:endParaRPr lang="en-US" sz="900" dirty="0"/>
                     </a:p>
@@ -8902,414 +9310,6 @@
                           </a:solidFill>
                         </a:rPr>
                         <a:t>0</a:t>
-                      </a:r>
-                      <a:endParaRPr lang="en-US" sz="900" dirty="0"/>
-                    </a:p>
-                  </a:txBody>
-                  <a:tcPr marL="91440" marR="91440" marT="45720" marB="45720">
-                    <a:lnL w="6350" cap="flat" cmpd="sng" algn="ctr">
-                      <a:solidFill>
-                        <a:srgbClr val="CCCCCC"/>
-                      </a:solidFill>
-                      <a:prstDash val="solid"/>
-                      <a:round/>
-                      <a:headEnd type="none" w="med" len="med"/>
-                      <a:tailEnd type="none" w="med" len="med"/>
-                    </a:lnL>
-                    <a:lnR w="6350" cap="flat" cmpd="sng" algn="ctr">
-                      <a:solidFill>
-                        <a:srgbClr val="CCCCCC"/>
-                      </a:solidFill>
-                      <a:prstDash val="solid"/>
-                      <a:round/>
-                      <a:headEnd type="none" w="med" len="med"/>
-                      <a:tailEnd type="none" w="med" len="med"/>
-                    </a:lnR>
-                    <a:lnT w="6350" cap="flat" cmpd="sng" algn="ctr">
-                      <a:solidFill>
-                        <a:srgbClr val="CCCCCC"/>
-                      </a:solidFill>
-                      <a:prstDash val="solid"/>
-                      <a:round/>
-                      <a:headEnd type="none" w="med" len="med"/>
-                      <a:tailEnd type="none" w="med" len="med"/>
-                    </a:lnT>
-                    <a:lnB w="6350" cap="flat" cmpd="sng" algn="ctr">
-                      <a:solidFill>
-                        <a:srgbClr val="CCCCCC"/>
-                      </a:solidFill>
-                      <a:prstDash val="solid"/>
-                      <a:round/>
-                      <a:headEnd type="none" w="med" len="med"/>
-                      <a:tailEnd type="none" w="med" len="med"/>
-                    </a:lnB>
-                  </a:tcPr>
-                </a:tc>
-              </a:tr>
-              <a:tr h="406400">
-                <a:tc>
-                  <a:txBody>
-                    <a:bodyPr/>
-                    <a:lstStyle/>
-                    <a:p>
-                      <a:pPr algn="ctr" indent="0" marL="0">
-                        <a:buNone/>
-                      </a:pPr>
-                      <a:r>
-                        <a:rPr lang="en-US" sz="900" dirty="0">
-                          <a:solidFill>
-                            <a:srgbClr val="2C2C2C"/>
-                          </a:solidFill>
-                        </a:rPr>
-                        <a:t>Fizzz3</a:t>
-                      </a:r>
-                      <a:endParaRPr lang="en-US" sz="900" dirty="0"/>
-                    </a:p>
-                  </a:txBody>
-                  <a:tcPr marL="91440" marR="91440" marT="45720" marB="45720">
-                    <a:lnL w="6350" cap="flat" cmpd="sng" algn="ctr">
-                      <a:solidFill>
-                        <a:srgbClr val="CCCCCC"/>
-                      </a:solidFill>
-                      <a:prstDash val="solid"/>
-                      <a:round/>
-                      <a:headEnd type="none" w="med" len="med"/>
-                      <a:tailEnd type="none" w="med" len="med"/>
-                    </a:lnL>
-                    <a:lnR w="6350" cap="flat" cmpd="sng" algn="ctr">
-                      <a:solidFill>
-                        <a:srgbClr val="CCCCCC"/>
-                      </a:solidFill>
-                      <a:prstDash val="solid"/>
-                      <a:round/>
-                      <a:headEnd type="none" w="med" len="med"/>
-                      <a:tailEnd type="none" w="med" len="med"/>
-                    </a:lnR>
-                    <a:lnT w="6350" cap="flat" cmpd="sng" algn="ctr">
-                      <a:solidFill>
-                        <a:srgbClr val="CCCCCC"/>
-                      </a:solidFill>
-                      <a:prstDash val="solid"/>
-                      <a:round/>
-                      <a:headEnd type="none" w="med" len="med"/>
-                      <a:tailEnd type="none" w="med" len="med"/>
-                    </a:lnT>
-                    <a:lnB w="6350" cap="flat" cmpd="sng" algn="ctr">
-                      <a:solidFill>
-                        <a:srgbClr val="CCCCCC"/>
-                      </a:solidFill>
-                      <a:prstDash val="solid"/>
-                      <a:round/>
-                      <a:headEnd type="none" w="med" len="med"/>
-                      <a:tailEnd type="none" w="med" len="med"/>
-                    </a:lnB>
-                  </a:tcPr>
-                </a:tc>
-                <a:tc>
-                  <a:txBody>
-                    <a:bodyPr/>
-                    <a:lstStyle/>
-                    <a:p>
-                      <a:pPr algn="ctr" indent="0" marL="0">
-                        <a:buNone/>
-                      </a:pPr>
-                      <a:r>
-                        <a:rPr lang="en-US" sz="900" dirty="0">
-                          <a:solidFill>
-                            <a:srgbClr val="2C2C2C"/>
-                          </a:solidFill>
-                        </a:rPr>
-                        <a:t>34</a:t>
-                      </a:r>
-                      <a:endParaRPr lang="en-US" sz="900" dirty="0"/>
-                    </a:p>
-                  </a:txBody>
-                  <a:tcPr marL="91440" marR="91440" marT="45720" marB="45720">
-                    <a:lnL w="6350" cap="flat" cmpd="sng" algn="ctr">
-                      <a:solidFill>
-                        <a:srgbClr val="CCCCCC"/>
-                      </a:solidFill>
-                      <a:prstDash val="solid"/>
-                      <a:round/>
-                      <a:headEnd type="none" w="med" len="med"/>
-                      <a:tailEnd type="none" w="med" len="med"/>
-                    </a:lnL>
-                    <a:lnR w="6350" cap="flat" cmpd="sng" algn="ctr">
-                      <a:solidFill>
-                        <a:srgbClr val="CCCCCC"/>
-                      </a:solidFill>
-                      <a:prstDash val="solid"/>
-                      <a:round/>
-                      <a:headEnd type="none" w="med" len="med"/>
-                      <a:tailEnd type="none" w="med" len="med"/>
-                    </a:lnR>
-                    <a:lnT w="6350" cap="flat" cmpd="sng" algn="ctr">
-                      <a:solidFill>
-                        <a:srgbClr val="CCCCCC"/>
-                      </a:solidFill>
-                      <a:prstDash val="solid"/>
-                      <a:round/>
-                      <a:headEnd type="none" w="med" len="med"/>
-                      <a:tailEnd type="none" w="med" len="med"/>
-                    </a:lnT>
-                    <a:lnB w="6350" cap="flat" cmpd="sng" algn="ctr">
-                      <a:solidFill>
-                        <a:srgbClr val="CCCCCC"/>
-                      </a:solidFill>
-                      <a:prstDash val="solid"/>
-                      <a:round/>
-                      <a:headEnd type="none" w="med" len="med"/>
-                      <a:tailEnd type="none" w="med" len="med"/>
-                    </a:lnB>
-                  </a:tcPr>
-                </a:tc>
-                <a:tc>
-                  <a:txBody>
-                    <a:bodyPr/>
-                    <a:lstStyle/>
-                    <a:p>
-                      <a:pPr algn="ctr" indent="0" marL="0">
-                        <a:buNone/>
-                      </a:pPr>
-                      <a:r>
-                        <a:rPr lang="en-US" sz="900" dirty="0">
-                          <a:solidFill>
-                            <a:srgbClr val="2C2C2C"/>
-                          </a:solidFill>
-                        </a:rPr>
-                        <a:t>10</a:t>
-                      </a:r>
-                      <a:endParaRPr lang="en-US" sz="900" dirty="0"/>
-                    </a:p>
-                  </a:txBody>
-                  <a:tcPr marL="91440" marR="91440" marT="45720" marB="45720">
-                    <a:lnL w="6350" cap="flat" cmpd="sng" algn="ctr">
-                      <a:solidFill>
-                        <a:srgbClr val="CCCCCC"/>
-                      </a:solidFill>
-                      <a:prstDash val="solid"/>
-                      <a:round/>
-                      <a:headEnd type="none" w="med" len="med"/>
-                      <a:tailEnd type="none" w="med" len="med"/>
-                    </a:lnL>
-                    <a:lnR w="6350" cap="flat" cmpd="sng" algn="ctr">
-                      <a:solidFill>
-                        <a:srgbClr val="CCCCCC"/>
-                      </a:solidFill>
-                      <a:prstDash val="solid"/>
-                      <a:round/>
-                      <a:headEnd type="none" w="med" len="med"/>
-                      <a:tailEnd type="none" w="med" len="med"/>
-                    </a:lnR>
-                    <a:lnT w="6350" cap="flat" cmpd="sng" algn="ctr">
-                      <a:solidFill>
-                        <a:srgbClr val="CCCCCC"/>
-                      </a:solidFill>
-                      <a:prstDash val="solid"/>
-                      <a:round/>
-                      <a:headEnd type="none" w="med" len="med"/>
-                      <a:tailEnd type="none" w="med" len="med"/>
-                    </a:lnT>
-                    <a:lnB w="6350" cap="flat" cmpd="sng" algn="ctr">
-                      <a:solidFill>
-                        <a:srgbClr val="CCCCCC"/>
-                      </a:solidFill>
-                      <a:prstDash val="solid"/>
-                      <a:round/>
-                      <a:headEnd type="none" w="med" len="med"/>
-                      <a:tailEnd type="none" w="med" len="med"/>
-                    </a:lnB>
-                  </a:tcPr>
-                </a:tc>
-                <a:tc>
-                  <a:txBody>
-                    <a:bodyPr/>
-                    <a:lstStyle/>
-                    <a:p>
-                      <a:pPr algn="ctr" indent="0" marL="0">
-                        <a:buNone/>
-                      </a:pPr>
-                      <a:r>
-                        <a:rPr lang="en-US" sz="900" dirty="0">
-                          <a:solidFill>
-                            <a:srgbClr val="2C2C2C"/>
-                          </a:solidFill>
-                        </a:rPr>
-                        <a:t>26</a:t>
-                      </a:r>
-                      <a:endParaRPr lang="en-US" sz="900" dirty="0"/>
-                    </a:p>
-                  </a:txBody>
-                  <a:tcPr marL="91440" marR="91440" marT="45720" marB="45720">
-                    <a:lnL w="6350" cap="flat" cmpd="sng" algn="ctr">
-                      <a:solidFill>
-                        <a:srgbClr val="CCCCCC"/>
-                      </a:solidFill>
-                      <a:prstDash val="solid"/>
-                      <a:round/>
-                      <a:headEnd type="none" w="med" len="med"/>
-                      <a:tailEnd type="none" w="med" len="med"/>
-                    </a:lnL>
-                    <a:lnR w="6350" cap="flat" cmpd="sng" algn="ctr">
-                      <a:solidFill>
-                        <a:srgbClr val="CCCCCC"/>
-                      </a:solidFill>
-                      <a:prstDash val="solid"/>
-                      <a:round/>
-                      <a:headEnd type="none" w="med" len="med"/>
-                      <a:tailEnd type="none" w="med" len="med"/>
-                    </a:lnR>
-                    <a:lnT w="6350" cap="flat" cmpd="sng" algn="ctr">
-                      <a:solidFill>
-                        <a:srgbClr val="CCCCCC"/>
-                      </a:solidFill>
-                      <a:prstDash val="solid"/>
-                      <a:round/>
-                      <a:headEnd type="none" w="med" len="med"/>
-                      <a:tailEnd type="none" w="med" len="med"/>
-                    </a:lnT>
-                    <a:lnB w="6350" cap="flat" cmpd="sng" algn="ctr">
-                      <a:solidFill>
-                        <a:srgbClr val="CCCCCC"/>
-                      </a:solidFill>
-                      <a:prstDash val="solid"/>
-                      <a:round/>
-                      <a:headEnd type="none" w="med" len="med"/>
-                      <a:tailEnd type="none" w="med" len="med"/>
-                    </a:lnB>
-                  </a:tcPr>
-                </a:tc>
-                <a:tc>
-                  <a:txBody>
-                    <a:bodyPr/>
-                    <a:lstStyle/>
-                    <a:p>
-                      <a:pPr algn="ctr" indent="0" marL="0">
-                        <a:buNone/>
-                      </a:pPr>
-                      <a:r>
-                        <a:rPr lang="en-US" sz="900" dirty="0">
-                          <a:solidFill>
-                            <a:srgbClr val="2C2C2C"/>
-                          </a:solidFill>
-                        </a:rPr>
-                        <a:t>16</a:t>
-                      </a:r>
-                      <a:endParaRPr lang="en-US" sz="900" dirty="0"/>
-                    </a:p>
-                  </a:txBody>
-                  <a:tcPr marL="91440" marR="91440" marT="45720" marB="45720">
-                    <a:lnL w="6350" cap="flat" cmpd="sng" algn="ctr">
-                      <a:solidFill>
-                        <a:srgbClr val="CCCCCC"/>
-                      </a:solidFill>
-                      <a:prstDash val="solid"/>
-                      <a:round/>
-                      <a:headEnd type="none" w="med" len="med"/>
-                      <a:tailEnd type="none" w="med" len="med"/>
-                    </a:lnL>
-                    <a:lnR w="6350" cap="flat" cmpd="sng" algn="ctr">
-                      <a:solidFill>
-                        <a:srgbClr val="CCCCCC"/>
-                      </a:solidFill>
-                      <a:prstDash val="solid"/>
-                      <a:round/>
-                      <a:headEnd type="none" w="med" len="med"/>
-                      <a:tailEnd type="none" w="med" len="med"/>
-                    </a:lnR>
-                    <a:lnT w="6350" cap="flat" cmpd="sng" algn="ctr">
-                      <a:solidFill>
-                        <a:srgbClr val="CCCCCC"/>
-                      </a:solidFill>
-                      <a:prstDash val="solid"/>
-                      <a:round/>
-                      <a:headEnd type="none" w="med" len="med"/>
-                      <a:tailEnd type="none" w="med" len="med"/>
-                    </a:lnT>
-                    <a:lnB w="6350" cap="flat" cmpd="sng" algn="ctr">
-                      <a:solidFill>
-                        <a:srgbClr val="CCCCCC"/>
-                      </a:solidFill>
-                      <a:prstDash val="solid"/>
-                      <a:round/>
-                      <a:headEnd type="none" w="med" len="med"/>
-                      <a:tailEnd type="none" w="med" len="med"/>
-                    </a:lnB>
-                  </a:tcPr>
-                </a:tc>
-                <a:tc>
-                  <a:txBody>
-                    <a:bodyPr/>
-                    <a:lstStyle/>
-                    <a:p>
-                      <a:pPr algn="ctr" indent="0" marL="0">
-                        <a:buNone/>
-                      </a:pPr>
-                      <a:r>
-                        <a:rPr lang="en-US" sz="900" dirty="0">
-                          <a:solidFill>
-                            <a:srgbClr val="2C2C2C"/>
-                          </a:solidFill>
-                        </a:rPr>
-                        <a:t>75</a:t>
-                      </a:r>
-                      <a:endParaRPr lang="en-US" sz="900" dirty="0"/>
-                    </a:p>
-                  </a:txBody>
-                  <a:tcPr marL="91440" marR="91440" marT="45720" marB="45720">
-                    <a:lnL w="6350" cap="flat" cmpd="sng" algn="ctr">
-                      <a:solidFill>
-                        <a:srgbClr val="CCCCCC"/>
-                      </a:solidFill>
-                      <a:prstDash val="solid"/>
-                      <a:round/>
-                      <a:headEnd type="none" w="med" len="med"/>
-                      <a:tailEnd type="none" w="med" len="med"/>
-                    </a:lnL>
-                    <a:lnR w="6350" cap="flat" cmpd="sng" algn="ctr">
-                      <a:solidFill>
-                        <a:srgbClr val="CCCCCC"/>
-                      </a:solidFill>
-                      <a:prstDash val="solid"/>
-                      <a:round/>
-                      <a:headEnd type="none" w="med" len="med"/>
-                      <a:tailEnd type="none" w="med" len="med"/>
-                    </a:lnR>
-                    <a:lnT w="6350" cap="flat" cmpd="sng" algn="ctr">
-                      <a:solidFill>
-                        <a:srgbClr val="CCCCCC"/>
-                      </a:solidFill>
-                      <a:prstDash val="solid"/>
-                      <a:round/>
-                      <a:headEnd type="none" w="med" len="med"/>
-                      <a:tailEnd type="none" w="med" len="med"/>
-                    </a:lnT>
-                    <a:lnB w="6350" cap="flat" cmpd="sng" algn="ctr">
-                      <a:solidFill>
-                        <a:srgbClr val="CCCCCC"/>
-                      </a:solidFill>
-                      <a:prstDash val="solid"/>
-                      <a:round/>
-                      <a:headEnd type="none" w="med" len="med"/>
-                      <a:tailEnd type="none" w="med" len="med"/>
-                    </a:lnB>
-                  </a:tcPr>
-                </a:tc>
-                <a:tc>
-                  <a:txBody>
-                    <a:bodyPr/>
-                    <a:lstStyle/>
-                    <a:p>
-                      <a:pPr algn="ctr" indent="0" marL="0">
-                        <a:buNone/>
-                      </a:pPr>
-                      <a:r>
-                        <a:rPr lang="en-US" sz="900" dirty="0">
-                          <a:solidFill>
-                            <a:srgbClr val="2C2C2C"/>
-                          </a:solidFill>
-                        </a:rPr>
-                        <a:t>10</a:t>
                       </a:r>
                       <a:endParaRPr lang="en-US" sz="900" dirty="0"/>
                     </a:p>
@@ -9485,7 +9485,7 @@
                             <a:srgbClr val="2C2C2C"/>
                           </a:solidFill>
                         </a:rPr>
-                        <a:t>11</a:t>
+                        <a:t>12</a:t>
                       </a:r>
                       <a:endParaRPr lang="en-US" sz="900" dirty="0"/>
                     </a:p>
@@ -9893,7 +9893,7 @@
                             <a:srgbClr val="2C2C2C"/>
                           </a:solidFill>
                         </a:rPr>
-                        <a:t>13</a:t>
+                        <a:t>14</a:t>
                       </a:r>
                       <a:endParaRPr lang="en-US" sz="900" dirty="0"/>
                     </a:p>
@@ -11776,7 +11776,7 @@
         </p:nvSpPr>
         <p:spPr>
           <a:xfrm>
-            <a:off x="8092440" y="3977640"/>
+            <a:off x="3012440" y="2202628"/>
             <a:ext cx="274320" cy="274320"/>
           </a:xfrm>
           <a:prstGeom prst="ellipse">
@@ -11791,6 +11791,62 @@
       <p:sp>
         <p:nvSpPr>
           <p:cNvPr id="12" name="Text 10"/>
+          <p:cNvSpPr/>
+          <p:nvPr/>
+        </p:nvSpPr>
+        <p:spPr>
+          <a:xfrm>
+            <a:off x="2783840" y="1928308"/>
+            <a:ext cx="731520" cy="182880"/>
+          </a:xfrm>
+          <a:prstGeom prst="rect">
+            <a:avLst/>
+          </a:prstGeom>
+          <a:noFill/>
+          <a:ln/>
+        </p:spPr>
+        <p:txBody>
+          <a:bodyPr wrap="square" rtlCol="0" anchor="ctr"/>
+          <a:lstStyle/>
+          <a:p>
+            <a:pPr algn="ctr" indent="0" marL="0">
+              <a:buNone/>
+            </a:pPr>
+            <a:r>
+              <a:rPr lang="en-US" sz="600" dirty="0">
+                <a:solidFill>
+                  <a:srgbClr val="2C2C2C"/>
+                </a:solidFill>
+              </a:rPr>
+              <a:t>Fizzz3</a:t>
+            </a:r>
+            <a:endParaRPr lang="en-US" sz="600" dirty="0"/>
+          </a:p>
+        </p:txBody>
+      </p:sp>
+      <p:sp>
+        <p:nvSpPr>
+          <p:cNvPr id="13" name="Shape 11"/>
+          <p:cNvSpPr/>
+          <p:nvPr/>
+        </p:nvSpPr>
+        <p:spPr>
+          <a:xfrm>
+            <a:off x="8092440" y="3977640"/>
+            <a:ext cx="274320" cy="274320"/>
+          </a:xfrm>
+          <a:prstGeom prst="ellipse">
+            <a:avLst/>
+          </a:prstGeom>
+          <a:solidFill>
+            <a:srgbClr val="DC1A41"/>
+          </a:solidFill>
+          <a:ln/>
+        </p:spPr>
+      </p:sp>
+      <p:sp>
+        <p:nvSpPr>
+          <p:cNvPr id="14" name="Text 12"/>
           <p:cNvSpPr/>
           <p:nvPr/>
         </p:nvSpPr>
@@ -11819,62 +11875,6 @@
                 </a:solidFill>
               </a:rPr>
               <a:t>Capn'Kirk</a:t>
-            </a:r>
-            <a:endParaRPr lang="en-US" sz="600" dirty="0"/>
-          </a:p>
-        </p:txBody>
-      </p:sp>
-      <p:sp>
-        <p:nvSpPr>
-          <p:cNvPr id="13" name="Shape 11"/>
-          <p:cNvSpPr/>
-          <p:nvPr/>
-        </p:nvSpPr>
-        <p:spPr>
-          <a:xfrm>
-            <a:off x="3012440" y="2202628"/>
-            <a:ext cx="274320" cy="274320"/>
-          </a:xfrm>
-          <a:prstGeom prst="ellipse">
-            <a:avLst/>
-          </a:prstGeom>
-          <a:solidFill>
-            <a:srgbClr val="DC1A41"/>
-          </a:solidFill>
-          <a:ln/>
-        </p:spPr>
-      </p:sp>
-      <p:sp>
-        <p:nvSpPr>
-          <p:cNvPr id="14" name="Text 12"/>
-          <p:cNvSpPr/>
-          <p:nvPr/>
-        </p:nvSpPr>
-        <p:spPr>
-          <a:xfrm>
-            <a:off x="2783840" y="1928308"/>
-            <a:ext cx="731520" cy="182880"/>
-          </a:xfrm>
-          <a:prstGeom prst="rect">
-            <a:avLst/>
-          </a:prstGeom>
-          <a:noFill/>
-          <a:ln/>
-        </p:spPr>
-        <p:txBody>
-          <a:bodyPr wrap="square" rtlCol="0" anchor="ctr"/>
-          <a:lstStyle/>
-          <a:p>
-            <a:pPr algn="ctr" indent="0" marL="0">
-              <a:buNone/>
-            </a:pPr>
-            <a:r>
-              <a:rPr lang="en-US" sz="600" dirty="0">
-                <a:solidFill>
-                  <a:srgbClr val="2C2C2C"/>
-                </a:solidFill>
-              </a:rPr>
-              <a:t>Fizzz3</a:t>
             </a:r>
             <a:endParaRPr lang="en-US" sz="600" dirty="0"/>
           </a:p>
@@ -12504,6 +12504,118 @@
                   <a:srgbClr val="2C2C2C"/>
                 </a:solidFill>
               </a:rPr>
+              <a:t>Fizzz3</a:t>
+            </a:r>
+            <a:endParaRPr lang="en-US" sz="800" dirty="0"/>
+          </a:p>
+        </p:txBody>
+      </p:sp>
+      <p:sp>
+        <p:nvSpPr>
+          <p:cNvPr id="10" name="Shape 8"/>
+          <p:cNvSpPr/>
+          <p:nvPr/>
+        </p:nvSpPr>
+        <p:spPr>
+          <a:xfrm>
+            <a:off x="2103120" y="1371600"/>
+            <a:ext cx="4853940" cy="109728"/>
+          </a:xfrm>
+          <a:prstGeom prst="rect">
+            <a:avLst/>
+          </a:prstGeom>
+          <a:solidFill>
+            <a:srgbClr val="2B5A7E"/>
+          </a:solidFill>
+          <a:ln/>
+        </p:spPr>
+      </p:sp>
+      <p:sp>
+        <p:nvSpPr>
+          <p:cNvPr id="11" name="Shape 9"/>
+          <p:cNvSpPr/>
+          <p:nvPr/>
+        </p:nvSpPr>
+        <p:spPr>
+          <a:xfrm>
+            <a:off x="6957060" y="1371600"/>
+            <a:ext cx="3537857" cy="109728"/>
+          </a:xfrm>
+          <a:prstGeom prst="rect">
+            <a:avLst/>
+          </a:prstGeom>
+          <a:solidFill>
+            <a:srgbClr val="DC1A41"/>
+          </a:solidFill>
+          <a:ln/>
+        </p:spPr>
+      </p:sp>
+      <p:sp>
+        <p:nvSpPr>
+          <p:cNvPr id="12" name="Text 10"/>
+          <p:cNvSpPr/>
+          <p:nvPr/>
+        </p:nvSpPr>
+        <p:spPr>
+          <a:xfrm>
+            <a:off x="10586357" y="1344168"/>
+            <a:ext cx="548640" cy="292608"/>
+          </a:xfrm>
+          <a:prstGeom prst="rect">
+            <a:avLst/>
+          </a:prstGeom>
+          <a:noFill/>
+          <a:ln/>
+        </p:spPr>
+        <p:txBody>
+          <a:bodyPr wrap="square" rtlCol="0" anchor="ctr"/>
+          <a:lstStyle/>
+          <a:p>
+            <a:pPr indent="0" marL="0">
+              <a:buNone/>
+            </a:pPr>
+            <a:r>
+              <a:rPr lang="en-US" sz="800" b="1" dirty="0">
+                <a:solidFill>
+                  <a:srgbClr val="2C2C2C"/>
+                </a:solidFill>
+              </a:rPr>
+              <a:t>74</a:t>
+            </a:r>
+            <a:endParaRPr lang="en-US" sz="800" dirty="0"/>
+          </a:p>
+        </p:txBody>
+      </p:sp>
+      <p:sp>
+        <p:nvSpPr>
+          <p:cNvPr id="13" name="Text 11"/>
+          <p:cNvSpPr/>
+          <p:nvPr/>
+        </p:nvSpPr>
+        <p:spPr>
+          <a:xfrm>
+            <a:off x="365760" y="1728216"/>
+            <a:ext cx="1645920" cy="292608"/>
+          </a:xfrm>
+          <a:prstGeom prst="rect">
+            <a:avLst/>
+          </a:prstGeom>
+          <a:noFill/>
+          <a:ln/>
+        </p:spPr>
+        <p:txBody>
+          <a:bodyPr wrap="square" rtlCol="0" anchor="ctr"/>
+          <a:lstStyle/>
+          <a:p>
+            <a:pPr algn="r" indent="0" marL="0">
+              <a:buNone/>
+            </a:pPr>
+            <a:r>
+              <a:rPr lang="en-US" sz="800" dirty="0">
+                <a:solidFill>
+                  <a:srgbClr val="2C2C2C"/>
+                </a:solidFill>
+              </a:rPr>
               <a:t>Capn'Kirk</a:t>
             </a:r>
             <a:endParaRPr lang="en-US" sz="800" dirty="0"/>
@@ -12512,13 +12624,13 @@
       </p:sp>
       <p:sp>
         <p:nvSpPr>
-          <p:cNvPr id="10" name="Shape 8"/>
-          <p:cNvSpPr/>
-          <p:nvPr/>
-        </p:nvSpPr>
-        <p:spPr>
-          <a:xfrm>
-            <a:off x="2103120" y="1371600"/>
+          <p:cNvPr id="14" name="Shape 12"/>
+          <p:cNvSpPr/>
+          <p:nvPr/>
+        </p:nvSpPr>
+        <p:spPr>
+          <a:xfrm>
+            <a:off x="2103120" y="1755648"/>
             <a:ext cx="6141720" cy="109728"/>
           </a:xfrm>
           <a:prstGeom prst="rect">
@@ -12532,13 +12644,13 @@
       </p:sp>
       <p:sp>
         <p:nvSpPr>
-          <p:cNvPr id="11" name="Shape 9"/>
-          <p:cNvSpPr/>
-          <p:nvPr/>
-        </p:nvSpPr>
-        <p:spPr>
-          <a:xfrm>
-            <a:off x="8244840" y="1371600"/>
+          <p:cNvPr id="15" name="Shape 13"/>
+          <p:cNvSpPr/>
+          <p:nvPr/>
+        </p:nvSpPr>
+        <p:spPr>
+          <a:xfrm>
+            <a:off x="8244840" y="1755648"/>
             <a:ext cx="0" cy="109728"/>
           </a:xfrm>
           <a:prstGeom prst="rect">
@@ -12552,13 +12664,13 @@
       </p:sp>
       <p:sp>
         <p:nvSpPr>
-          <p:cNvPr id="12" name="Text 10"/>
-          <p:cNvSpPr/>
-          <p:nvPr/>
-        </p:nvSpPr>
-        <p:spPr>
-          <a:xfrm>
-            <a:off x="8336280" y="1344168"/>
+          <p:cNvPr id="16" name="Text 14"/>
+          <p:cNvSpPr/>
+          <p:nvPr/>
+        </p:nvSpPr>
+        <p:spPr>
+          <a:xfrm>
+            <a:off x="8336280" y="1728216"/>
             <a:ext cx="548640" cy="292608"/>
           </a:xfrm>
           <a:prstGeom prst="rect">
@@ -12581,118 +12693,6 @@
                 </a:solidFill>
               </a:rPr>
               <a:t>62</a:t>
-            </a:r>
-            <a:endParaRPr lang="en-US" sz="800" dirty="0"/>
-          </a:p>
-        </p:txBody>
-      </p:sp>
-      <p:sp>
-        <p:nvSpPr>
-          <p:cNvPr id="13" name="Text 11"/>
-          <p:cNvSpPr/>
-          <p:nvPr/>
-        </p:nvSpPr>
-        <p:spPr>
-          <a:xfrm>
-            <a:off x="365760" y="1728216"/>
-            <a:ext cx="1645920" cy="292608"/>
-          </a:xfrm>
-          <a:prstGeom prst="rect">
-            <a:avLst/>
-          </a:prstGeom>
-          <a:noFill/>
-          <a:ln/>
-        </p:spPr>
-        <p:txBody>
-          <a:bodyPr wrap="square" rtlCol="0" anchor="ctr"/>
-          <a:lstStyle/>
-          <a:p>
-            <a:pPr algn="r" indent="0" marL="0">
-              <a:buNone/>
-            </a:pPr>
-            <a:r>
-              <a:rPr lang="en-US" sz="800" dirty="0">
-                <a:solidFill>
-                  <a:srgbClr val="2C2C2C"/>
-                </a:solidFill>
-              </a:rPr>
-              <a:t>Fizzz3</a:t>
-            </a:r>
-            <a:endParaRPr lang="en-US" sz="800" dirty="0"/>
-          </a:p>
-        </p:txBody>
-      </p:sp>
-      <p:sp>
-        <p:nvSpPr>
-          <p:cNvPr id="14" name="Shape 12"/>
-          <p:cNvSpPr/>
-          <p:nvPr/>
-        </p:nvSpPr>
-        <p:spPr>
-          <a:xfrm>
-            <a:off x="2103120" y="1755648"/>
-            <a:ext cx="4853940" cy="109728"/>
-          </a:xfrm>
-          <a:prstGeom prst="rect">
-            <a:avLst/>
-          </a:prstGeom>
-          <a:solidFill>
-            <a:srgbClr val="2B5A7E"/>
-          </a:solidFill>
-          <a:ln/>
-        </p:spPr>
-      </p:sp>
-      <p:sp>
-        <p:nvSpPr>
-          <p:cNvPr id="15" name="Shape 13"/>
-          <p:cNvSpPr/>
-          <p:nvPr/>
-        </p:nvSpPr>
-        <p:spPr>
-          <a:xfrm>
-            <a:off x="6957060" y="1755648"/>
-            <a:ext cx="3537857" cy="109728"/>
-          </a:xfrm>
-          <a:prstGeom prst="rect">
-            <a:avLst/>
-          </a:prstGeom>
-          <a:solidFill>
-            <a:srgbClr val="DC1A41"/>
-          </a:solidFill>
-          <a:ln/>
-        </p:spPr>
-      </p:sp>
-      <p:sp>
-        <p:nvSpPr>
-          <p:cNvPr id="16" name="Text 14"/>
-          <p:cNvSpPr/>
-          <p:nvPr/>
-        </p:nvSpPr>
-        <p:spPr>
-          <a:xfrm>
-            <a:off x="10586357" y="1728216"/>
-            <a:ext cx="548640" cy="292608"/>
-          </a:xfrm>
-          <a:prstGeom prst="rect">
-            <a:avLst/>
-          </a:prstGeom>
-          <a:noFill/>
-          <a:ln/>
-        </p:spPr>
-        <p:txBody>
-          <a:bodyPr wrap="square" rtlCol="0" anchor="ctr"/>
-          <a:lstStyle/>
-          <a:p>
-            <a:pPr indent="0" marL="0">
-              <a:buNone/>
-            </a:pPr>
-            <a:r>
-              <a:rPr lang="en-US" sz="800" b="1" dirty="0">
-                <a:solidFill>
-                  <a:srgbClr val="2C2C2C"/>
-                </a:solidFill>
-              </a:rPr>
-              <a:t>74</a:t>
             </a:r>
             <a:endParaRPr lang="en-US" sz="800" dirty="0"/>
           </a:p>
@@ -15627,7 +15627,7 @@
                   <a:srgbClr val="DC1A41"/>
                 </a:solidFill>
               </a:rPr>
-              <a:t>80% ceiling</a:t>
+              <a:t>79% ceiling</a:t>
             </a:r>
             <a:endParaRPr lang="en-US" sz="1600" dirty="0"/>
           </a:p>
@@ -15687,6 +15687,159 @@
         <p:spPr>
           <a:xfrm>
             <a:off x="2532888" y="1481328"/>
+            <a:ext cx="1783080" cy="228600"/>
+          </a:xfrm>
+          <a:prstGeom prst="rect">
+            <a:avLst/>
+          </a:prstGeom>
+          <a:noFill/>
+          <a:ln/>
+        </p:spPr>
+        <p:txBody>
+          <a:bodyPr wrap="square" rtlCol="0" anchor="ctr"/>
+          <a:lstStyle/>
+          <a:p>
+            <a:pPr indent="0" marL="0">
+              <a:buNone/>
+            </a:pPr>
+            <a:r>
+              <a:rPr lang="en-US" sz="900" b="1" dirty="0">
+                <a:solidFill>
+                  <a:srgbClr val="2C2C2C"/>
+                </a:solidFill>
+              </a:rPr>
+              <a:t>Fizzz3</a:t>
+            </a:r>
+            <a:endParaRPr lang="en-US" sz="900" dirty="0"/>
+          </a:p>
+        </p:txBody>
+      </p:sp>
+      <p:sp>
+        <p:nvSpPr>
+          <p:cNvPr id="14" name="Text 12"/>
+          <p:cNvSpPr/>
+          <p:nvPr/>
+        </p:nvSpPr>
+        <p:spPr>
+          <a:xfrm>
+            <a:off x="2532888" y="1737360"/>
+            <a:ext cx="1783080" cy="274320"/>
+          </a:xfrm>
+          <a:prstGeom prst="rect">
+            <a:avLst/>
+          </a:prstGeom>
+          <a:noFill/>
+          <a:ln/>
+        </p:spPr>
+        <p:txBody>
+          <a:bodyPr wrap="square" rtlCol="0" anchor="ctr"/>
+          <a:lstStyle/>
+          <a:p>
+            <a:pPr indent="0" marL="0">
+              <a:buNone/>
+            </a:pPr>
+            <a:r>
+              <a:rPr lang="en-US" sz="800" dirty="0">
+                <a:solidFill>
+                  <a:srgbClr val="6B6B6B"/>
+                </a:solidFill>
+              </a:rPr>
+              <a:t>Arizona Wildcats</a:t>
+            </a:r>
+            <a:endParaRPr lang="en-US" sz="800" dirty="0"/>
+          </a:p>
+        </p:txBody>
+      </p:sp>
+      <p:sp>
+        <p:nvSpPr>
+          <p:cNvPr id="15" name="Text 13"/>
+          <p:cNvSpPr/>
+          <p:nvPr/>
+        </p:nvSpPr>
+        <p:spPr>
+          <a:xfrm>
+            <a:off x="2532888" y="2057400"/>
+            <a:ext cx="1783080" cy="320040"/>
+          </a:xfrm>
+          <a:prstGeom prst="rect">
+            <a:avLst/>
+          </a:prstGeom>
+          <a:noFill/>
+          <a:ln/>
+        </p:spPr>
+        <p:txBody>
+          <a:bodyPr wrap="square" rtlCol="0" anchor="ctr"/>
+          <a:lstStyle/>
+          <a:p>
+            <a:pPr indent="0" marL="0">
+              <a:buNone/>
+            </a:pPr>
+            <a:r>
+              <a:rPr lang="en-US" sz="1600" b="1" dirty="0">
+                <a:solidFill>
+                  <a:srgbClr val="DC1A41"/>
+                </a:solidFill>
+              </a:rPr>
+              <a:t>78% ceiling</a:t>
+            </a:r>
+            <a:endParaRPr lang="en-US" sz="1600" dirty="0"/>
+          </a:p>
+        </p:txBody>
+      </p:sp>
+      <p:sp>
+        <p:nvSpPr>
+          <p:cNvPr id="16" name="Shape 14"/>
+          <p:cNvSpPr/>
+          <p:nvPr/>
+        </p:nvSpPr>
+        <p:spPr>
+          <a:xfrm>
+            <a:off x="4480560" y="1371600"/>
+            <a:ext cx="1965960" cy="1280160"/>
+          </a:xfrm>
+          <a:prstGeom prst="rect">
+            <a:avLst/>
+          </a:prstGeom>
+          <a:solidFill>
+            <a:srgbClr val="FFFFFF"/>
+          </a:solidFill>
+          <a:ln w="12700">
+            <a:solidFill>
+              <a:srgbClr val="CCCCCC"/>
+            </a:solidFill>
+            <a:prstDash val="solid"/>
+          </a:ln>
+        </p:spPr>
+      </p:sp>
+      <p:sp>
+        <p:nvSpPr>
+          <p:cNvPr id="17" name="Shape 15"/>
+          <p:cNvSpPr/>
+          <p:nvPr/>
+        </p:nvSpPr>
+        <p:spPr>
+          <a:xfrm>
+            <a:off x="4480560" y="1371600"/>
+            <a:ext cx="73152" cy="1280160"/>
+          </a:xfrm>
+          <a:prstGeom prst="rect">
+            <a:avLst/>
+          </a:prstGeom>
+          <a:solidFill>
+            <a:srgbClr val="DC1A41"/>
+          </a:solidFill>
+          <a:ln/>
+        </p:spPr>
+      </p:sp>
+      <p:sp>
+        <p:nvSpPr>
+          <p:cNvPr id="18" name="Text 16"/>
+          <p:cNvSpPr/>
+          <p:nvPr/>
+        </p:nvSpPr>
+        <p:spPr>
+          <a:xfrm>
+            <a:off x="4590288" y="1481328"/>
             <a:ext cx="1783080" cy="228600"/>
           </a:xfrm>
           <a:prstGeom prst="rect">
@@ -15716,13 +15869,13 @@
       </p:sp>
       <p:sp>
         <p:nvSpPr>
-          <p:cNvPr id="14" name="Text 12"/>
-          <p:cNvSpPr/>
-          <p:nvPr/>
-        </p:nvSpPr>
-        <p:spPr>
-          <a:xfrm>
-            <a:off x="2532888" y="1737360"/>
+          <p:cNvPr id="19" name="Text 17"/>
+          <p:cNvSpPr/>
+          <p:nvPr/>
+        </p:nvSpPr>
+        <p:spPr>
+          <a:xfrm>
+            <a:off x="4590288" y="1737360"/>
             <a:ext cx="1783080" cy="274320"/>
           </a:xfrm>
           <a:prstGeom prst="rect">
@@ -15752,13 +15905,13 @@
       </p:sp>
       <p:sp>
         <p:nvSpPr>
-          <p:cNvPr id="15" name="Text 13"/>
-          <p:cNvSpPr/>
-          <p:nvPr/>
-        </p:nvSpPr>
-        <p:spPr>
-          <a:xfrm>
-            <a:off x="2532888" y="2057400"/>
+          <p:cNvPr id="20" name="Text 18"/>
+          <p:cNvSpPr/>
+          <p:nvPr/>
+        </p:nvSpPr>
+        <p:spPr>
+          <a:xfrm>
+            <a:off x="4590288" y="2057400"/>
             <a:ext cx="1783080" cy="320040"/>
           </a:xfrm>
           <a:prstGeom prst="rect">
@@ -15788,13 +15941,13 @@
       </p:sp>
       <p:sp>
         <p:nvSpPr>
-          <p:cNvPr id="16" name="Shape 14"/>
-          <p:cNvSpPr/>
-          <p:nvPr/>
-        </p:nvSpPr>
-        <p:spPr>
-          <a:xfrm>
-            <a:off x="4480560" y="1371600"/>
+          <p:cNvPr id="21" name="Shape 19"/>
+          <p:cNvSpPr/>
+          <p:nvPr/>
+        </p:nvSpPr>
+        <p:spPr>
+          <a:xfrm>
+            <a:off x="6537960" y="1371600"/>
             <a:ext cx="1965960" cy="1280160"/>
           </a:xfrm>
           <a:prstGeom prst="rect">
@@ -15813,13 +15966,13 @@
       </p:sp>
       <p:sp>
         <p:nvSpPr>
-          <p:cNvPr id="17" name="Shape 15"/>
-          <p:cNvSpPr/>
-          <p:nvPr/>
-        </p:nvSpPr>
-        <p:spPr>
-          <a:xfrm>
-            <a:off x="4480560" y="1371600"/>
+          <p:cNvPr id="22" name="Shape 20"/>
+          <p:cNvSpPr/>
+          <p:nvPr/>
+        </p:nvSpPr>
+        <p:spPr>
+          <a:xfrm>
+            <a:off x="6537960" y="1371600"/>
             <a:ext cx="73152" cy="1280160"/>
           </a:xfrm>
           <a:prstGeom prst="rect">
@@ -15833,13 +15986,13 @@
       </p:sp>
       <p:sp>
         <p:nvSpPr>
-          <p:cNvPr id="18" name="Text 16"/>
-          <p:cNvSpPr/>
-          <p:nvPr/>
-        </p:nvSpPr>
-        <p:spPr>
-          <a:xfrm>
-            <a:off x="4590288" y="1481328"/>
+          <p:cNvPr id="23" name="Text 21"/>
+          <p:cNvSpPr/>
+          <p:nvPr/>
+        </p:nvSpPr>
+        <p:spPr>
+          <a:xfrm>
+            <a:off x="6647688" y="1481328"/>
             <a:ext cx="1783080" cy="228600"/>
           </a:xfrm>
           <a:prstGeom prst="rect">
@@ -15861,7 +16014,7 @@
                   <a:srgbClr val="2C2C2C"/>
                 </a:solidFill>
               </a:rPr>
-              <a:t>Fizzz3</a:t>
+              <a:t>Paul233365</a:t>
             </a:r>
             <a:endParaRPr lang="en-US" sz="900" dirty="0"/>
           </a:p>
@@ -15869,13 +16022,13 @@
       </p:sp>
       <p:sp>
         <p:nvSpPr>
-          <p:cNvPr id="19" name="Text 17"/>
-          <p:cNvSpPr/>
-          <p:nvPr/>
-        </p:nvSpPr>
-        <p:spPr>
-          <a:xfrm>
-            <a:off x="4590288" y="1737360"/>
+          <p:cNvPr id="24" name="Text 22"/>
+          <p:cNvSpPr/>
+          <p:nvPr/>
+        </p:nvSpPr>
+        <p:spPr>
+          <a:xfrm>
+            <a:off x="6647688" y="1737360"/>
             <a:ext cx="1783080" cy="274320"/>
           </a:xfrm>
           <a:prstGeom prst="rect">
@@ -15905,13 +16058,13 @@
       </p:sp>
       <p:sp>
         <p:nvSpPr>
-          <p:cNvPr id="20" name="Text 18"/>
-          <p:cNvSpPr/>
-          <p:nvPr/>
-        </p:nvSpPr>
-        <p:spPr>
-          <a:xfrm>
-            <a:off x="4590288" y="2057400"/>
+          <p:cNvPr id="25" name="Text 23"/>
+          <p:cNvSpPr/>
+          <p:nvPr/>
+        </p:nvSpPr>
+        <p:spPr>
+          <a:xfrm>
+            <a:off x="6647688" y="2057400"/>
             <a:ext cx="1783080" cy="320040"/>
           </a:xfrm>
           <a:prstGeom prst="rect">
@@ -15933,160 +16086,7 @@
                   <a:srgbClr val="DC1A41"/>
                 </a:solidFill>
               </a:rPr>
-              <a:t>86% ceiling</a:t>
-            </a:r>
-            <a:endParaRPr lang="en-US" sz="1600" dirty="0"/>
-          </a:p>
-        </p:txBody>
-      </p:sp>
-      <p:sp>
-        <p:nvSpPr>
-          <p:cNvPr id="21" name="Shape 19"/>
-          <p:cNvSpPr/>
-          <p:nvPr/>
-        </p:nvSpPr>
-        <p:spPr>
-          <a:xfrm>
-            <a:off x="6537960" y="1371600"/>
-            <a:ext cx="1965960" cy="1280160"/>
-          </a:xfrm>
-          <a:prstGeom prst="rect">
-            <a:avLst/>
-          </a:prstGeom>
-          <a:solidFill>
-            <a:srgbClr val="FFFFFF"/>
-          </a:solidFill>
-          <a:ln w="12700">
-            <a:solidFill>
-              <a:srgbClr val="CCCCCC"/>
-            </a:solidFill>
-            <a:prstDash val="solid"/>
-          </a:ln>
-        </p:spPr>
-      </p:sp>
-      <p:sp>
-        <p:nvSpPr>
-          <p:cNvPr id="22" name="Shape 20"/>
-          <p:cNvSpPr/>
-          <p:nvPr/>
-        </p:nvSpPr>
-        <p:spPr>
-          <a:xfrm>
-            <a:off x="6537960" y="1371600"/>
-            <a:ext cx="73152" cy="1280160"/>
-          </a:xfrm>
-          <a:prstGeom prst="rect">
-            <a:avLst/>
-          </a:prstGeom>
-          <a:solidFill>
-            <a:srgbClr val="DC1A41"/>
-          </a:solidFill>
-          <a:ln/>
-        </p:spPr>
-      </p:sp>
-      <p:sp>
-        <p:nvSpPr>
-          <p:cNvPr id="23" name="Text 21"/>
-          <p:cNvSpPr/>
-          <p:nvPr/>
-        </p:nvSpPr>
-        <p:spPr>
-          <a:xfrm>
-            <a:off x="6647688" y="1481328"/>
-            <a:ext cx="1783080" cy="228600"/>
-          </a:xfrm>
-          <a:prstGeom prst="rect">
-            <a:avLst/>
-          </a:prstGeom>
-          <a:noFill/>
-          <a:ln/>
-        </p:spPr>
-        <p:txBody>
-          <a:bodyPr wrap="square" rtlCol="0" anchor="ctr"/>
-          <a:lstStyle/>
-          <a:p>
-            <a:pPr indent="0" marL="0">
-              <a:buNone/>
-            </a:pPr>
-            <a:r>
-              <a:rPr lang="en-US" sz="900" b="1" dirty="0">
-                <a:solidFill>
-                  <a:srgbClr val="2C2C2C"/>
-                </a:solidFill>
-              </a:rPr>
-              <a:t>Paul233365</a:t>
-            </a:r>
-            <a:endParaRPr lang="en-US" sz="900" dirty="0"/>
-          </a:p>
-        </p:txBody>
-      </p:sp>
-      <p:sp>
-        <p:nvSpPr>
-          <p:cNvPr id="24" name="Text 22"/>
-          <p:cNvSpPr/>
-          <p:nvPr/>
-        </p:nvSpPr>
-        <p:spPr>
-          <a:xfrm>
-            <a:off x="6647688" y="1737360"/>
-            <a:ext cx="1783080" cy="274320"/>
-          </a:xfrm>
-          <a:prstGeom prst="rect">
-            <a:avLst/>
-          </a:prstGeom>
-          <a:noFill/>
-          <a:ln/>
-        </p:spPr>
-        <p:txBody>
-          <a:bodyPr wrap="square" rtlCol="0" anchor="ctr"/>
-          <a:lstStyle/>
-          <a:p>
-            <a:pPr indent="0" marL="0">
-              <a:buNone/>
-            </a:pPr>
-            <a:r>
-              <a:rPr lang="en-US" sz="800" dirty="0">
-                <a:solidFill>
-                  <a:srgbClr val="6B6B6B"/>
-                </a:solidFill>
-              </a:rPr>
-              <a:t>Arizona Wildcats</a:t>
-            </a:r>
-            <a:endParaRPr lang="en-US" sz="800" dirty="0"/>
-          </a:p>
-        </p:txBody>
-      </p:sp>
-      <p:sp>
-        <p:nvSpPr>
-          <p:cNvPr id="25" name="Text 23"/>
-          <p:cNvSpPr/>
-          <p:nvPr/>
-        </p:nvSpPr>
-        <p:spPr>
-          <a:xfrm>
-            <a:off x="6647688" y="2057400"/>
-            <a:ext cx="1783080" cy="320040"/>
-          </a:xfrm>
-          <a:prstGeom prst="rect">
-            <a:avLst/>
-          </a:prstGeom>
-          <a:noFill/>
-          <a:ln/>
-        </p:spPr>
-        <p:txBody>
-          <a:bodyPr wrap="square" rtlCol="0" anchor="ctr"/>
-          <a:lstStyle/>
-          <a:p>
-            <a:pPr indent="0" marL="0">
-              <a:buNone/>
-            </a:pPr>
-            <a:r>
-              <a:rPr lang="en-US" sz="1600" b="1" dirty="0">
-                <a:solidFill>
-                  <a:srgbClr val="DC1A41"/>
-                </a:solidFill>
-              </a:rPr>
-              <a:t>84% ceiling</a:t>
+              <a:t>77% ceiling</a:t>
             </a:r>
             <a:endParaRPr lang="en-US" sz="1600" dirty="0"/>
           </a:p>
@@ -16239,7 +16239,7 @@
                   <a:srgbClr val="DC1A41"/>
                 </a:solidFill>
               </a:rPr>
-              <a:t>77% ceiling</a:t>
+              <a:t>88% ceiling</a:t>
             </a:r>
             <a:endParaRPr lang="en-US" sz="1600" dirty="0"/>
           </a:p>
@@ -16392,7 +16392,7 @@
                   <a:srgbClr val="DC1A41"/>
                 </a:solidFill>
               </a:rPr>
-              <a:t>90% ceiling</a:t>
+              <a:t>77% ceiling</a:t>
             </a:r>
             <a:endParaRPr lang="en-US" sz="1600" dirty="0"/>
           </a:p>
@@ -16545,7 +16545,7 @@
                   <a:srgbClr val="DC1A41"/>
                 </a:solidFill>
               </a:rPr>
-              <a:t>78% ceiling</a:t>
+              <a:t>76% ceiling</a:t>
             </a:r>
             <a:endParaRPr lang="en-US" sz="1600" dirty="0"/>
           </a:p>
@@ -16698,7 +16698,7 @@
                   <a:srgbClr val="DC1A41"/>
                 </a:solidFill>
               </a:rPr>
-              <a:t>82% ceiling</a:t>
+              <a:t>84% ceiling</a:t>
             </a:r>
             <a:endParaRPr lang="en-US" sz="1600" dirty="0"/>
           </a:p>
@@ -16971,7 +16971,7 @@
         <p:spPr>
           <a:xfrm>
             <a:off x="8503920" y="987552"/>
-            <a:ext cx="6306671" cy="228600"/>
+            <a:ext cx="6212541" cy="228600"/>
           </a:xfrm>
           <a:prstGeom prst="rect">
             <a:avLst/>
@@ -16990,7 +16990,231 @@
         </p:nvSpPr>
         <p:spPr>
           <a:xfrm>
-            <a:off x="14902031" y="960120"/>
+            <a:off x="14807901" y="960120"/>
+            <a:ext cx="731520" cy="292608"/>
+          </a:xfrm>
+          <a:prstGeom prst="rect">
+            <a:avLst/>
+          </a:prstGeom>
+          <a:noFill/>
+          <a:ln/>
+        </p:spPr>
+        <p:txBody>
+          <a:bodyPr wrap="square" rtlCol="0" anchor="ctr"/>
+          <a:lstStyle/>
+          <a:p>
+            <a:pPr indent="0" marL="0">
+              <a:buNone/>
+            </a:pPr>
+            <a:r>
+              <a:rPr lang="en-US" sz="800" b="1" dirty="0">
+                <a:solidFill>
+                  <a:srgbClr val="2C2C2C"/>
+                </a:solidFill>
+              </a:rPr>
+              <a:t>1770</a:t>
+            </a:r>
+            <a:endParaRPr lang="en-US" sz="800" dirty="0"/>
+          </a:p>
+        </p:txBody>
+      </p:sp>
+      <p:sp>
+        <p:nvSpPr>
+          <p:cNvPr id="9" name="Text 7"/>
+          <p:cNvSpPr/>
+          <p:nvPr/>
+        </p:nvSpPr>
+        <p:spPr>
+          <a:xfrm>
+            <a:off x="365760" y="1344168"/>
+            <a:ext cx="1645920" cy="292608"/>
+          </a:xfrm>
+          <a:prstGeom prst="rect">
+            <a:avLst/>
+          </a:prstGeom>
+          <a:noFill/>
+          <a:ln/>
+        </p:spPr>
+        <p:txBody>
+          <a:bodyPr wrap="square" rtlCol="0" anchor="ctr"/>
+          <a:lstStyle/>
+          <a:p>
+            <a:pPr algn="r" indent="0" marL="0">
+              <a:buNone/>
+            </a:pPr>
+            <a:r>
+              <a:rPr lang="en-US" sz="800" dirty="0">
+                <a:solidFill>
+                  <a:srgbClr val="2C2C2C"/>
+                </a:solidFill>
+              </a:rPr>
+              <a:t>Fizzz3</a:t>
+            </a:r>
+            <a:endParaRPr lang="en-US" sz="800" dirty="0"/>
+          </a:p>
+        </p:txBody>
+      </p:sp>
+      <p:sp>
+        <p:nvSpPr>
+          <p:cNvPr id="10" name="Shape 8"/>
+          <p:cNvSpPr/>
+          <p:nvPr/>
+        </p:nvSpPr>
+        <p:spPr>
+          <a:xfrm>
+            <a:off x="2103120" y="1371600"/>
+            <a:ext cx="6258560" cy="228600"/>
+          </a:xfrm>
+          <a:prstGeom prst="rect">
+            <a:avLst/>
+          </a:prstGeom>
+          <a:solidFill>
+            <a:srgbClr val="2B5A7E"/>
+          </a:solidFill>
+          <a:ln/>
+        </p:spPr>
+      </p:sp>
+      <p:sp>
+        <p:nvSpPr>
+          <p:cNvPr id="11" name="Shape 9"/>
+          <p:cNvSpPr/>
+          <p:nvPr/>
+        </p:nvSpPr>
+        <p:spPr>
+          <a:xfrm>
+            <a:off x="8361680" y="1371600"/>
+            <a:ext cx="6212541" cy="228600"/>
+          </a:xfrm>
+          <a:prstGeom prst="rect">
+            <a:avLst/>
+          </a:prstGeom>
+          <a:solidFill>
+            <a:srgbClr val="E0E0E0"/>
+          </a:solidFill>
+          <a:ln/>
+        </p:spPr>
+      </p:sp>
+      <p:sp>
+        <p:nvSpPr>
+          <p:cNvPr id="12" name="Text 10"/>
+          <p:cNvSpPr/>
+          <p:nvPr/>
+        </p:nvSpPr>
+        <p:spPr>
+          <a:xfrm>
+            <a:off x="14665661" y="1344168"/>
+            <a:ext cx="731520" cy="292608"/>
+          </a:xfrm>
+          <a:prstGeom prst="rect">
+            <a:avLst/>
+          </a:prstGeom>
+          <a:noFill/>
+          <a:ln/>
+        </p:spPr>
+        <p:txBody>
+          <a:bodyPr wrap="square" rtlCol="0" anchor="ctr"/>
+          <a:lstStyle/>
+          <a:p>
+            <a:pPr indent="0" marL="0">
+              <a:buNone/>
+            </a:pPr>
+            <a:r>
+              <a:rPr lang="en-US" sz="800" b="1" dirty="0">
+                <a:solidFill>
+                  <a:srgbClr val="2C2C2C"/>
+                </a:solidFill>
+              </a:rPr>
+              <a:t>1760</a:t>
+            </a:r>
+            <a:endParaRPr lang="en-US" sz="800" dirty="0"/>
+          </a:p>
+        </p:txBody>
+      </p:sp>
+      <p:sp>
+        <p:nvSpPr>
+          <p:cNvPr id="13" name="Text 11"/>
+          <p:cNvSpPr/>
+          <p:nvPr/>
+        </p:nvSpPr>
+        <p:spPr>
+          <a:xfrm>
+            <a:off x="365760" y="1728216"/>
+            <a:ext cx="1645920" cy="292608"/>
+          </a:xfrm>
+          <a:prstGeom prst="rect">
+            <a:avLst/>
+          </a:prstGeom>
+          <a:noFill/>
+          <a:ln/>
+        </p:spPr>
+        <p:txBody>
+          <a:bodyPr wrap="square" rtlCol="0" anchor="ctr"/>
+          <a:lstStyle/>
+          <a:p>
+            <a:pPr algn="r" indent="0" marL="0">
+              <a:buNone/>
+            </a:pPr>
+            <a:r>
+              <a:rPr lang="en-US" sz="800" dirty="0">
+                <a:solidFill>
+                  <a:srgbClr val="2C2C2C"/>
+                </a:solidFill>
+              </a:rPr>
+              <a:t>Capn'Kirk</a:t>
+            </a:r>
+            <a:endParaRPr lang="en-US" sz="800" dirty="0"/>
+          </a:p>
+        </p:txBody>
+      </p:sp>
+      <p:sp>
+        <p:nvSpPr>
+          <p:cNvPr id="14" name="Shape 12"/>
+          <p:cNvSpPr/>
+          <p:nvPr/>
+        </p:nvSpPr>
+        <p:spPr>
+          <a:xfrm>
+            <a:off x="2103120" y="1755648"/>
+            <a:ext cx="6116320" cy="228600"/>
+          </a:xfrm>
+          <a:prstGeom prst="rect">
+            <a:avLst/>
+          </a:prstGeom>
+          <a:solidFill>
+            <a:srgbClr val="2B5A7E"/>
+          </a:solidFill>
+          <a:ln/>
+        </p:spPr>
+      </p:sp>
+      <p:sp>
+        <p:nvSpPr>
+          <p:cNvPr id="15" name="Shape 13"/>
+          <p:cNvSpPr/>
+          <p:nvPr/>
+        </p:nvSpPr>
+        <p:spPr>
+          <a:xfrm>
+            <a:off x="8219440" y="1755648"/>
+            <a:ext cx="6400800" cy="228600"/>
+          </a:xfrm>
+          <a:prstGeom prst="rect">
+            <a:avLst/>
+          </a:prstGeom>
+          <a:solidFill>
+            <a:srgbClr val="E0E0E0"/>
+          </a:solidFill>
+          <a:ln/>
+        </p:spPr>
+      </p:sp>
+      <p:sp>
+        <p:nvSpPr>
+          <p:cNvPr id="16" name="Text 14"/>
+          <p:cNvSpPr/>
+          <p:nvPr/>
+        </p:nvSpPr>
+        <p:spPr>
+          <a:xfrm>
+            <a:off x="14711680" y="1728216"/>
             <a:ext cx="731520" cy="292608"/>
           </a:xfrm>
           <a:prstGeom prst="rect">
@@ -17020,13 +17244,13 @@
       </p:sp>
       <p:sp>
         <p:nvSpPr>
-          <p:cNvPr id="9" name="Text 7"/>
-          <p:cNvSpPr/>
-          <p:nvPr/>
-        </p:nvSpPr>
-        <p:spPr>
-          <a:xfrm>
-            <a:off x="365760" y="1344168"/>
+          <p:cNvPr id="17" name="Text 15"/>
+          <p:cNvSpPr/>
+          <p:nvPr/>
+        </p:nvSpPr>
+        <p:spPr>
+          <a:xfrm>
+            <a:off x="365760" y="2112264"/>
             <a:ext cx="1645920" cy="292608"/>
           </a:xfrm>
           <a:prstGeom prst="rect">
@@ -17048,7 +17272,7 @@
                   <a:srgbClr val="2C2C2C"/>
                 </a:solidFill>
               </a:rPr>
-              <a:t>Capn'Kirk</a:t>
+              <a:t>Paul233365</a:t>
             </a:r>
             <a:endParaRPr lang="en-US" sz="800" dirty="0"/>
           </a:p>
@@ -17056,14 +17280,14 @@
       </p:sp>
       <p:sp>
         <p:nvSpPr>
-          <p:cNvPr id="10" name="Shape 8"/>
-          <p:cNvSpPr/>
-          <p:nvPr/>
-        </p:nvSpPr>
-        <p:spPr>
-          <a:xfrm>
-            <a:off x="2103120" y="1371600"/>
-            <a:ext cx="6116320" cy="228600"/>
+          <p:cNvPr id="18" name="Shape 16"/>
+          <p:cNvSpPr/>
+          <p:nvPr/>
+        </p:nvSpPr>
+        <p:spPr>
+          <a:xfrm>
+            <a:off x="2103120" y="2139696"/>
+            <a:ext cx="5689600" cy="228600"/>
           </a:xfrm>
           <a:prstGeom prst="rect">
             <a:avLst/>
@@ -17076,14 +17300,14 @@
       </p:sp>
       <p:sp>
         <p:nvSpPr>
-          <p:cNvPr id="11" name="Shape 9"/>
-          <p:cNvSpPr/>
-          <p:nvPr/>
-        </p:nvSpPr>
-        <p:spPr>
-          <a:xfrm>
-            <a:off x="8219440" y="1371600"/>
-            <a:ext cx="6494929" cy="228600"/>
+          <p:cNvPr id="19" name="Shape 17"/>
+          <p:cNvSpPr/>
+          <p:nvPr/>
+        </p:nvSpPr>
+        <p:spPr>
+          <a:xfrm>
+            <a:off x="7792720" y="2139696"/>
+            <a:ext cx="6400800" cy="228600"/>
           </a:xfrm>
           <a:prstGeom prst="rect">
             <a:avLst/>
@@ -17096,125 +17320,13 @@
       </p:sp>
       <p:sp>
         <p:nvSpPr>
-          <p:cNvPr id="12" name="Text 10"/>
-          <p:cNvSpPr/>
-          <p:nvPr/>
-        </p:nvSpPr>
-        <p:spPr>
-          <a:xfrm>
-            <a:off x="14805809" y="1344168"/>
-            <a:ext cx="731520" cy="292608"/>
-          </a:xfrm>
-          <a:prstGeom prst="rect">
-            <a:avLst/>
-          </a:prstGeom>
-          <a:noFill/>
-          <a:ln/>
-        </p:spPr>
-        <p:txBody>
-          <a:bodyPr wrap="square" rtlCol="0" anchor="ctr"/>
-          <a:lstStyle/>
-          <a:p>
-            <a:pPr indent="0" marL="0">
-              <a:buNone/>
-            </a:pPr>
-            <a:r>
-              <a:rPr lang="en-US" sz="800" b="1" dirty="0">
-                <a:solidFill>
-                  <a:srgbClr val="2C2C2C"/>
-                </a:solidFill>
-              </a:rPr>
-              <a:t>1810</a:t>
-            </a:r>
-            <a:endParaRPr lang="en-US" sz="800" dirty="0"/>
-          </a:p>
-        </p:txBody>
-      </p:sp>
-      <p:sp>
-        <p:nvSpPr>
-          <p:cNvPr id="13" name="Text 11"/>
-          <p:cNvSpPr/>
-          <p:nvPr/>
-        </p:nvSpPr>
-        <p:spPr>
-          <a:xfrm>
-            <a:off x="365760" y="1728216"/>
-            <a:ext cx="1645920" cy="292608"/>
-          </a:xfrm>
-          <a:prstGeom prst="rect">
-            <a:avLst/>
-          </a:prstGeom>
-          <a:noFill/>
-          <a:ln/>
-        </p:spPr>
-        <p:txBody>
-          <a:bodyPr wrap="square" rtlCol="0" anchor="ctr"/>
-          <a:lstStyle/>
-          <a:p>
-            <a:pPr algn="r" indent="0" marL="0">
-              <a:buNone/>
-            </a:pPr>
-            <a:r>
-              <a:rPr lang="en-US" sz="800" dirty="0">
-                <a:solidFill>
-                  <a:srgbClr val="2C2C2C"/>
-                </a:solidFill>
-              </a:rPr>
-              <a:t>Fizzz3</a:t>
-            </a:r>
-            <a:endParaRPr lang="en-US" sz="800" dirty="0"/>
-          </a:p>
-        </p:txBody>
-      </p:sp>
-      <p:sp>
-        <p:nvSpPr>
-          <p:cNvPr id="14" name="Shape 12"/>
-          <p:cNvSpPr/>
-          <p:nvPr/>
-        </p:nvSpPr>
-        <p:spPr>
-          <a:xfrm>
-            <a:off x="2103120" y="1755648"/>
-            <a:ext cx="5974080" cy="228600"/>
-          </a:xfrm>
-          <a:prstGeom prst="rect">
-            <a:avLst/>
-          </a:prstGeom>
-          <a:solidFill>
-            <a:srgbClr val="2B5A7E"/>
-          </a:solidFill>
-          <a:ln/>
-        </p:spPr>
-      </p:sp>
-      <p:sp>
-        <p:nvSpPr>
-          <p:cNvPr id="15" name="Shape 13"/>
-          <p:cNvSpPr/>
-          <p:nvPr/>
-        </p:nvSpPr>
-        <p:spPr>
-          <a:xfrm>
-            <a:off x="8077200" y="1755648"/>
-            <a:ext cx="6306671" cy="228600"/>
-          </a:xfrm>
-          <a:prstGeom prst="rect">
-            <a:avLst/>
-          </a:prstGeom>
-          <a:solidFill>
-            <a:srgbClr val="E0E0E0"/>
-          </a:solidFill>
-          <a:ln/>
-        </p:spPr>
-      </p:sp>
-      <p:sp>
-        <p:nvSpPr>
-          <p:cNvPr id="16" name="Text 14"/>
-          <p:cNvSpPr/>
-          <p:nvPr/>
-        </p:nvSpPr>
-        <p:spPr>
-          <a:xfrm>
-            <a:off x="14475311" y="1728216"/>
+          <p:cNvPr id="20" name="Text 18"/>
+          <p:cNvSpPr/>
+          <p:nvPr/>
+        </p:nvSpPr>
+        <p:spPr>
+          <a:xfrm>
+            <a:off x="14284960" y="2112264"/>
             <a:ext cx="731520" cy="292608"/>
           </a:xfrm>
           <a:prstGeom prst="rect">
@@ -17244,118 +17356,6 @@
       </p:sp>
       <p:sp>
         <p:nvSpPr>
-          <p:cNvPr id="17" name="Text 15"/>
-          <p:cNvSpPr/>
-          <p:nvPr/>
-        </p:nvSpPr>
-        <p:spPr>
-          <a:xfrm>
-            <a:off x="365760" y="2112264"/>
-            <a:ext cx="1645920" cy="292608"/>
-          </a:xfrm>
-          <a:prstGeom prst="rect">
-            <a:avLst/>
-          </a:prstGeom>
-          <a:noFill/>
-          <a:ln/>
-        </p:spPr>
-        <p:txBody>
-          <a:bodyPr wrap="square" rtlCol="0" anchor="ctr"/>
-          <a:lstStyle/>
-          <a:p>
-            <a:pPr algn="r" indent="0" marL="0">
-              <a:buNone/>
-            </a:pPr>
-            <a:r>
-              <a:rPr lang="en-US" sz="800" dirty="0">
-                <a:solidFill>
-                  <a:srgbClr val="2C2C2C"/>
-                </a:solidFill>
-              </a:rPr>
-              <a:t>Paul233365</a:t>
-            </a:r>
-            <a:endParaRPr lang="en-US" sz="800" dirty="0"/>
-          </a:p>
-        </p:txBody>
-      </p:sp>
-      <p:sp>
-        <p:nvSpPr>
-          <p:cNvPr id="18" name="Shape 16"/>
-          <p:cNvSpPr/>
-          <p:nvPr/>
-        </p:nvSpPr>
-        <p:spPr>
-          <a:xfrm>
-            <a:off x="2103120" y="2139696"/>
-            <a:ext cx="5689600" cy="228600"/>
-          </a:xfrm>
-          <a:prstGeom prst="rect">
-            <a:avLst/>
-          </a:prstGeom>
-          <a:solidFill>
-            <a:srgbClr val="2B5A7E"/>
-          </a:solidFill>
-          <a:ln/>
-        </p:spPr>
-      </p:sp>
-      <p:sp>
-        <p:nvSpPr>
-          <p:cNvPr id="19" name="Shape 17"/>
-          <p:cNvSpPr/>
-          <p:nvPr/>
-        </p:nvSpPr>
-        <p:spPr>
-          <a:xfrm>
-            <a:off x="7792720" y="2139696"/>
-            <a:ext cx="6494929" cy="228600"/>
-          </a:xfrm>
-          <a:prstGeom prst="rect">
-            <a:avLst/>
-          </a:prstGeom>
-          <a:solidFill>
-            <a:srgbClr val="E0E0E0"/>
-          </a:solidFill>
-          <a:ln/>
-        </p:spPr>
-      </p:sp>
-      <p:sp>
-        <p:nvSpPr>
-          <p:cNvPr id="20" name="Text 18"/>
-          <p:cNvSpPr/>
-          <p:nvPr/>
-        </p:nvSpPr>
-        <p:spPr>
-          <a:xfrm>
-            <a:off x="14379089" y="2112264"/>
-            <a:ext cx="731520" cy="292608"/>
-          </a:xfrm>
-          <a:prstGeom prst="rect">
-            <a:avLst/>
-          </a:prstGeom>
-          <a:noFill/>
-          <a:ln/>
-        </p:spPr>
-        <p:txBody>
-          <a:bodyPr wrap="square" rtlCol="0" anchor="ctr"/>
-          <a:lstStyle/>
-          <a:p>
-            <a:pPr indent="0" marL="0">
-              <a:buNone/>
-            </a:pPr>
-            <a:r>
-              <a:rPr lang="en-US" sz="800" b="1" dirty="0">
-                <a:solidFill>
-                  <a:srgbClr val="2C2C2C"/>
-                </a:solidFill>
-              </a:rPr>
-              <a:t>1780</a:t>
-            </a:r>
-            <a:endParaRPr lang="en-US" sz="800" dirty="0"/>
-          </a:p>
-        </p:txBody>
-      </p:sp>
-      <p:sp>
-        <p:nvSpPr>
           <p:cNvPr id="21" name="Text 19"/>
           <p:cNvSpPr/>
           <p:nvPr/>
@@ -17419,7 +17419,7 @@
         <p:spPr>
           <a:xfrm>
             <a:off x="7650480" y="2523744"/>
-            <a:ext cx="6494929" cy="228600"/>
+            <a:ext cx="6306671" cy="228600"/>
           </a:xfrm>
           <a:prstGeom prst="rect">
             <a:avLst/>
@@ -17438,7 +17438,7 @@
         </p:nvSpPr>
         <p:spPr>
           <a:xfrm>
-            <a:off x="14236849" y="2496312"/>
+            <a:off x="14048591" y="2496312"/>
             <a:ext cx="731520" cy="292608"/>
           </a:xfrm>
           <a:prstGeom prst="rect">
@@ -17460,7 +17460,7 @@
                   <a:srgbClr val="2C2C2C"/>
                 </a:solidFill>
               </a:rPr>
-              <a:t>1770</a:t>
+              <a:t>1730</a:t>
             </a:r>
             <a:endParaRPr lang="en-US" sz="800" dirty="0"/>
           </a:p>
@@ -18591,7 +18591,7 @@
                 <a:ea typeface="Arial" pitchFamily="34" charset="-122"/>
                 <a:cs typeface="Arial" pitchFamily="34" charset="-120"/>
               </a:rPr>
-              <a:t>+20</a:t>
+              <a:t>+10</a:t>
             </a:r>
             <a:endParaRPr lang="en-US" sz="1600" dirty="0"/>
           </a:p>
@@ -19063,7 +19063,7 @@
                 <a:ea typeface="Arial" pitchFamily="34" charset="-122"/>
                 <a:cs typeface="Arial" pitchFamily="34" charset="-120"/>
               </a:rPr>
-              <a:t>TaylorDuran clings to a narrow 20-point lead with Arizona as champion pick. Capn'Kirk surged in R32 and is breathing down his neck with Duke. The Sweet 16 will be decisive.</a:t>
+              <a:t>TaylorDuran barely holds a 10-point lead as Fizzz3 surged to #2 after nailing the Tennessee pick. Capn'Kirk lurks 20 back at #3. This race is wide open heading into Sweet 16.</a:t>
             </a:r>
             <a:endParaRPr lang="en-US" sz="1000" dirty="0"/>
           </a:p>
@@ -19677,7 +19677,7 @@
                             <a:srgbClr val="2C2C2C"/>
                           </a:solidFill>
                         </a:rPr>
-                        <a:t>Capn'Kirk</a:t>
+                        <a:t>Fizzz3</a:t>
                       </a:r>
                       <a:endParaRPr lang="en-US" sz="900" dirty="0"/>
                     </a:p>
@@ -19735,7 +19735,7 @@
                             <a:srgbClr val="2C2C2C"/>
                           </a:solidFill>
                         </a:rPr>
-                        <a:t>430</a:t>
+                        <a:t>440</a:t>
                       </a:r>
                       <a:endParaRPr lang="en-US" sz="900" dirty="0"/>
                     </a:p>
@@ -19793,7 +19793,7 @@
                             <a:srgbClr val="2C2C2C"/>
                           </a:solidFill>
                         </a:rPr>
-                        <a:t>88.0%</a:t>
+                        <a:t>79.9%</a:t>
                       </a:r>
                       <a:endParaRPr lang="en-US" sz="900" dirty="0"/>
                     </a:p>
@@ -19911,7 +19911,7 @@
                             <a:srgbClr val="2C2C2C"/>
                           </a:solidFill>
                         </a:rPr>
-                        <a:t>Fizzz3</a:t>
+                        <a:t>Capn'Kirk</a:t>
                       </a:r>
                       <a:endParaRPr lang="en-US" sz="900" dirty="0"/>
                     </a:p>
@@ -19969,7 +19969,7 @@
                             <a:srgbClr val="2C2C2C"/>
                           </a:solidFill>
                         </a:rPr>
-                        <a:t>420</a:t>
+                        <a:t>430</a:t>
                       </a:r>
                       <a:endParaRPr lang="en-US" sz="900" dirty="0"/>
                     </a:p>
@@ -20027,7 +20027,7 @@
                             <a:srgbClr val="2C2C2C"/>
                           </a:solidFill>
                         </a:rPr>
-                        <a:t>79.9%</a:t>
+                        <a:t>88.0%</a:t>
                       </a:r>
                       <a:endParaRPr lang="en-US" sz="900" dirty="0"/>
                     </a:p>
@@ -20495,7 +20495,7 @@
                             <a:srgbClr val="2C2C2C"/>
                           </a:solidFill>
                         </a:rPr>
-                        <a:t>52.6%</a:t>
+                        <a:t>52.1%</a:t>
                       </a:r>
                       <a:endParaRPr lang="en-US" sz="900" dirty="0"/>
                     </a:p>
@@ -20729,7 +20729,7 @@
                             <a:srgbClr val="2C2C2C"/>
                           </a:solidFill>
                         </a:rPr>
-                        <a:t>21.1%</a:t>
+                        <a:t>21.0%</a:t>
                       </a:r>
                       <a:endParaRPr lang="en-US" sz="900" dirty="0"/>
                     </a:p>
@@ -20963,7 +20963,7 @@
                             <a:srgbClr val="2C2C2C"/>
                           </a:solidFill>
                         </a:rPr>
-                        <a:t>21.1%</a:t>
+                        <a:t>21.0%</a:t>
                       </a:r>
                       <a:endParaRPr lang="en-US" sz="900" dirty="0"/>
                     </a:p>
@@ -21842,7 +21842,7 @@
                             <a:srgbClr val="2C2C2C"/>
                           </a:solidFill>
                         </a:rPr>
-                        <a:t>1790</a:t>
+                        <a:t>1770</a:t>
                       </a:r>
                       <a:endParaRPr lang="en-US" sz="900" dirty="0"/>
                     </a:p>
@@ -21958,7 +21958,7 @@
                             <a:srgbClr val="2C2C2C"/>
                           </a:solidFill>
                         </a:rPr>
-                        <a:t>7</a:t>
+                        <a:t>8</a:t>
                       </a:r>
                       <a:endParaRPr lang="en-US" sz="900" dirty="0"/>
                     </a:p>
@@ -22134,7 +22134,7 @@
                             <a:srgbClr val="2C2C2C"/>
                           </a:solidFill>
                         </a:rPr>
-                        <a:t>Capn'Kirk</a:t>
+                        <a:t>Fizzz3</a:t>
                       </a:r>
                       <a:endParaRPr lang="en-US" sz="900" dirty="0"/>
                     </a:p>
@@ -22192,7 +22192,7 @@
                             <a:srgbClr val="2C2C2C"/>
                           </a:solidFill>
                         </a:rPr>
-                        <a:t>430</a:t>
+                        <a:t>440</a:t>
                       </a:r>
                       <a:endParaRPr lang="en-US" sz="900" dirty="0"/>
                     </a:p>
@@ -22250,7 +22250,7 @@
                             <a:srgbClr val="2C2C2C"/>
                           </a:solidFill>
                         </a:rPr>
-                        <a:t>1810</a:t>
+                        <a:t>1760</a:t>
                       </a:r>
                       <a:endParaRPr lang="en-US" sz="900" dirty="0"/>
                     </a:p>
@@ -22308,7 +22308,7 @@
                             <a:srgbClr val="2C2C2C"/>
                           </a:solidFill>
                         </a:rPr>
-                        <a:t>34</a:t>
+                        <a:t>35</a:t>
                       </a:r>
                       <a:endParaRPr lang="en-US" sz="900" dirty="0"/>
                     </a:p>
@@ -22366,7 +22366,7 @@
                             <a:srgbClr val="2C2C2C"/>
                           </a:solidFill>
                         </a:rPr>
-                        <a:t>9</a:t>
+                        <a:t>10</a:t>
                       </a:r>
                       <a:endParaRPr lang="en-US" sz="900" dirty="0"/>
                     </a:p>
@@ -22424,7 +22424,7 @@
                             <a:srgbClr val="2C2C2C"/>
                           </a:solidFill>
                         </a:rPr>
-                        <a:t>Duke Blue Devils</a:t>
+                        <a:t>Arizona Wildcats</a:t>
                       </a:r>
                       <a:endParaRPr lang="en-US" sz="900" dirty="0"/>
                     </a:p>
@@ -22542,7 +22542,7 @@
                             <a:srgbClr val="2C2C2C"/>
                           </a:solidFill>
                         </a:rPr>
-                        <a:t>Fizzz3</a:t>
+                        <a:t>Capn'Kirk</a:t>
                       </a:r>
                       <a:endParaRPr lang="en-US" sz="900" dirty="0"/>
                     </a:p>
@@ -22600,7 +22600,7 @@
                             <a:srgbClr val="2C2C2C"/>
                           </a:solidFill>
                         </a:rPr>
-                        <a:t>420</a:t>
+                        <a:t>430</a:t>
                       </a:r>
                       <a:endParaRPr lang="en-US" sz="900" dirty="0"/>
                     </a:p>
@@ -22658,7 +22658,7 @@
                             <a:srgbClr val="2C2C2C"/>
                           </a:solidFill>
                         </a:rPr>
-                        <a:t>1760</a:t>
+                        <a:t>1790</a:t>
                       </a:r>
                       <a:endParaRPr lang="en-US" sz="900" dirty="0"/>
                     </a:p>
@@ -22832,7 +22832,7 @@
                             <a:srgbClr val="2C2C2C"/>
                           </a:solidFill>
                         </a:rPr>
-                        <a:t>Arizona Wildcats</a:t>
+                        <a:t>Duke Blue Devils</a:t>
                       </a:r>
                       <a:endParaRPr lang="en-US" sz="900" dirty="0"/>
                     </a:p>
@@ -23066,7 +23066,7 @@
                             <a:srgbClr val="2C2C2C"/>
                           </a:solidFill>
                         </a:rPr>
-                        <a:t>1780</a:t>
+                        <a:t>1760</a:t>
                       </a:r>
                       <a:endParaRPr lang="en-US" sz="900" dirty="0"/>
                     </a:p>
@@ -23182,7 +23182,7 @@
                             <a:srgbClr val="2C2C2C"/>
                           </a:solidFill>
                         </a:rPr>
-                        <a:t>11</a:t>
+                        <a:t>12</a:t>
                       </a:r>
                       <a:endParaRPr lang="en-US" sz="900" dirty="0"/>
                     </a:p>
@@ -23474,7 +23474,7 @@
                             <a:srgbClr val="2C2C2C"/>
                           </a:solidFill>
                         </a:rPr>
-                        <a:t>1770</a:t>
+                        <a:t>1730</a:t>
                       </a:r>
                       <a:endParaRPr lang="en-US" sz="900" dirty="0"/>
                     </a:p>
@@ -23590,7 +23590,7 @@
                             <a:srgbClr val="2C2C2C"/>
                           </a:solidFill>
                         </a:rPr>
-                        <a:t>13</a:t>
+                        <a:t>14</a:t>
                       </a:r>
                       <a:endParaRPr lang="en-US" sz="900" dirty="0"/>
                     </a:p>
@@ -25195,7 +25195,7 @@
                 <a:ea typeface="Arial" pitchFamily="34" charset="-122"/>
                 <a:cs typeface="Arial" pitchFamily="34" charset="-120"/>
               </a:rPr>
-              <a:t>Only a 20-point gap after Capn'Kirk surged in R32. Sweet 16 picks will determine if TaylorDuran holds or gets overtaken.</a:t>
+              <a:t>Only a 10-point gap after Fizzz3 surged to #2. The top 3 are separated by just 20 points — Sweet 16 is anyone's game.</a:t>
             </a:r>
             <a:endParaRPr lang="en-US" sz="900" dirty="0"/>
           </a:p>
@@ -25759,6 +25759,98 @@
                   <a:srgbClr val="2C2C2C"/>
                 </a:solidFill>
               </a:rPr>
+              <a:t>Fizzz3</a:t>
+            </a:r>
+            <a:endParaRPr lang="en-US" sz="800" dirty="0"/>
+          </a:p>
+        </p:txBody>
+      </p:sp>
+      <p:sp>
+        <p:nvSpPr>
+          <p:cNvPr id="9" name="Shape 7"/>
+          <p:cNvSpPr/>
+          <p:nvPr/>
+        </p:nvSpPr>
+        <p:spPr>
+          <a:xfrm>
+            <a:off x="2103120" y="1371600"/>
+            <a:ext cx="6258560" cy="228600"/>
+          </a:xfrm>
+          <a:prstGeom prst="rect">
+            <a:avLst/>
+          </a:prstGeom>
+          <a:solidFill>
+            <a:srgbClr val="2B5A7E"/>
+          </a:solidFill>
+          <a:ln/>
+        </p:spPr>
+      </p:sp>
+      <p:sp>
+        <p:nvSpPr>
+          <p:cNvPr id="10" name="Text 8"/>
+          <p:cNvSpPr/>
+          <p:nvPr/>
+        </p:nvSpPr>
+        <p:spPr>
+          <a:xfrm>
+            <a:off x="8453120" y="1344168"/>
+            <a:ext cx="548640" cy="292608"/>
+          </a:xfrm>
+          <a:prstGeom prst="rect">
+            <a:avLst/>
+          </a:prstGeom>
+          <a:noFill/>
+          <a:ln/>
+        </p:spPr>
+        <p:txBody>
+          <a:bodyPr wrap="square" rtlCol="0" anchor="ctr"/>
+          <a:lstStyle/>
+          <a:p>
+            <a:pPr indent="0" marL="0">
+              <a:buNone/>
+            </a:pPr>
+            <a:r>
+              <a:rPr lang="en-US" sz="800" b="1" dirty="0">
+                <a:solidFill>
+                  <a:srgbClr val="2C2C2C"/>
+                </a:solidFill>
+              </a:rPr>
+              <a:t>440</a:t>
+            </a:r>
+            <a:endParaRPr lang="en-US" sz="800" dirty="0"/>
+          </a:p>
+        </p:txBody>
+      </p:sp>
+      <p:sp>
+        <p:nvSpPr>
+          <p:cNvPr id="11" name="Text 9"/>
+          <p:cNvSpPr/>
+          <p:nvPr/>
+        </p:nvSpPr>
+        <p:spPr>
+          <a:xfrm>
+            <a:off x="365760" y="1728216"/>
+            <a:ext cx="1645920" cy="292608"/>
+          </a:xfrm>
+          <a:prstGeom prst="rect">
+            <a:avLst/>
+          </a:prstGeom>
+          <a:noFill/>
+          <a:ln/>
+        </p:spPr>
+        <p:txBody>
+          <a:bodyPr wrap="square" rtlCol="0" anchor="ctr"/>
+          <a:lstStyle/>
+          <a:p>
+            <a:pPr algn="r" indent="0" marL="0">
+              <a:buNone/>
+            </a:pPr>
+            <a:r>
+              <a:rPr lang="en-US" sz="800" dirty="0">
+                <a:solidFill>
+                  <a:srgbClr val="2C2C2C"/>
+                </a:solidFill>
+              </a:rPr>
               <a:t>Capn'Kirk</a:t>
             </a:r>
             <a:endParaRPr lang="en-US" sz="800" dirty="0"/>
@@ -25767,13 +25859,13 @@
       </p:sp>
       <p:sp>
         <p:nvSpPr>
-          <p:cNvPr id="9" name="Shape 7"/>
-          <p:cNvSpPr/>
-          <p:nvPr/>
-        </p:nvSpPr>
-        <p:spPr>
-          <a:xfrm>
-            <a:off x="2103120" y="1371600"/>
+          <p:cNvPr id="12" name="Shape 10"/>
+          <p:cNvSpPr/>
+          <p:nvPr/>
+        </p:nvSpPr>
+        <p:spPr>
+          <a:xfrm>
+            <a:off x="2103120" y="1755648"/>
             <a:ext cx="6116320" cy="228600"/>
           </a:xfrm>
           <a:prstGeom prst="rect">
@@ -25787,13 +25879,13 @@
       </p:sp>
       <p:sp>
         <p:nvSpPr>
-          <p:cNvPr id="10" name="Text 8"/>
-          <p:cNvSpPr/>
-          <p:nvPr/>
-        </p:nvSpPr>
-        <p:spPr>
-          <a:xfrm>
-            <a:off x="8310880" y="1344168"/>
+          <p:cNvPr id="13" name="Text 11"/>
+          <p:cNvSpPr/>
+          <p:nvPr/>
+        </p:nvSpPr>
+        <p:spPr>
+          <a:xfrm>
+            <a:off x="8310880" y="1728216"/>
             <a:ext cx="548640" cy="292608"/>
           </a:xfrm>
           <a:prstGeom prst="rect">
@@ -25816,98 +25908,6 @@
                 </a:solidFill>
               </a:rPr>
               <a:t>430</a:t>
-            </a:r>
-            <a:endParaRPr lang="en-US" sz="800" dirty="0"/>
-          </a:p>
-        </p:txBody>
-      </p:sp>
-      <p:sp>
-        <p:nvSpPr>
-          <p:cNvPr id="11" name="Text 9"/>
-          <p:cNvSpPr/>
-          <p:nvPr/>
-        </p:nvSpPr>
-        <p:spPr>
-          <a:xfrm>
-            <a:off x="365760" y="1728216"/>
-            <a:ext cx="1645920" cy="292608"/>
-          </a:xfrm>
-          <a:prstGeom prst="rect">
-            <a:avLst/>
-          </a:prstGeom>
-          <a:noFill/>
-          <a:ln/>
-        </p:spPr>
-        <p:txBody>
-          <a:bodyPr wrap="square" rtlCol="0" anchor="ctr"/>
-          <a:lstStyle/>
-          <a:p>
-            <a:pPr algn="r" indent="0" marL="0">
-              <a:buNone/>
-            </a:pPr>
-            <a:r>
-              <a:rPr lang="en-US" sz="800" dirty="0">
-                <a:solidFill>
-                  <a:srgbClr val="2C2C2C"/>
-                </a:solidFill>
-              </a:rPr>
-              <a:t>Fizzz3</a:t>
-            </a:r>
-            <a:endParaRPr lang="en-US" sz="800" dirty="0"/>
-          </a:p>
-        </p:txBody>
-      </p:sp>
-      <p:sp>
-        <p:nvSpPr>
-          <p:cNvPr id="12" name="Shape 10"/>
-          <p:cNvSpPr/>
-          <p:nvPr/>
-        </p:nvSpPr>
-        <p:spPr>
-          <a:xfrm>
-            <a:off x="2103120" y="1755648"/>
-            <a:ext cx="5974080" cy="228600"/>
-          </a:xfrm>
-          <a:prstGeom prst="rect">
-            <a:avLst/>
-          </a:prstGeom>
-          <a:solidFill>
-            <a:srgbClr val="2B5A7E"/>
-          </a:solidFill>
-          <a:ln/>
-        </p:spPr>
-      </p:sp>
-      <p:sp>
-        <p:nvSpPr>
-          <p:cNvPr id="13" name="Text 11"/>
-          <p:cNvSpPr/>
-          <p:nvPr/>
-        </p:nvSpPr>
-        <p:spPr>
-          <a:xfrm>
-            <a:off x="8168640" y="1728216"/>
-            <a:ext cx="548640" cy="292608"/>
-          </a:xfrm>
-          <a:prstGeom prst="rect">
-            <a:avLst/>
-          </a:prstGeom>
-          <a:noFill/>
-          <a:ln/>
-        </p:spPr>
-        <p:txBody>
-          <a:bodyPr wrap="square" rtlCol="0" anchor="ctr"/>
-          <a:lstStyle/>
-          <a:p>
-            <a:pPr indent="0" marL="0">
-              <a:buNone/>
-            </a:pPr>
-            <a:r>
-              <a:rPr lang="en-US" sz="800" b="1" dirty="0">
-                <a:solidFill>
-                  <a:srgbClr val="2C2C2C"/>
-                </a:solidFill>
-              </a:rPr>
-              <a:t>420</a:t>
             </a:r>
             <a:endParaRPr lang="en-US" sz="800" dirty="0"/>
           </a:p>

</xml_diff>